<commit_message>
Remove draft-source wording from submission
</commit_message>
<xml_diff>
--- a/drafts/saturday_submission.pptx
+++ b/drafts/saturday_submission.pptx
@@ -2,16 +2,16 @@
 <file path=ppt/presentation.xml><?xml version="1.0" encoding="utf-8"?>
 <p:presentation xmlns:p="http://schemas.openxmlformats.org/presentationml/2006/main">
   <p:sldMasterIdLst>
-    <p:sldMasterId xmlns:r="http://schemas.openxmlformats.org/officeDocument/2006/relationships" id="2147483648" r:id="R83e5211d570049a0"/>
+    <p:sldMasterId xmlns:r="http://schemas.openxmlformats.org/officeDocument/2006/relationships" id="2147483648" r:id="R778ab3701b814490"/>
   </p:sldMasterIdLst>
   <p:notesMasterIdLst>
-    <p:notesMasterId xmlns:r="http://schemas.openxmlformats.org/officeDocument/2006/relationships" r:id="Rf249dc5b30fc488a"/>
+    <p:notesMasterId xmlns:r="http://schemas.openxmlformats.org/officeDocument/2006/relationships" r:id="Rdc93340fec654148"/>
   </p:notesMasterIdLst>
   <p:sldIdLst>
-    <p:sldId xmlns:r="http://schemas.openxmlformats.org/officeDocument/2006/relationships" id="256" r:id="Rc3bbee5b9fa64587"/>
-    <p:sldId xmlns:r="http://schemas.openxmlformats.org/officeDocument/2006/relationships" id="257" r:id="R1b413e7099eb4cc8"/>
-    <p:sldId xmlns:r="http://schemas.openxmlformats.org/officeDocument/2006/relationships" id="258" r:id="R3b2884483b534da6"/>
-    <p:sldId xmlns:r="http://schemas.openxmlformats.org/officeDocument/2006/relationships" id="259" r:id="R8bd42fe633b84346"/>
+    <p:sldId xmlns:r="http://schemas.openxmlformats.org/officeDocument/2006/relationships" id="256" r:id="R93203bb4ca784b82"/>
+    <p:sldId xmlns:r="http://schemas.openxmlformats.org/officeDocument/2006/relationships" id="257" r:id="R0ca987cedb014f98"/>
+    <p:sldId xmlns:r="http://schemas.openxmlformats.org/officeDocument/2006/relationships" id="258" r:id="Redc741d5cb5f46b7"/>
+    <p:sldId xmlns:r="http://schemas.openxmlformats.org/officeDocument/2006/relationships" id="259" r:id="Red9b7cb8bb3a4fcb"/>
   </p:sldIdLst>
   <p:sldSz cx="12192000" cy="6858000"/>
   <p:notesSz cx="6858000" cy="9144000"/>
@@ -723,7 +723,7 @@
   </p:cSld>
   <p:clrMap bg1="lt1" tx1="dk1" bg2="lt2" tx2="dk2" accent1="accent1" accent2="accent2" accent3="accent3" accent4="accent4" accent5="accent5" accent6="accent6" hlink="hlink" folHlink="folHlink"/>
   <p:sldLayoutIdLst>
-    <p:sldLayoutId xmlns:r="http://schemas.openxmlformats.org/officeDocument/2006/relationships" id="2147483649" r:id="R95a32dffb6d54095"/>
+    <p:sldLayoutId xmlns:r="http://schemas.openxmlformats.org/officeDocument/2006/relationships" id="2147483649" r:id="Rfab8b5b54975464b"/>
   </p:sldLayoutIdLst>
   <p:txStyles>
     <p:titleStyle>
@@ -2390,7 +2390,7 @@
           <p:cNvPr id="22" name="">
             <a:extLst xmlns:a="http://schemas.openxmlformats.org/drawingml/2006/main">
               <a:ext uri="{FF2B5EF4-FFF2-40B4-BE49-F238E27FC236}">
-                <a16:creationId xmlns:a16="http://schemas.microsoft.com/office/drawing/2014/main" id="{365B45ED-A701-47C5-B832-D632D3853629}"/>
+                <a16:creationId xmlns:a16="http://schemas.microsoft.com/office/drawing/2014/main" id="{840958B4-1550-4B8A-997E-AE80BD142712}"/>
               </a:ext>
             </a:extLst>
           </p:cNvPr>
@@ -2421,7 +2421,7 @@
           <p:cNvPr id="2" name="">
             <a:extLst xmlns:a="http://schemas.openxmlformats.org/drawingml/2006/main">
               <a:ext uri="{FF2B5EF4-FFF2-40B4-BE49-F238E27FC236}">
-                <a16:creationId xmlns:a16="http://schemas.microsoft.com/office/drawing/2014/main" id="{277C59C3-6537-4388-8FA5-C7A2367C233D}"/>
+                <a16:creationId xmlns:a16="http://schemas.microsoft.com/office/drawing/2014/main" id="{E4534141-7F0F-4F4B-A4BA-9BC50C6C1CEF}"/>
               </a:ext>
             </a:extLst>
           </p:cNvPr>
@@ -2479,7 +2479,7 @@
           <p:cNvPr id="3" name="">
             <a:extLst xmlns:a="http://schemas.openxmlformats.org/drawingml/2006/main">
               <a:ext uri="{FF2B5EF4-FFF2-40B4-BE49-F238E27FC236}">
-                <a16:creationId xmlns:a16="http://schemas.microsoft.com/office/drawing/2014/main" id="{8AE5956B-C133-4F5A-856C-B40043A3CEA0}"/>
+                <a16:creationId xmlns:a16="http://schemas.microsoft.com/office/drawing/2014/main" id="{621ABB3A-A66B-404C-B66A-BB5F398DFE6D}"/>
               </a:ext>
             </a:extLst>
           </p:cNvPr>
@@ -2537,7 +2537,7 @@
           <p:cNvPr id="4" name="">
             <a:extLst xmlns:a="http://schemas.openxmlformats.org/drawingml/2006/main">
               <a:ext uri="{FF2B5EF4-FFF2-40B4-BE49-F238E27FC236}">
-                <a16:creationId xmlns:a16="http://schemas.microsoft.com/office/drawing/2014/main" id="{D88FD964-39C7-46F3-A64F-9798F47773BA}"/>
+                <a16:creationId xmlns:a16="http://schemas.microsoft.com/office/drawing/2014/main" id="{79CF29B1-FD1D-4596-A35C-CF2E7CC1DD52}"/>
               </a:ext>
             </a:extLst>
           </p:cNvPr>
@@ -2577,7 +2577,7 @@
           <p:cNvPr id="5" name="">
             <a:extLst xmlns:a="http://schemas.openxmlformats.org/drawingml/2006/main">
               <a:ext uri="{FF2B5EF4-FFF2-40B4-BE49-F238E27FC236}">
-                <a16:creationId xmlns:a16="http://schemas.microsoft.com/office/drawing/2014/main" id="{1D0130E0-0465-4E4C-950D-D31A764EAA47}"/>
+                <a16:creationId xmlns:a16="http://schemas.microsoft.com/office/drawing/2014/main" id="{1179516A-3953-47DC-9FB1-1A5CA96F1743}"/>
               </a:ext>
             </a:extLst>
           </p:cNvPr>
@@ -2608,7 +2608,7 @@
           <p:cNvPr id="6" name="">
             <a:extLst xmlns:a="http://schemas.openxmlformats.org/drawingml/2006/main">
               <a:ext uri="{FF2B5EF4-FFF2-40B4-BE49-F238E27FC236}">
-                <a16:creationId xmlns:a16="http://schemas.microsoft.com/office/drawing/2014/main" id="{C3F4FCE1-C681-4E4D-8B34-39752D24704F}"/>
+                <a16:creationId xmlns:a16="http://schemas.microsoft.com/office/drawing/2014/main" id="{911F4F45-399F-445C-8698-66C52DC9A195}"/>
               </a:ext>
             </a:extLst>
           </p:cNvPr>
@@ -2666,7 +2666,7 @@
           <p:cNvPr id="7" name="">
             <a:extLst xmlns:a="http://schemas.openxmlformats.org/drawingml/2006/main">
               <a:ext uri="{FF2B5EF4-FFF2-40B4-BE49-F238E27FC236}">
-                <a16:creationId xmlns:a16="http://schemas.microsoft.com/office/drawing/2014/main" id="{72ADFD96-0C77-444F-87FB-A9265E155106}"/>
+                <a16:creationId xmlns:a16="http://schemas.microsoft.com/office/drawing/2014/main" id="{160A3781-174D-446D-AEE7-5CC33A3F801A}"/>
               </a:ext>
             </a:extLst>
           </p:cNvPr>
@@ -2972,7 +2972,7 @@
           <p:cNvPr id="9" name="">
             <a:extLst xmlns:a="http://schemas.openxmlformats.org/drawingml/2006/main">
               <a:ext uri="{FF2B5EF4-FFF2-40B4-BE49-F238E27FC236}">
-                <a16:creationId xmlns:a16="http://schemas.microsoft.com/office/drawing/2014/main" id="{B67EFAF9-E96F-44D4-A9BF-0218F6077D0D}"/>
+                <a16:creationId xmlns:a16="http://schemas.microsoft.com/office/drawing/2014/main" id="{FEDE8069-3F1A-4E43-A2D0-61E028E57AB7}"/>
               </a:ext>
             </a:extLst>
           </p:cNvPr>
@@ -3030,7 +3030,7 @@
           <p:cNvPr id="10" name="">
             <a:extLst xmlns:a="http://schemas.openxmlformats.org/drawingml/2006/main">
               <a:ext uri="{FF2B5EF4-FFF2-40B4-BE49-F238E27FC236}">
-                <a16:creationId xmlns:a16="http://schemas.microsoft.com/office/drawing/2014/main" id="{DDC49FA7-65DA-4129-8504-D1869E203AB5}"/>
+                <a16:creationId xmlns:a16="http://schemas.microsoft.com/office/drawing/2014/main" id="{F56439E0-A195-4924-9A4E-F13465DEAEAC}"/>
               </a:ext>
             </a:extLst>
           </p:cNvPr>
@@ -3099,7 +3099,7 @@
         </p:xfrm>
         <a:graphic xmlns:a="http://schemas.openxmlformats.org/drawingml/2006/main">
           <a:graphicData uri="http://schemas.openxmlformats.org/drawingml/2006/chart">
-            <c:chart xmlns:r="http://schemas.openxmlformats.org/officeDocument/2006/relationships" xmlns:c="http://schemas.openxmlformats.org/drawingml/2006/chart" r:id="Rc7644f3738914494"/>
+            <c:chart xmlns:r="http://schemas.openxmlformats.org/officeDocument/2006/relationships" xmlns:c="http://schemas.openxmlformats.org/drawingml/2006/chart" r:id="Rf0fcadf4c1644f50"/>
           </a:graphicData>
         </a:graphic>
       </p:graphicFrame>
@@ -3108,7 +3108,7 @@
           <p:cNvPr id="12" name="">
             <a:extLst xmlns:a="http://schemas.openxmlformats.org/drawingml/2006/main">
               <a:ext uri="{FF2B5EF4-FFF2-40B4-BE49-F238E27FC236}">
-                <a16:creationId xmlns:a16="http://schemas.microsoft.com/office/drawing/2014/main" id="{52F7C1C2-F62C-4C56-9BA7-94B35B053768}"/>
+                <a16:creationId xmlns:a16="http://schemas.microsoft.com/office/drawing/2014/main" id="{69E775F8-1E87-4F40-A977-0E08ED4F8D8A}"/>
               </a:ext>
             </a:extLst>
           </p:cNvPr>
@@ -3166,7 +3166,7 @@
           <p:cNvPr id="13" name="">
             <a:extLst xmlns:a="http://schemas.openxmlformats.org/drawingml/2006/main">
               <a:ext uri="{FF2B5EF4-FFF2-40B4-BE49-F238E27FC236}">
-                <a16:creationId xmlns:a16="http://schemas.microsoft.com/office/drawing/2014/main" id="{C809369D-D12E-47EA-B407-30339FA498E2}"/>
+                <a16:creationId xmlns:a16="http://schemas.microsoft.com/office/drawing/2014/main" id="{F3998250-408D-437E-BDF9-BD42097F2A51}"/>
               </a:ext>
             </a:extLst>
           </p:cNvPr>
@@ -3197,7 +3197,7 @@
           <p:cNvPr id="14" name="">
             <a:extLst xmlns:a="http://schemas.openxmlformats.org/drawingml/2006/main">
               <a:ext uri="{FF2B5EF4-FFF2-40B4-BE49-F238E27FC236}">
-                <a16:creationId xmlns:a16="http://schemas.microsoft.com/office/drawing/2014/main" id="{7FE9F527-0092-4FDC-A4E5-E3E3A84A9E6A}"/>
+                <a16:creationId xmlns:a16="http://schemas.microsoft.com/office/drawing/2014/main" id="{980B1D63-3E53-4D04-8373-C27589FDF00A}"/>
               </a:ext>
             </a:extLst>
           </p:cNvPr>
@@ -3725,7 +3725,7 @@
           <p:cNvPr id="16" name="">
             <a:extLst xmlns:a="http://schemas.openxmlformats.org/drawingml/2006/main">
               <a:ext uri="{FF2B5EF4-FFF2-40B4-BE49-F238E27FC236}">
-                <a16:creationId xmlns:a16="http://schemas.microsoft.com/office/drawing/2014/main" id="{1C971B73-6FB5-4954-B9A7-32B613C996EB}"/>
+                <a16:creationId xmlns:a16="http://schemas.microsoft.com/office/drawing/2014/main" id="{7627B2E6-0BD7-4692-BBD1-4033C16A477C}"/>
               </a:ext>
             </a:extLst>
           </p:cNvPr>
@@ -3783,7 +3783,7 @@
           <p:cNvPr id="17" name="">
             <a:extLst xmlns:a="http://schemas.openxmlformats.org/drawingml/2006/main">
               <a:ext uri="{FF2B5EF4-FFF2-40B4-BE49-F238E27FC236}">
-                <a16:creationId xmlns:a16="http://schemas.microsoft.com/office/drawing/2014/main" id="{A6FC7095-5901-4597-B999-E424D9348D51}"/>
+                <a16:creationId xmlns:a16="http://schemas.microsoft.com/office/drawing/2014/main" id="{329D8282-2D32-47BA-B131-EE5292EC5901}"/>
               </a:ext>
             </a:extLst>
           </p:cNvPr>
@@ -3938,7 +3938,7 @@
           <p:cNvPr id="18" name="">
             <a:extLst xmlns:a="http://schemas.openxmlformats.org/drawingml/2006/main">
               <a:ext uri="{FF2B5EF4-FFF2-40B4-BE49-F238E27FC236}">
-                <a16:creationId xmlns:a16="http://schemas.microsoft.com/office/drawing/2014/main" id="{B76DD0D2-2F9A-40B9-AFEA-C007E2BA51D2}"/>
+                <a16:creationId xmlns:a16="http://schemas.microsoft.com/office/drawing/2014/main" id="{453C664F-E163-44F2-8CB1-EE18DA7671D3}"/>
               </a:ext>
             </a:extLst>
           </p:cNvPr>
@@ -3996,7 +3996,7 @@
           <p:cNvPr id="19" name="">
             <a:extLst xmlns:a="http://schemas.openxmlformats.org/drawingml/2006/main">
               <a:ext uri="{FF2B5EF4-FFF2-40B4-BE49-F238E27FC236}">
-                <a16:creationId xmlns:a16="http://schemas.microsoft.com/office/drawing/2014/main" id="{530E71B5-6BD1-4AFB-9C80-07D578AB51E1}"/>
+                <a16:creationId xmlns:a16="http://schemas.microsoft.com/office/drawing/2014/main" id="{E75AECFA-D892-4198-BBB4-71F25B9CE08E}"/>
               </a:ext>
             </a:extLst>
           </p:cNvPr>
@@ -4058,7 +4058,7 @@
           <p:cNvPr id="20" name="">
             <a:extLst xmlns:a="http://schemas.openxmlformats.org/drawingml/2006/main">
               <a:ext uri="{FF2B5EF4-FFF2-40B4-BE49-F238E27FC236}">
-                <a16:creationId xmlns:a16="http://schemas.microsoft.com/office/drawing/2014/main" id="{BA5C1C28-4FAD-47D3-9DDD-96DB1B01908B}"/>
+                <a16:creationId xmlns:a16="http://schemas.microsoft.com/office/drawing/2014/main" id="{1120F8E1-0036-4450-BCBF-EB64B6B713EF}"/>
               </a:ext>
             </a:extLst>
           </p:cNvPr>
@@ -4120,7 +4120,7 @@
           <p:cNvPr id="21" name="">
             <a:extLst xmlns:a="http://schemas.openxmlformats.org/drawingml/2006/main">
               <a:ext uri="{FF2B5EF4-FFF2-40B4-BE49-F238E27FC236}">
-                <a16:creationId xmlns:a16="http://schemas.microsoft.com/office/drawing/2014/main" id="{87F0E997-DE30-4E1A-BC0A-A6428E44BC44}"/>
+                <a16:creationId xmlns:a16="http://schemas.microsoft.com/office/drawing/2014/main" id="{33BF9946-63B2-47DE-872C-8E89A9694701}"/>
               </a:ext>
             </a:extLst>
           </p:cNvPr>
@@ -4176,7 +4176,7 @@
     </p:spTree>
     <p:extLst>
       <p:ext uri="{BB962C8B-B14F-4D97-AF65-F5344CB8AC3E}">
-        <p14:creationId xmlns:p14="http://schemas.microsoft.com/office/powerpoint/2010/main" val="1287843829"/>
+        <p14:creationId xmlns:p14="http://schemas.microsoft.com/office/powerpoint/2010/main" val="1131303972"/>
       </p:ext>
     </p:extLst>
   </p:cSld>
@@ -4207,7 +4207,7 @@
           <p:cNvPr id="21" name="">
             <a:extLst xmlns:a="http://schemas.openxmlformats.org/drawingml/2006/main">
               <a:ext uri="{FF2B5EF4-FFF2-40B4-BE49-F238E27FC236}">
-                <a16:creationId xmlns:a16="http://schemas.microsoft.com/office/drawing/2014/main" id="{FD728F0A-0DFD-4640-808F-627B87580082}"/>
+                <a16:creationId xmlns:a16="http://schemas.microsoft.com/office/drawing/2014/main" id="{CDD6A91A-DF1C-4916-94FA-02141E7E4D28}"/>
               </a:ext>
             </a:extLst>
           </p:cNvPr>
@@ -4238,7 +4238,7 @@
           <p:cNvPr id="2" name="">
             <a:extLst xmlns:a="http://schemas.openxmlformats.org/drawingml/2006/main">
               <a:ext uri="{FF2B5EF4-FFF2-40B4-BE49-F238E27FC236}">
-                <a16:creationId xmlns:a16="http://schemas.microsoft.com/office/drawing/2014/main" id="{D59A3C79-DED7-4CFC-BB3C-92E1A4777CFF}"/>
+                <a16:creationId xmlns:a16="http://schemas.microsoft.com/office/drawing/2014/main" id="{43EA5A1B-C4B4-42E9-81B9-A8D520CB1AD0}"/>
               </a:ext>
             </a:extLst>
           </p:cNvPr>
@@ -4296,7 +4296,7 @@
           <p:cNvPr id="3" name="">
             <a:extLst xmlns:a="http://schemas.openxmlformats.org/drawingml/2006/main">
               <a:ext uri="{FF2B5EF4-FFF2-40B4-BE49-F238E27FC236}">
-                <a16:creationId xmlns:a16="http://schemas.microsoft.com/office/drawing/2014/main" id="{A9C27983-154F-49F2-BBCF-50E16DD6EC21}"/>
+                <a16:creationId xmlns:a16="http://schemas.microsoft.com/office/drawing/2014/main" id="{60A211A8-DC06-47B9-854F-CA7CC9D094F1}"/>
               </a:ext>
             </a:extLst>
           </p:cNvPr>
@@ -4354,7 +4354,7 @@
           <p:cNvPr id="4" name="">
             <a:extLst xmlns:a="http://schemas.openxmlformats.org/drawingml/2006/main">
               <a:ext uri="{FF2B5EF4-FFF2-40B4-BE49-F238E27FC236}">
-                <a16:creationId xmlns:a16="http://schemas.microsoft.com/office/drawing/2014/main" id="{B87313FB-319F-45CA-A9D4-9BEB4B14C317}"/>
+                <a16:creationId xmlns:a16="http://schemas.microsoft.com/office/drawing/2014/main" id="{6CB4E249-947A-49C9-AADD-A9488EFE1829}"/>
               </a:ext>
             </a:extLst>
           </p:cNvPr>
@@ -4412,7 +4412,7 @@
           <p:cNvPr id="5" name="">
             <a:extLst xmlns:a="http://schemas.openxmlformats.org/drawingml/2006/main">
               <a:ext uri="{FF2B5EF4-FFF2-40B4-BE49-F238E27FC236}">
-                <a16:creationId xmlns:a16="http://schemas.microsoft.com/office/drawing/2014/main" id="{35D7F22C-0E03-491A-A73A-74FE8F0CC7FE}"/>
+                <a16:creationId xmlns:a16="http://schemas.microsoft.com/office/drawing/2014/main" id="{0D15AA0C-8CC5-42EB-B253-6D7CDB61E4FA}"/>
               </a:ext>
             </a:extLst>
           </p:cNvPr>
@@ -4687,7 +4687,7 @@
           <p:cNvPr id="7" name="">
             <a:extLst xmlns:a="http://schemas.openxmlformats.org/drawingml/2006/main">
               <a:ext uri="{FF2B5EF4-FFF2-40B4-BE49-F238E27FC236}">
-                <a16:creationId xmlns:a16="http://schemas.microsoft.com/office/drawing/2014/main" id="{676755AE-4025-45A4-83D3-B0495D797966}"/>
+                <a16:creationId xmlns:a16="http://schemas.microsoft.com/office/drawing/2014/main" id="{2115EF24-EBAD-499B-9D6B-4299E5134AAE}"/>
               </a:ext>
             </a:extLst>
           </p:cNvPr>
@@ -4718,7 +4718,7 @@
           <p:cNvPr id="8" name="">
             <a:extLst xmlns:a="http://schemas.openxmlformats.org/drawingml/2006/main">
               <a:ext uri="{FF2B5EF4-FFF2-40B4-BE49-F238E27FC236}">
-                <a16:creationId xmlns:a16="http://schemas.microsoft.com/office/drawing/2014/main" id="{FFF0995D-8F0F-4AB8-AB62-8FB39A8F9A64}"/>
+                <a16:creationId xmlns:a16="http://schemas.microsoft.com/office/drawing/2014/main" id="{D18472F2-7FF3-4F6F-9106-68B48298A785}"/>
               </a:ext>
             </a:extLst>
           </p:cNvPr>
@@ -5297,7 +5297,7 @@
           <p:cNvPr id="10" name="">
             <a:extLst xmlns:a="http://schemas.openxmlformats.org/drawingml/2006/main">
               <a:ext uri="{FF2B5EF4-FFF2-40B4-BE49-F238E27FC236}">
-                <a16:creationId xmlns:a16="http://schemas.microsoft.com/office/drawing/2014/main" id="{E5C190DA-4ADD-4172-8957-E52F3241D48D}"/>
+                <a16:creationId xmlns:a16="http://schemas.microsoft.com/office/drawing/2014/main" id="{6976DC48-01D1-497C-8BB5-25F84D0D2E26}"/>
               </a:ext>
             </a:extLst>
           </p:cNvPr>
@@ -5359,7 +5359,7 @@
           <p:cNvPr id="11" name="">
             <a:extLst xmlns:a="http://schemas.openxmlformats.org/drawingml/2006/main">
               <a:ext uri="{FF2B5EF4-FFF2-40B4-BE49-F238E27FC236}">
-                <a16:creationId xmlns:a16="http://schemas.microsoft.com/office/drawing/2014/main" id="{AD3D69AB-F38F-4F05-9E89-C225BE520CB7}"/>
+                <a16:creationId xmlns:a16="http://schemas.microsoft.com/office/drawing/2014/main" id="{CE428306-5EC9-408E-BAB8-08CB472513B5}"/>
               </a:ext>
             </a:extLst>
           </p:cNvPr>
@@ -5424,7 +5424,7 @@
         </p:xfrm>
         <a:graphic xmlns:a="http://schemas.openxmlformats.org/drawingml/2006/main">
           <a:graphicData uri="http://schemas.openxmlformats.org/drawingml/2006/chart">
-            <c:chart xmlns:r="http://schemas.openxmlformats.org/officeDocument/2006/relationships" xmlns:c="http://schemas.openxmlformats.org/drawingml/2006/chart" r:id="Ra97aadc4020b40ba"/>
+            <c:chart xmlns:r="http://schemas.openxmlformats.org/officeDocument/2006/relationships" xmlns:c="http://schemas.openxmlformats.org/drawingml/2006/chart" r:id="Rcd094564a20d409a"/>
           </a:graphicData>
         </a:graphic>
       </p:graphicFrame>
@@ -5433,7 +5433,7 @@
           <p:cNvPr id="13" name="">
             <a:extLst xmlns:a="http://schemas.openxmlformats.org/drawingml/2006/main">
               <a:ext uri="{FF2B5EF4-FFF2-40B4-BE49-F238E27FC236}">
-                <a16:creationId xmlns:a16="http://schemas.microsoft.com/office/drawing/2014/main" id="{A78F0C7A-6A5F-4BD1-A5E0-BDE73C852C8A}"/>
+                <a16:creationId xmlns:a16="http://schemas.microsoft.com/office/drawing/2014/main" id="{53AE3BAE-B9B4-413C-8AE1-11B983C99058}"/>
               </a:ext>
             </a:extLst>
           </p:cNvPr>
@@ -5491,7 +5491,7 @@
           <p:cNvPr id="14" name="">
             <a:extLst xmlns:a="http://schemas.openxmlformats.org/drawingml/2006/main">
               <a:ext uri="{FF2B5EF4-FFF2-40B4-BE49-F238E27FC236}">
-                <a16:creationId xmlns:a16="http://schemas.microsoft.com/office/drawing/2014/main" id="{5C5ECDBE-3DE4-4274-86C3-FD674E59DDFD}"/>
+                <a16:creationId xmlns:a16="http://schemas.microsoft.com/office/drawing/2014/main" id="{5C42A6B2-DB5D-4D78-9162-EE2FCA32B2A8}"/>
               </a:ext>
             </a:extLst>
           </p:cNvPr>
@@ -5556,7 +5556,7 @@
         </p:xfrm>
         <a:graphic xmlns:a="http://schemas.openxmlformats.org/drawingml/2006/main">
           <a:graphicData uri="http://schemas.openxmlformats.org/drawingml/2006/chart">
-            <c:chart xmlns:r="http://schemas.openxmlformats.org/officeDocument/2006/relationships" xmlns:c="http://schemas.openxmlformats.org/drawingml/2006/chart" r:id="Rfdae77fb7fd84ef1"/>
+            <c:chart xmlns:r="http://schemas.openxmlformats.org/officeDocument/2006/relationships" xmlns:c="http://schemas.openxmlformats.org/drawingml/2006/chart" r:id="Rd276613a7b99405a"/>
           </a:graphicData>
         </a:graphic>
       </p:graphicFrame>
@@ -5565,7 +5565,7 @@
           <p:cNvPr id="16" name="">
             <a:extLst xmlns:a="http://schemas.openxmlformats.org/drawingml/2006/main">
               <a:ext uri="{FF2B5EF4-FFF2-40B4-BE49-F238E27FC236}">
-                <a16:creationId xmlns:a16="http://schemas.microsoft.com/office/drawing/2014/main" id="{CF0102D0-C346-440F-8CF3-F3323141E960}"/>
+                <a16:creationId xmlns:a16="http://schemas.microsoft.com/office/drawing/2014/main" id="{DE278F89-0C81-44A3-9E7E-93D89928A935}"/>
               </a:ext>
             </a:extLst>
           </p:cNvPr>
@@ -5627,7 +5627,7 @@
           <p:cNvPr id="17" name="">
             <a:extLst xmlns:a="http://schemas.openxmlformats.org/drawingml/2006/main">
               <a:ext uri="{FF2B5EF4-FFF2-40B4-BE49-F238E27FC236}">
-                <a16:creationId xmlns:a16="http://schemas.microsoft.com/office/drawing/2014/main" id="{6511E1A9-5016-49B8-A5A7-8708D1D19CDA}"/>
+                <a16:creationId xmlns:a16="http://schemas.microsoft.com/office/drawing/2014/main" id="{ED6B5336-8658-488D-BD7D-2F5B33F95132}"/>
               </a:ext>
             </a:extLst>
           </p:cNvPr>
@@ -5658,7 +5658,7 @@
           <p:cNvPr id="18" name="">
             <a:extLst xmlns:a="http://schemas.openxmlformats.org/drawingml/2006/main">
               <a:ext uri="{FF2B5EF4-FFF2-40B4-BE49-F238E27FC236}">
-                <a16:creationId xmlns:a16="http://schemas.microsoft.com/office/drawing/2014/main" id="{DF609F2F-9AC3-44BC-92BE-17E5170BE2AD}"/>
+                <a16:creationId xmlns:a16="http://schemas.microsoft.com/office/drawing/2014/main" id="{6D2B291C-CB48-479B-B381-93A8BA222395}"/>
               </a:ext>
             </a:extLst>
           </p:cNvPr>
@@ -5716,7 +5716,7 @@
           <p:cNvPr id="19" name="">
             <a:extLst xmlns:a="http://schemas.openxmlformats.org/drawingml/2006/main">
               <a:ext uri="{FF2B5EF4-FFF2-40B4-BE49-F238E27FC236}">
-                <a16:creationId xmlns:a16="http://schemas.microsoft.com/office/drawing/2014/main" id="{609538A9-9542-48CA-BE1F-5E6D037ED41F}"/>
+                <a16:creationId xmlns:a16="http://schemas.microsoft.com/office/drawing/2014/main" id="{6E9E404C-2026-4B70-BDD0-0648FB87FAAD}"/>
               </a:ext>
             </a:extLst>
           </p:cNvPr>
@@ -5774,7 +5774,7 @@
           <p:cNvPr id="20" name="">
             <a:extLst xmlns:a="http://schemas.openxmlformats.org/drawingml/2006/main">
               <a:ext uri="{FF2B5EF4-FFF2-40B4-BE49-F238E27FC236}">
-                <a16:creationId xmlns:a16="http://schemas.microsoft.com/office/drawing/2014/main" id="{30D2F951-9DA6-42EE-9A07-C8E89756B077}"/>
+                <a16:creationId xmlns:a16="http://schemas.microsoft.com/office/drawing/2014/main" id="{AFB96C95-DF0F-46F4-9A20-DA4674B33A43}"/>
               </a:ext>
             </a:extLst>
           </p:cNvPr>
@@ -5830,7 +5830,7 @@
     </p:spTree>
     <p:extLst>
       <p:ext uri="{BB962C8B-B14F-4D97-AF65-F5344CB8AC3E}">
-        <p14:creationId xmlns:p14="http://schemas.microsoft.com/office/powerpoint/2010/main" val="1355499876"/>
+        <p14:creationId xmlns:p14="http://schemas.microsoft.com/office/powerpoint/2010/main" val="1990438380"/>
       </p:ext>
     </p:extLst>
   </p:cSld>
@@ -5861,7 +5861,7 @@
           <p:cNvPr id="28" name="">
             <a:extLst xmlns:a="http://schemas.openxmlformats.org/drawingml/2006/main">
               <a:ext uri="{FF2B5EF4-FFF2-40B4-BE49-F238E27FC236}">
-                <a16:creationId xmlns:a16="http://schemas.microsoft.com/office/drawing/2014/main" id="{74A3C80E-BC4A-4578-99D4-127DA38AE02B}"/>
+                <a16:creationId xmlns:a16="http://schemas.microsoft.com/office/drawing/2014/main" id="{F82FB901-EDFE-49BD-AC7E-B0A9EF87DFAF}"/>
               </a:ext>
             </a:extLst>
           </p:cNvPr>
@@ -5892,7 +5892,7 @@
           <p:cNvPr id="2" name="">
             <a:extLst xmlns:a="http://schemas.openxmlformats.org/drawingml/2006/main">
               <a:ext uri="{FF2B5EF4-FFF2-40B4-BE49-F238E27FC236}">
-                <a16:creationId xmlns:a16="http://schemas.microsoft.com/office/drawing/2014/main" id="{8F930ABA-0719-497A-AD76-9775FFFFBEF2}"/>
+                <a16:creationId xmlns:a16="http://schemas.microsoft.com/office/drawing/2014/main" id="{AC736904-BC1E-4E63-AD38-5C588E1C6164}"/>
               </a:ext>
             </a:extLst>
           </p:cNvPr>
@@ -5950,7 +5950,7 @@
           <p:cNvPr id="3" name="">
             <a:extLst xmlns:a="http://schemas.openxmlformats.org/drawingml/2006/main">
               <a:ext uri="{FF2B5EF4-FFF2-40B4-BE49-F238E27FC236}">
-                <a16:creationId xmlns:a16="http://schemas.microsoft.com/office/drawing/2014/main" id="{9FEF2F63-ABD8-4A3B-BCA1-F262E819BF74}"/>
+                <a16:creationId xmlns:a16="http://schemas.microsoft.com/office/drawing/2014/main" id="{E8A8D4F3-74D4-4400-B8FF-DB7851B6CA31}"/>
               </a:ext>
             </a:extLst>
           </p:cNvPr>
@@ -6008,7 +6008,7 @@
           <p:cNvPr id="4" name="">
             <a:extLst xmlns:a="http://schemas.openxmlformats.org/drawingml/2006/main">
               <a:ext uri="{FF2B5EF4-FFF2-40B4-BE49-F238E27FC236}">
-                <a16:creationId xmlns:a16="http://schemas.microsoft.com/office/drawing/2014/main" id="{2F651B96-E82A-47C6-A8DA-1DD18EBC52FE}"/>
+                <a16:creationId xmlns:a16="http://schemas.microsoft.com/office/drawing/2014/main" id="{42F3AD27-9B89-4469-A4F5-423C79285F01}"/>
               </a:ext>
             </a:extLst>
           </p:cNvPr>
@@ -6066,7 +6066,7 @@
           <p:cNvPr id="5" name="">
             <a:extLst xmlns:a="http://schemas.openxmlformats.org/drawingml/2006/main">
               <a:ext uri="{FF2B5EF4-FFF2-40B4-BE49-F238E27FC236}">
-                <a16:creationId xmlns:a16="http://schemas.microsoft.com/office/drawing/2014/main" id="{C2628BC5-E3E5-4AE4-9744-9802E18CFD78}"/>
+                <a16:creationId xmlns:a16="http://schemas.microsoft.com/office/drawing/2014/main" id="{568FEDEF-215A-4874-95BF-4A9CA2260A34}"/>
               </a:ext>
             </a:extLst>
           </p:cNvPr>
@@ -6097,7 +6097,7 @@
           <p:cNvPr id="6" name="">
             <a:extLst xmlns:a="http://schemas.openxmlformats.org/drawingml/2006/main">
               <a:ext uri="{FF2B5EF4-FFF2-40B4-BE49-F238E27FC236}">
-                <a16:creationId xmlns:a16="http://schemas.microsoft.com/office/drawing/2014/main" id="{D0B00843-9181-4F2F-B5F1-4E19E43E26E1}"/>
+                <a16:creationId xmlns:a16="http://schemas.microsoft.com/office/drawing/2014/main" id="{12BA9839-ADE7-46E3-A8A0-65C67667948D}"/>
               </a:ext>
             </a:extLst>
           </p:cNvPr>
@@ -6155,7 +6155,7 @@
           <p:cNvPr id="7" name="">
             <a:extLst xmlns:a="http://schemas.openxmlformats.org/drawingml/2006/main">
               <a:ext uri="{FF2B5EF4-FFF2-40B4-BE49-F238E27FC236}">
-                <a16:creationId xmlns:a16="http://schemas.microsoft.com/office/drawing/2014/main" id="{4537D5A4-549D-45F3-B96B-DDFE7F5183DB}"/>
+                <a16:creationId xmlns:a16="http://schemas.microsoft.com/office/drawing/2014/main" id="{DB240333-B84A-44C6-BBD6-430DFB29A117}"/>
               </a:ext>
             </a:extLst>
           </p:cNvPr>
@@ -6217,7 +6217,7 @@
           <p:cNvPr id="8" name="">
             <a:extLst xmlns:a="http://schemas.openxmlformats.org/drawingml/2006/main">
               <a:ext uri="{FF2B5EF4-FFF2-40B4-BE49-F238E27FC236}">
-                <a16:creationId xmlns:a16="http://schemas.microsoft.com/office/drawing/2014/main" id="{8DACC257-0DD8-4A93-A591-DC8A4B6E6BE7}"/>
+                <a16:creationId xmlns:a16="http://schemas.microsoft.com/office/drawing/2014/main" id="{DA54F51C-8AD2-46D0-881E-53E01D16943D}"/>
               </a:ext>
             </a:extLst>
           </p:cNvPr>
@@ -6265,7 +6265,7 @@
                 <a:ea typeface="Helvetica Neue"/>
                 <a:cs typeface="Helvetica Neue"/>
               </a:rPr>
-              <a:t>Model evidence from the 16-slide analysis</a:t>
+              <a:t>Model performance evidence</a:t>
             </a:r>
           </a:p>
         </p:txBody>
@@ -6282,7 +6282,7 @@
         </p:xfrm>
         <a:graphic xmlns:a="http://schemas.openxmlformats.org/drawingml/2006/main">
           <a:graphicData uri="http://schemas.openxmlformats.org/drawingml/2006/chart">
-            <c:chart xmlns:r="http://schemas.openxmlformats.org/officeDocument/2006/relationships" xmlns:c="http://schemas.openxmlformats.org/drawingml/2006/chart" r:id="R52eec6023ef64542"/>
+            <c:chart xmlns:r="http://schemas.openxmlformats.org/officeDocument/2006/relationships" xmlns:c="http://schemas.openxmlformats.org/drawingml/2006/chart" r:id="R245aa5ae02df443f"/>
           </a:graphicData>
         </a:graphic>
       </p:graphicFrame>
@@ -6291,7 +6291,7 @@
           <p:cNvPr id="10" name="">
             <a:extLst xmlns:a="http://schemas.openxmlformats.org/drawingml/2006/main">
               <a:ext uri="{FF2B5EF4-FFF2-40B4-BE49-F238E27FC236}">
-                <a16:creationId xmlns:a16="http://schemas.microsoft.com/office/drawing/2014/main" id="{5045F837-938D-4A59-AA69-8C1780E1A423}"/>
+                <a16:creationId xmlns:a16="http://schemas.microsoft.com/office/drawing/2014/main" id="{551ED51A-28A9-4D7A-8510-9006C8E891E1}"/>
               </a:ext>
             </a:extLst>
           </p:cNvPr>
@@ -6353,7 +6353,7 @@
           <p:cNvPr id="11" name="">
             <a:extLst xmlns:a="http://schemas.openxmlformats.org/drawingml/2006/main">
               <a:ext uri="{FF2B5EF4-FFF2-40B4-BE49-F238E27FC236}">
-                <a16:creationId xmlns:a16="http://schemas.microsoft.com/office/drawing/2014/main" id="{F5ACCF5F-1BE3-4996-99DE-DDE02BCFF3E4}"/>
+                <a16:creationId xmlns:a16="http://schemas.microsoft.com/office/drawing/2014/main" id="{3CD2AA5C-AEE9-433F-A3D4-D2C7D18CD4AB}"/>
               </a:ext>
             </a:extLst>
           </p:cNvPr>
@@ -6384,7 +6384,7 @@
           <p:cNvPr id="12" name="">
             <a:extLst xmlns:a="http://schemas.openxmlformats.org/drawingml/2006/main">
               <a:ext uri="{FF2B5EF4-FFF2-40B4-BE49-F238E27FC236}">
-                <a16:creationId xmlns:a16="http://schemas.microsoft.com/office/drawing/2014/main" id="{514F34BB-21B4-4029-864F-8B17E94DFC6A}"/>
+                <a16:creationId xmlns:a16="http://schemas.microsoft.com/office/drawing/2014/main" id="{E72C00FC-9D88-432E-86DC-20AAF3ABAB86}"/>
               </a:ext>
             </a:extLst>
           </p:cNvPr>
@@ -6442,7 +6442,7 @@
           <p:cNvPr id="13" name="">
             <a:extLst xmlns:a="http://schemas.openxmlformats.org/drawingml/2006/main">
               <a:ext uri="{FF2B5EF4-FFF2-40B4-BE49-F238E27FC236}">
-                <a16:creationId xmlns:a16="http://schemas.microsoft.com/office/drawing/2014/main" id="{A9DD6A3B-2469-4131-BEA4-FF4651485C1C}"/>
+                <a16:creationId xmlns:a16="http://schemas.microsoft.com/office/drawing/2014/main" id="{90147ABA-D9E8-447E-A324-F57472B31894}"/>
               </a:ext>
             </a:extLst>
           </p:cNvPr>
@@ -6500,7 +6500,7 @@
           <p:cNvPr id="14" name="">
             <a:extLst xmlns:a="http://schemas.openxmlformats.org/drawingml/2006/main">
               <a:ext uri="{FF2B5EF4-FFF2-40B4-BE49-F238E27FC236}">
-                <a16:creationId xmlns:a16="http://schemas.microsoft.com/office/drawing/2014/main" id="{51127571-0B4E-44C5-800D-4BE12026D290}"/>
+                <a16:creationId xmlns:a16="http://schemas.microsoft.com/office/drawing/2014/main" id="{E0518B7C-6CE7-4DF9-8E1A-A00AEC86FDBD}"/>
               </a:ext>
             </a:extLst>
           </p:cNvPr>
@@ -6625,7 +6625,7 @@
           <p:cNvPr id="15" name="">
             <a:extLst xmlns:a="http://schemas.openxmlformats.org/drawingml/2006/main">
               <a:ext uri="{FF2B5EF4-FFF2-40B4-BE49-F238E27FC236}">
-                <a16:creationId xmlns:a16="http://schemas.microsoft.com/office/drawing/2014/main" id="{01A7AB22-C4EC-4CB4-9F5A-23E845F6F18A}"/>
+                <a16:creationId xmlns:a16="http://schemas.microsoft.com/office/drawing/2014/main" id="{9EA5B34B-8F5E-4AE9-8ECA-290D98A585CD}"/>
               </a:ext>
             </a:extLst>
           </p:cNvPr>
@@ -6687,7 +6687,7 @@
           <p:cNvPr id="16" name="">
             <a:extLst xmlns:a="http://schemas.openxmlformats.org/drawingml/2006/main">
               <a:ext uri="{FF2B5EF4-FFF2-40B4-BE49-F238E27FC236}">
-                <a16:creationId xmlns:a16="http://schemas.microsoft.com/office/drawing/2014/main" id="{82D750E2-C7FC-49E8-8EEB-715268026A15}"/>
+                <a16:creationId xmlns:a16="http://schemas.microsoft.com/office/drawing/2014/main" id="{3914B36D-59D6-440A-B9AF-3485FA226216}"/>
               </a:ext>
             </a:extLst>
           </p:cNvPr>
@@ -6745,7 +6745,7 @@
           <p:cNvPr id="17" name="">
             <a:extLst xmlns:a="http://schemas.openxmlformats.org/drawingml/2006/main">
               <a:ext uri="{FF2B5EF4-FFF2-40B4-BE49-F238E27FC236}">
-                <a16:creationId xmlns:a16="http://schemas.microsoft.com/office/drawing/2014/main" id="{E694BABD-E120-40F5-B6F8-C9A4E0ED5C9B}"/>
+                <a16:creationId xmlns:a16="http://schemas.microsoft.com/office/drawing/2014/main" id="{0369827B-B173-4A5C-806B-4A63D4552BF0}"/>
               </a:ext>
             </a:extLst>
           </p:cNvPr>
@@ -6803,7 +6803,7 @@
           <p:cNvPr id="18" name="">
             <a:extLst xmlns:a="http://schemas.openxmlformats.org/drawingml/2006/main">
               <a:ext uri="{FF2B5EF4-FFF2-40B4-BE49-F238E27FC236}">
-                <a16:creationId xmlns:a16="http://schemas.microsoft.com/office/drawing/2014/main" id="{D49DBDE9-963E-4BF5-BE82-6ECEF6D9D6A4}"/>
+                <a16:creationId xmlns:a16="http://schemas.microsoft.com/office/drawing/2014/main" id="{7E3DD76F-B37A-4E33-BAB9-29DC98C5CA7A}"/>
               </a:ext>
             </a:extLst>
           </p:cNvPr>
@@ -6928,7 +6928,7 @@
           <p:cNvPr id="19" name="">
             <a:extLst xmlns:a="http://schemas.openxmlformats.org/drawingml/2006/main">
               <a:ext uri="{FF2B5EF4-FFF2-40B4-BE49-F238E27FC236}">
-                <a16:creationId xmlns:a16="http://schemas.microsoft.com/office/drawing/2014/main" id="{03F7641C-A3D1-48DB-B563-C835AC54E7DF}"/>
+                <a16:creationId xmlns:a16="http://schemas.microsoft.com/office/drawing/2014/main" id="{AC97C2E5-4D8E-4BBD-9A0A-A3927DA4E83C}"/>
               </a:ext>
             </a:extLst>
           </p:cNvPr>
@@ -6990,7 +6990,7 @@
           <p:cNvPr id="20" name="">
             <a:extLst xmlns:a="http://schemas.openxmlformats.org/drawingml/2006/main">
               <a:ext uri="{FF2B5EF4-FFF2-40B4-BE49-F238E27FC236}">
-                <a16:creationId xmlns:a16="http://schemas.microsoft.com/office/drawing/2014/main" id="{516C2A07-97A6-4C28-9A92-37F62355C4DA}"/>
+                <a16:creationId xmlns:a16="http://schemas.microsoft.com/office/drawing/2014/main" id="{789D9F5B-862C-40C6-90FB-47859954EA9A}"/>
               </a:ext>
             </a:extLst>
           </p:cNvPr>
@@ -7048,7 +7048,7 @@
           <p:cNvPr id="21" name="">
             <a:extLst xmlns:a="http://schemas.openxmlformats.org/drawingml/2006/main">
               <a:ext uri="{FF2B5EF4-FFF2-40B4-BE49-F238E27FC236}">
-                <a16:creationId xmlns:a16="http://schemas.microsoft.com/office/drawing/2014/main" id="{1CBD4E8E-CE6D-4EB6-B9FE-F7A4BE894756}"/>
+                <a16:creationId xmlns:a16="http://schemas.microsoft.com/office/drawing/2014/main" id="{BCB435D4-31E8-489B-928D-C6BD3356E50D}"/>
               </a:ext>
             </a:extLst>
           </p:cNvPr>
@@ -7106,7 +7106,7 @@
           <p:cNvPr id="22" name="">
             <a:extLst xmlns:a="http://schemas.openxmlformats.org/drawingml/2006/main">
               <a:ext uri="{FF2B5EF4-FFF2-40B4-BE49-F238E27FC236}">
-                <a16:creationId xmlns:a16="http://schemas.microsoft.com/office/drawing/2014/main" id="{1EB7C7B9-FFA5-4E90-8163-ABD1E3CAEB45}"/>
+                <a16:creationId xmlns:a16="http://schemas.microsoft.com/office/drawing/2014/main" id="{30D3382D-AE19-4B18-A475-BDF394D6A43A}"/>
               </a:ext>
             </a:extLst>
           </p:cNvPr>
@@ -7231,7 +7231,7 @@
           <p:cNvPr id="23" name="">
             <a:extLst xmlns:a="http://schemas.openxmlformats.org/drawingml/2006/main">
               <a:ext uri="{FF2B5EF4-FFF2-40B4-BE49-F238E27FC236}">
-                <a16:creationId xmlns:a16="http://schemas.microsoft.com/office/drawing/2014/main" id="{B953B072-4AE4-4853-9656-ED1096A3422F}"/>
+                <a16:creationId xmlns:a16="http://schemas.microsoft.com/office/drawing/2014/main" id="{76AE44BE-AAC9-42C8-9668-73F0BC33EA70}"/>
               </a:ext>
             </a:extLst>
           </p:cNvPr>
@@ -7293,7 +7293,7 @@
           <p:cNvPr id="24" name="">
             <a:extLst xmlns:a="http://schemas.openxmlformats.org/drawingml/2006/main">
               <a:ext uri="{FF2B5EF4-FFF2-40B4-BE49-F238E27FC236}">
-                <a16:creationId xmlns:a16="http://schemas.microsoft.com/office/drawing/2014/main" id="{E6E761BF-35F3-4102-AB48-7948614DD375}"/>
+                <a16:creationId xmlns:a16="http://schemas.microsoft.com/office/drawing/2014/main" id="{91BA5935-7C24-4152-ADBF-097BDC50B47C}"/>
               </a:ext>
             </a:extLst>
           </p:cNvPr>
@@ -7324,7 +7324,7 @@
           <p:cNvPr id="25" name="">
             <a:extLst xmlns:a="http://schemas.openxmlformats.org/drawingml/2006/main">
               <a:ext uri="{FF2B5EF4-FFF2-40B4-BE49-F238E27FC236}">
-                <a16:creationId xmlns:a16="http://schemas.microsoft.com/office/drawing/2014/main" id="{E2B34E6A-073F-433F-BA78-AE57047213B8}"/>
+                <a16:creationId xmlns:a16="http://schemas.microsoft.com/office/drawing/2014/main" id="{EC4E0C64-CD65-4107-8908-21CF8198861A}"/>
               </a:ext>
             </a:extLst>
           </p:cNvPr>
@@ -7382,7 +7382,7 @@
           <p:cNvPr id="26" name="">
             <a:extLst xmlns:a="http://schemas.openxmlformats.org/drawingml/2006/main">
               <a:ext uri="{FF2B5EF4-FFF2-40B4-BE49-F238E27FC236}">
-                <a16:creationId xmlns:a16="http://schemas.microsoft.com/office/drawing/2014/main" id="{47A4FEB7-7BFB-437E-877F-42212070F8D5}"/>
+                <a16:creationId xmlns:a16="http://schemas.microsoft.com/office/drawing/2014/main" id="{72C80FB7-128C-4602-A89A-751A0E7A9F67}"/>
               </a:ext>
             </a:extLst>
           </p:cNvPr>
@@ -7440,7 +7440,7 @@
           <p:cNvPr id="27" name="">
             <a:extLst xmlns:a="http://schemas.openxmlformats.org/drawingml/2006/main">
               <a:ext uri="{FF2B5EF4-FFF2-40B4-BE49-F238E27FC236}">
-                <a16:creationId xmlns:a16="http://schemas.microsoft.com/office/drawing/2014/main" id="{F028615C-B5A9-4AC0-A927-D7C5AACE57EB}"/>
+                <a16:creationId xmlns:a16="http://schemas.microsoft.com/office/drawing/2014/main" id="{11473622-116B-4966-9E12-FA4810BFE9D7}"/>
               </a:ext>
             </a:extLst>
           </p:cNvPr>
@@ -7496,7 +7496,7 @@
     </p:spTree>
     <p:extLst>
       <p:ext uri="{BB962C8B-B14F-4D97-AF65-F5344CB8AC3E}">
-        <p14:creationId xmlns:p14="http://schemas.microsoft.com/office/powerpoint/2010/main" val="1442061715"/>
+        <p14:creationId xmlns:p14="http://schemas.microsoft.com/office/powerpoint/2010/main" val="1419618753"/>
       </p:ext>
     </p:extLst>
   </p:cSld>
@@ -7527,7 +7527,7 @@
           <p:cNvPr id="19" name="">
             <a:extLst xmlns:a="http://schemas.openxmlformats.org/drawingml/2006/main">
               <a:ext uri="{FF2B5EF4-FFF2-40B4-BE49-F238E27FC236}">
-                <a16:creationId xmlns:a16="http://schemas.microsoft.com/office/drawing/2014/main" id="{EE597846-FAB9-4352-82D4-219AD1D5DCB6}"/>
+                <a16:creationId xmlns:a16="http://schemas.microsoft.com/office/drawing/2014/main" id="{3C25A798-3771-4638-89F8-17091B246AB2}"/>
               </a:ext>
             </a:extLst>
           </p:cNvPr>
@@ -7558,7 +7558,7 @@
           <p:cNvPr id="2" name="">
             <a:extLst xmlns:a="http://schemas.openxmlformats.org/drawingml/2006/main">
               <a:ext uri="{FF2B5EF4-FFF2-40B4-BE49-F238E27FC236}">
-                <a16:creationId xmlns:a16="http://schemas.microsoft.com/office/drawing/2014/main" id="{2967FEE9-61A2-4B6B-B759-BF47ED555F52}"/>
+                <a16:creationId xmlns:a16="http://schemas.microsoft.com/office/drawing/2014/main" id="{695FDFAA-A7B9-40CA-8AFD-B4376EE92CDC}"/>
               </a:ext>
             </a:extLst>
           </p:cNvPr>
@@ -7616,7 +7616,7 @@
           <p:cNvPr id="3" name="">
             <a:extLst xmlns:a="http://schemas.openxmlformats.org/drawingml/2006/main">
               <a:ext uri="{FF2B5EF4-FFF2-40B4-BE49-F238E27FC236}">
-                <a16:creationId xmlns:a16="http://schemas.microsoft.com/office/drawing/2014/main" id="{7B32CE82-01A3-472A-83F3-67994BD3F891}"/>
+                <a16:creationId xmlns:a16="http://schemas.microsoft.com/office/drawing/2014/main" id="{1F74C329-C232-4D39-A7B4-386630AC687D}"/>
               </a:ext>
             </a:extLst>
           </p:cNvPr>
@@ -7674,7 +7674,7 @@
           <p:cNvPr id="4" name="">
             <a:extLst xmlns:a="http://schemas.openxmlformats.org/drawingml/2006/main">
               <a:ext uri="{FF2B5EF4-FFF2-40B4-BE49-F238E27FC236}">
-                <a16:creationId xmlns:a16="http://schemas.microsoft.com/office/drawing/2014/main" id="{D0879696-CDEE-4A54-BEAD-E8B0A700A898}"/>
+                <a16:creationId xmlns:a16="http://schemas.microsoft.com/office/drawing/2014/main" id="{9B6E1582-D73E-4FFE-8DDF-09333EDBE1DB}"/>
               </a:ext>
             </a:extLst>
           </p:cNvPr>
@@ -7732,7 +7732,7 @@
           <p:cNvPr id="5" name="">
             <a:extLst xmlns:a="http://schemas.openxmlformats.org/drawingml/2006/main">
               <a:ext uri="{FF2B5EF4-FFF2-40B4-BE49-F238E27FC236}">
-                <a16:creationId xmlns:a16="http://schemas.microsoft.com/office/drawing/2014/main" id="{A3C7C6EE-B245-4C4D-9BF0-5CBE9AA27209}"/>
+                <a16:creationId xmlns:a16="http://schemas.microsoft.com/office/drawing/2014/main" id="{CEA368E6-A393-41E5-97E2-943E3761C363}"/>
               </a:ext>
             </a:extLst>
           </p:cNvPr>
@@ -7763,7 +7763,7 @@
           <p:cNvPr id="6" name="">
             <a:extLst xmlns:a="http://schemas.openxmlformats.org/drawingml/2006/main">
               <a:ext uri="{FF2B5EF4-FFF2-40B4-BE49-F238E27FC236}">
-                <a16:creationId xmlns:a16="http://schemas.microsoft.com/office/drawing/2014/main" id="{49F5C89C-8703-4045-AA06-4DF0E06553A1}"/>
+                <a16:creationId xmlns:a16="http://schemas.microsoft.com/office/drawing/2014/main" id="{D4C830D4-24E5-4B08-A575-EFD043CC0C76}"/>
               </a:ext>
             </a:extLst>
           </p:cNvPr>
@@ -7775,7 +7775,7 @@
         <p:spPr>
           <a:xfrm xmlns:a="http://schemas.openxmlformats.org/drawingml/2006/main">
             <a:off x="514350" y="1743075"/>
-            <a:ext cx="3619500" cy="247650"/>
+            <a:ext cx="4000500" cy="247650"/>
           </a:xfrm>
           <a:prstGeom xmlns:a="http://schemas.openxmlformats.org/drawingml/2006/main" prst="rect">
             <a:avLst/>
@@ -7811,7 +7811,7 @@
                 <a:ea typeface="Helvetica Neue"/>
                 <a:cs typeface="Helvetica Neue"/>
               </a:rPr>
-              <a:t>Evidence from the full analysis</a:t>
+              <a:t>Readmission risk stratification</a:t>
             </a:r>
           </a:p>
         </p:txBody>
@@ -7828,7 +7828,7 @@
         </p:xfrm>
         <a:graphic xmlns:a="http://schemas.openxmlformats.org/drawingml/2006/main">
           <a:graphicData uri="http://schemas.openxmlformats.org/drawingml/2006/chart">
-            <c:chart xmlns:r="http://schemas.openxmlformats.org/officeDocument/2006/relationships" xmlns:c="http://schemas.openxmlformats.org/drawingml/2006/chart" r:id="R9d9dccd0e8984b42"/>
+            <c:chart xmlns:r="http://schemas.openxmlformats.org/officeDocument/2006/relationships" xmlns:c="http://schemas.openxmlformats.org/drawingml/2006/chart" r:id="R4426ab9da4634f83"/>
           </a:graphicData>
         </a:graphic>
       </p:graphicFrame>
@@ -7837,7 +7837,7 @@
           <p:cNvPr id="8" name="">
             <a:extLst xmlns:a="http://schemas.openxmlformats.org/drawingml/2006/main">
               <a:ext uri="{FF2B5EF4-FFF2-40B4-BE49-F238E27FC236}">
-                <a16:creationId xmlns:a16="http://schemas.microsoft.com/office/drawing/2014/main" id="{3FA8CD6F-BCF1-4856-AFCD-B528CE7EDAE1}"/>
+                <a16:creationId xmlns:a16="http://schemas.microsoft.com/office/drawing/2014/main" id="{65C5CD5A-A4DA-4078-8A17-0E2DEF1040E4}"/>
               </a:ext>
             </a:extLst>
           </p:cNvPr>
@@ -7899,7 +7899,7 @@
           <p:cNvPr id="9" name="">
             <a:extLst xmlns:a="http://schemas.openxmlformats.org/drawingml/2006/main">
               <a:ext uri="{FF2B5EF4-FFF2-40B4-BE49-F238E27FC236}">
-                <a16:creationId xmlns:a16="http://schemas.microsoft.com/office/drawing/2014/main" id="{472302A5-11BA-4A7C-8C7D-4127F54007B9}"/>
+                <a16:creationId xmlns:a16="http://schemas.microsoft.com/office/drawing/2014/main" id="{187D0BFF-462D-4F5E-9B82-863586FF4A32}"/>
               </a:ext>
             </a:extLst>
           </p:cNvPr>
@@ -8421,7 +8421,7 @@
           <p:cNvPr id="11" name="">
             <a:extLst xmlns:a="http://schemas.openxmlformats.org/drawingml/2006/main">
               <a:ext uri="{FF2B5EF4-FFF2-40B4-BE49-F238E27FC236}">
-                <a16:creationId xmlns:a16="http://schemas.microsoft.com/office/drawing/2014/main" id="{55C905E1-460B-44C3-B63E-9B441CA0C5C9}"/>
+                <a16:creationId xmlns:a16="http://schemas.microsoft.com/office/drawing/2014/main" id="{7751825C-64DE-4F59-A130-3D80F548786C}"/>
               </a:ext>
             </a:extLst>
           </p:cNvPr>
@@ -8483,7 +8483,7 @@
           <p:cNvPr id="12" name="">
             <a:extLst xmlns:a="http://schemas.openxmlformats.org/drawingml/2006/main">
               <a:ext uri="{FF2B5EF4-FFF2-40B4-BE49-F238E27FC236}">
-                <a16:creationId xmlns:a16="http://schemas.microsoft.com/office/drawing/2014/main" id="{49B5AEEA-41FE-4110-9024-C1AC21A08BEA}"/>
+                <a16:creationId xmlns:a16="http://schemas.microsoft.com/office/drawing/2014/main" id="{AC9C6E7C-9F21-452D-89A6-47102BB53978}"/>
               </a:ext>
             </a:extLst>
           </p:cNvPr>
@@ -8514,7 +8514,7 @@
           <p:cNvPr id="13" name="">
             <a:extLst xmlns:a="http://schemas.openxmlformats.org/drawingml/2006/main">
               <a:ext uri="{FF2B5EF4-FFF2-40B4-BE49-F238E27FC236}">
-                <a16:creationId xmlns:a16="http://schemas.microsoft.com/office/drawing/2014/main" id="{4FE6822A-F942-495F-8793-0F4FED1C4BFC}"/>
+                <a16:creationId xmlns:a16="http://schemas.microsoft.com/office/drawing/2014/main" id="{A248CF0E-88E9-40ED-BE76-0983143FD4CD}"/>
               </a:ext>
             </a:extLst>
           </p:cNvPr>
@@ -8874,7 +8874,7 @@
           <p:cNvPr id="15" name="">
             <a:extLst xmlns:a="http://schemas.openxmlformats.org/drawingml/2006/main">
               <a:ext uri="{FF2B5EF4-FFF2-40B4-BE49-F238E27FC236}">
-                <a16:creationId xmlns:a16="http://schemas.microsoft.com/office/drawing/2014/main" id="{2221DD45-9CBF-4899-B565-E8D974F6D0D9}"/>
+                <a16:creationId xmlns:a16="http://schemas.microsoft.com/office/drawing/2014/main" id="{52D7337B-02A8-44EB-B84D-98C92CBDDAEF}"/>
               </a:ext>
             </a:extLst>
           </p:cNvPr>
@@ -9178,7 +9178,7 @@
           <p:cNvPr id="17" name="">
             <a:extLst xmlns:a="http://schemas.openxmlformats.org/drawingml/2006/main">
               <a:ext uri="{FF2B5EF4-FFF2-40B4-BE49-F238E27FC236}">
-                <a16:creationId xmlns:a16="http://schemas.microsoft.com/office/drawing/2014/main" id="{2F249CEF-6ED7-439E-B222-DFB04AE08BA2}"/>
+                <a16:creationId xmlns:a16="http://schemas.microsoft.com/office/drawing/2014/main" id="{451F7855-B894-46A8-96A1-D6556E46B8EF}"/>
               </a:ext>
             </a:extLst>
           </p:cNvPr>
@@ -9240,7 +9240,7 @@
           <p:cNvPr id="18" name="">
             <a:extLst xmlns:a="http://schemas.openxmlformats.org/drawingml/2006/main">
               <a:ext uri="{FF2B5EF4-FFF2-40B4-BE49-F238E27FC236}">
-                <a16:creationId xmlns:a16="http://schemas.microsoft.com/office/drawing/2014/main" id="{74436DFD-E55A-4199-B799-775493A2F735}"/>
+                <a16:creationId xmlns:a16="http://schemas.microsoft.com/office/drawing/2014/main" id="{3763E0E4-7F90-4273-A3BA-B0D7948213AB}"/>
               </a:ext>
             </a:extLst>
           </p:cNvPr>
@@ -9296,7 +9296,7 @@
     </p:spTree>
     <p:extLst>
       <p:ext uri="{BB962C8B-B14F-4D97-AF65-F5344CB8AC3E}">
-        <p14:creationId xmlns:p14="http://schemas.microsoft.com/office/powerpoint/2010/main" val="1500652471"/>
+        <p14:creationId xmlns:p14="http://schemas.microsoft.com/office/powerpoint/2010/main" val="1539863027"/>
       </p:ext>
     </p:extLst>
   </p:cSld>

</xml_diff>

<commit_message>
Add ethical considerations slide
</commit_message>
<xml_diff>
--- a/drafts/saturday_submission.pptx
+++ b/drafts/saturday_submission.pptx
@@ -2,17 +2,18 @@
 <file path=ppt/presentation.xml><?xml version="1.0" encoding="utf-8"?>
 <p:presentation xmlns:p="http://schemas.openxmlformats.org/presentationml/2006/main">
   <p:sldMasterIdLst>
-    <p:sldMasterId xmlns:r="http://schemas.openxmlformats.org/officeDocument/2006/relationships" id="2147483648" r:id="Rcd7c15550c694192"/>
+    <p:sldMasterId xmlns:r="http://schemas.openxmlformats.org/officeDocument/2006/relationships" id="2147483648" r:id="Rfb1a74cab27f42b3"/>
   </p:sldMasterIdLst>
   <p:notesMasterIdLst>
-    <p:notesMasterId xmlns:r="http://schemas.openxmlformats.org/officeDocument/2006/relationships" r:id="R066f954fd2054f3e"/>
+    <p:notesMasterId xmlns:r="http://schemas.openxmlformats.org/officeDocument/2006/relationships" r:id="R0b3efe43e25b4219"/>
   </p:notesMasterIdLst>
   <p:sldIdLst>
-    <p:sldId xmlns:r="http://schemas.openxmlformats.org/officeDocument/2006/relationships" id="256" r:id="Rdc0ca1a2234d4406"/>
-    <p:sldId xmlns:r="http://schemas.openxmlformats.org/officeDocument/2006/relationships" id="257" r:id="Reef764a09d5943b3"/>
-    <p:sldId xmlns:r="http://schemas.openxmlformats.org/officeDocument/2006/relationships" id="258" r:id="R465c7a2b31ed4402"/>
-    <p:sldId xmlns:r="http://schemas.openxmlformats.org/officeDocument/2006/relationships" id="259" r:id="R8c93694254284f2e"/>
-    <p:sldId xmlns:r="http://schemas.openxmlformats.org/officeDocument/2006/relationships" id="260" r:id="Rcd57b6c014124ca4"/>
+    <p:sldId xmlns:r="http://schemas.openxmlformats.org/officeDocument/2006/relationships" id="256" r:id="Rcf104adae36b4049"/>
+    <p:sldId xmlns:r="http://schemas.openxmlformats.org/officeDocument/2006/relationships" id="257" r:id="R39926d04a4624de7"/>
+    <p:sldId xmlns:r="http://schemas.openxmlformats.org/officeDocument/2006/relationships" id="258" r:id="Rc90682541a5942fe"/>
+    <p:sldId xmlns:r="http://schemas.openxmlformats.org/officeDocument/2006/relationships" id="259" r:id="R08f52a4159b24347"/>
+    <p:sldId xmlns:r="http://schemas.openxmlformats.org/officeDocument/2006/relationships" id="260" r:id="Re4834e0d1c9a4bb2"/>
+    <p:sldId xmlns:r="http://schemas.openxmlformats.org/officeDocument/2006/relationships" id="261" r:id="R2cb7abaf31f2447c"/>
   </p:sldIdLst>
   <p:sldSz cx="12192000" cy="6858000"/>
   <p:notesSz cx="6858000" cy="9144000"/>
@@ -756,6 +757,76 @@
 </p:notes>
 </file>
 
+<file path=ppt/notesSlides/notesSlide6.xml><?xml version="1.0" encoding="utf-8"?>
+<p:notes xmlns:p="http://schemas.openxmlformats.org/presentationml/2006/main">
+  <p:cSld>
+    <p:spTree>
+      <p:nvGrpSpPr>
+        <p:cNvPr id="1" name=""/>
+        <p:cNvGrpSpPr/>
+        <p:nvPr/>
+      </p:nvGrpSpPr>
+      <p:grpSpPr>
+        <a:xfrm xmlns:a="http://schemas.openxmlformats.org/drawingml/2006/main"/>
+      </p:grpSpPr>
+      <p:sp>
+        <p:nvSpPr>
+          <p:cNvPr id="2" name="Slide Image Placeholder 1"/>
+          <p:cNvSpPr>
+            <a:spLocks xmlns:a="http://schemas.openxmlformats.org/drawingml/2006/main" noGrp="1"/>
+          </p:cNvSpPr>
+          <p:nvPr>
+            <p:ph type="sldImg" idx="0"/>
+          </p:nvPr>
+        </p:nvSpPr>
+        <p:spPr/>
+      </p:sp>
+      <p:sp>
+        <p:nvSpPr>
+          <p:cNvPr id="3" name="Notes Placeholder 2"/>
+          <p:cNvSpPr>
+            <a:spLocks xmlns:a="http://schemas.openxmlformats.org/drawingml/2006/main" noGrp="1"/>
+          </p:cNvSpPr>
+          <p:nvPr>
+            <p:ph type="body" idx="1"/>
+          </p:nvPr>
+        </p:nvSpPr>
+        <p:spPr/>
+        <p:txBody>
+          <a:bodyPr xmlns:a="http://schemas.openxmlformats.org/drawingml/2006/main"/>
+          <a:lstStyle xmlns:a="http://schemas.openxmlformats.org/drawingml/2006/main"/>
+          <a:p xmlns:a="http://schemas.openxmlformats.org/drawingml/2006/main">
+            <a:r>
+              <a:t>Use this slide to explain the ethical guardrails. Cover algorithmic bias, patient privacy, data governance, transparency, regulatory compliance, and responsible AI. Emphasize that the model should support human judgment rather than replace it. NHN should monitor fairness, limit access to sensitive data, validate data quality, explain score drivers, and complete compliance review before scaling.</a:t>
+            </a:r>
+          </a:p>
+        </p:txBody>
+      </p:sp>
+      <p:sp>
+        <p:nvSpPr>
+          <p:cNvPr id="4" name="Slide Number Placeholder 3"/>
+          <p:cNvSpPr>
+            <a:spLocks xmlns:a="http://schemas.openxmlformats.org/drawingml/2006/main" noGrp="1"/>
+          </p:cNvSpPr>
+          <p:nvPr>
+            <p:ph type="sldNum" idx="5"/>
+          </p:nvPr>
+        </p:nvSpPr>
+        <p:spPr/>
+        <p:txBody>
+          <a:bodyPr xmlns:a="http://schemas.openxmlformats.org/drawingml/2006/main"/>
+          <a:lstStyle xmlns:a="http://schemas.openxmlformats.org/drawingml/2006/main"/>
+          <a:p xmlns:a="http://schemas.openxmlformats.org/drawingml/2006/main"/>
+        </p:txBody>
+      </p:sp>
+    </p:spTree>
+  </p:cSld>
+  <p:clrMapOvr>
+    <a:masterClrMapping xmlns:a="http://schemas.openxmlformats.org/drawingml/2006/main"/>
+  </p:clrMapOvr>
+</p:notes>
+</file>
+
 <file path=ppt/slideLayouts/slideLayout1.xml><?xml version="1.0" encoding="utf-8"?>
 <p:sldLayout xmlns:p="http://schemas.openxmlformats.org/presentationml/2006/main" type="title">
   <p:cSld name="Title Slide">
@@ -794,7 +865,7 @@
   </p:cSld>
   <p:clrMap bg1="lt1" tx1="dk1" bg2="lt2" tx2="dk2" accent1="accent1" accent2="accent2" accent3="accent3" accent4="accent4" accent5="accent5" accent6="accent6" hlink="hlink" folHlink="folHlink"/>
   <p:sldLayoutIdLst>
-    <p:sldLayoutId xmlns:r="http://schemas.openxmlformats.org/officeDocument/2006/relationships" id="2147483649" r:id="R880a254c02cb4e24"/>
+    <p:sldLayoutId xmlns:r="http://schemas.openxmlformats.org/officeDocument/2006/relationships" id="2147483649" r:id="R53f4db76f9cb4377"/>
   </p:sldLayoutIdLst>
   <p:txStyles>
     <p:titleStyle>
@@ -2461,7 +2532,7 @@
           <p:cNvPr id="22" name="">
             <a:extLst xmlns:a="http://schemas.openxmlformats.org/drawingml/2006/main">
               <a:ext uri="{FF2B5EF4-FFF2-40B4-BE49-F238E27FC236}">
-                <a16:creationId xmlns:a16="http://schemas.microsoft.com/office/drawing/2014/main" id="{606E2580-DC82-4E07-B0F0-E1C57EE64C8C}"/>
+                <a16:creationId xmlns:a16="http://schemas.microsoft.com/office/drawing/2014/main" id="{761FD397-23F8-4A2C-8F38-F8B88E340C1F}"/>
               </a:ext>
             </a:extLst>
           </p:cNvPr>
@@ -2492,7 +2563,7 @@
           <p:cNvPr id="2" name="">
             <a:extLst xmlns:a="http://schemas.openxmlformats.org/drawingml/2006/main">
               <a:ext uri="{FF2B5EF4-FFF2-40B4-BE49-F238E27FC236}">
-                <a16:creationId xmlns:a16="http://schemas.microsoft.com/office/drawing/2014/main" id="{D695F6CE-FFE7-4BB0-B411-93D95E572BF2}"/>
+                <a16:creationId xmlns:a16="http://schemas.microsoft.com/office/drawing/2014/main" id="{48F306B6-AE6C-4805-97E9-609D36504694}"/>
               </a:ext>
             </a:extLst>
           </p:cNvPr>
@@ -2550,7 +2621,7 @@
           <p:cNvPr id="3" name="">
             <a:extLst xmlns:a="http://schemas.openxmlformats.org/drawingml/2006/main">
               <a:ext uri="{FF2B5EF4-FFF2-40B4-BE49-F238E27FC236}">
-                <a16:creationId xmlns:a16="http://schemas.microsoft.com/office/drawing/2014/main" id="{BA35BF8A-D15E-42B7-ADC8-1964916838E9}"/>
+                <a16:creationId xmlns:a16="http://schemas.microsoft.com/office/drawing/2014/main" id="{06140678-3CA4-478C-AC95-8A4F5C97B6C8}"/>
               </a:ext>
             </a:extLst>
           </p:cNvPr>
@@ -2608,7 +2679,7 @@
           <p:cNvPr id="4" name="">
             <a:extLst xmlns:a="http://schemas.openxmlformats.org/drawingml/2006/main">
               <a:ext uri="{FF2B5EF4-FFF2-40B4-BE49-F238E27FC236}">
-                <a16:creationId xmlns:a16="http://schemas.microsoft.com/office/drawing/2014/main" id="{317A2D8E-FB4B-41CC-977D-D31E5679FA66}"/>
+                <a16:creationId xmlns:a16="http://schemas.microsoft.com/office/drawing/2014/main" id="{99C94DFE-EDF2-4AC2-9F25-39A86607B59C}"/>
               </a:ext>
             </a:extLst>
           </p:cNvPr>
@@ -2648,7 +2719,7 @@
           <p:cNvPr id="5" name="">
             <a:extLst xmlns:a="http://schemas.openxmlformats.org/drawingml/2006/main">
               <a:ext uri="{FF2B5EF4-FFF2-40B4-BE49-F238E27FC236}">
-                <a16:creationId xmlns:a16="http://schemas.microsoft.com/office/drawing/2014/main" id="{3DD25391-40B4-42B2-9330-FF5DEF89F04F}"/>
+                <a16:creationId xmlns:a16="http://schemas.microsoft.com/office/drawing/2014/main" id="{6937DA1F-79BD-48C0-83AC-D52E340B90DD}"/>
               </a:ext>
             </a:extLst>
           </p:cNvPr>
@@ -2679,7 +2750,7 @@
           <p:cNvPr id="6" name="">
             <a:extLst xmlns:a="http://schemas.openxmlformats.org/drawingml/2006/main">
               <a:ext uri="{FF2B5EF4-FFF2-40B4-BE49-F238E27FC236}">
-                <a16:creationId xmlns:a16="http://schemas.microsoft.com/office/drawing/2014/main" id="{6F73BC7B-B9D4-4EAD-899C-5D46DC932898}"/>
+                <a16:creationId xmlns:a16="http://schemas.microsoft.com/office/drawing/2014/main" id="{06704897-E13C-467C-9663-DD0F9D723BEE}"/>
               </a:ext>
             </a:extLst>
           </p:cNvPr>
@@ -2737,7 +2808,7 @@
           <p:cNvPr id="7" name="">
             <a:extLst xmlns:a="http://schemas.openxmlformats.org/drawingml/2006/main">
               <a:ext uri="{FF2B5EF4-FFF2-40B4-BE49-F238E27FC236}">
-                <a16:creationId xmlns:a16="http://schemas.microsoft.com/office/drawing/2014/main" id="{1229ECF0-8451-42D1-981B-D5EAF4C59638}"/>
+                <a16:creationId xmlns:a16="http://schemas.microsoft.com/office/drawing/2014/main" id="{C4B8BCC1-5D6A-464C-8354-6F6DAB7880C1}"/>
               </a:ext>
             </a:extLst>
           </p:cNvPr>
@@ -3043,7 +3114,7 @@
           <p:cNvPr id="9" name="">
             <a:extLst xmlns:a="http://schemas.openxmlformats.org/drawingml/2006/main">
               <a:ext uri="{FF2B5EF4-FFF2-40B4-BE49-F238E27FC236}">
-                <a16:creationId xmlns:a16="http://schemas.microsoft.com/office/drawing/2014/main" id="{DD9E160F-55EA-441F-9727-52BBC96B2753}"/>
+                <a16:creationId xmlns:a16="http://schemas.microsoft.com/office/drawing/2014/main" id="{2C505739-BEFD-4034-8470-FA7D7B90B095}"/>
               </a:ext>
             </a:extLst>
           </p:cNvPr>
@@ -3101,7 +3172,7 @@
           <p:cNvPr id="10" name="">
             <a:extLst xmlns:a="http://schemas.openxmlformats.org/drawingml/2006/main">
               <a:ext uri="{FF2B5EF4-FFF2-40B4-BE49-F238E27FC236}">
-                <a16:creationId xmlns:a16="http://schemas.microsoft.com/office/drawing/2014/main" id="{296060D4-6312-4B83-A1A7-6406E585F7C6}"/>
+                <a16:creationId xmlns:a16="http://schemas.microsoft.com/office/drawing/2014/main" id="{E8ADF11A-1EC4-4D6B-AA4A-C34E73ED75DB}"/>
               </a:ext>
             </a:extLst>
           </p:cNvPr>
@@ -3170,7 +3241,7 @@
         </p:xfrm>
         <a:graphic xmlns:a="http://schemas.openxmlformats.org/drawingml/2006/main">
           <a:graphicData uri="http://schemas.openxmlformats.org/drawingml/2006/chart">
-            <c:chart xmlns:r="http://schemas.openxmlformats.org/officeDocument/2006/relationships" xmlns:c="http://schemas.openxmlformats.org/drawingml/2006/chart" r:id="Rf51abda887bb431f"/>
+            <c:chart xmlns:r="http://schemas.openxmlformats.org/officeDocument/2006/relationships" xmlns:c="http://schemas.openxmlformats.org/drawingml/2006/chart" r:id="R71b1a657f40b412a"/>
           </a:graphicData>
         </a:graphic>
       </p:graphicFrame>
@@ -3179,7 +3250,7 @@
           <p:cNvPr id="12" name="">
             <a:extLst xmlns:a="http://schemas.openxmlformats.org/drawingml/2006/main">
               <a:ext uri="{FF2B5EF4-FFF2-40B4-BE49-F238E27FC236}">
-                <a16:creationId xmlns:a16="http://schemas.microsoft.com/office/drawing/2014/main" id="{025F2AA4-4024-40D7-A0B4-4E57BA509B85}"/>
+                <a16:creationId xmlns:a16="http://schemas.microsoft.com/office/drawing/2014/main" id="{DD421EB8-D6FA-4E7D-A2C9-D8979E08555C}"/>
               </a:ext>
             </a:extLst>
           </p:cNvPr>
@@ -3237,7 +3308,7 @@
           <p:cNvPr id="13" name="">
             <a:extLst xmlns:a="http://schemas.openxmlformats.org/drawingml/2006/main">
               <a:ext uri="{FF2B5EF4-FFF2-40B4-BE49-F238E27FC236}">
-                <a16:creationId xmlns:a16="http://schemas.microsoft.com/office/drawing/2014/main" id="{357BF4C1-91BD-4BF8-B61B-6A7BF8A66FD1}"/>
+                <a16:creationId xmlns:a16="http://schemas.microsoft.com/office/drawing/2014/main" id="{ADA26561-8607-4830-A185-3B733B49A156}"/>
               </a:ext>
             </a:extLst>
           </p:cNvPr>
@@ -3268,7 +3339,7 @@
           <p:cNvPr id="14" name="">
             <a:extLst xmlns:a="http://schemas.openxmlformats.org/drawingml/2006/main">
               <a:ext uri="{FF2B5EF4-FFF2-40B4-BE49-F238E27FC236}">
-                <a16:creationId xmlns:a16="http://schemas.microsoft.com/office/drawing/2014/main" id="{BBF4EA0A-03CA-4A00-84B9-417595EE7D36}"/>
+                <a16:creationId xmlns:a16="http://schemas.microsoft.com/office/drawing/2014/main" id="{917CB7C0-BA19-4239-ADBD-EA1D1AD8F5A5}"/>
               </a:ext>
             </a:extLst>
           </p:cNvPr>
@@ -3796,7 +3867,7 @@
           <p:cNvPr id="16" name="">
             <a:extLst xmlns:a="http://schemas.openxmlformats.org/drawingml/2006/main">
               <a:ext uri="{FF2B5EF4-FFF2-40B4-BE49-F238E27FC236}">
-                <a16:creationId xmlns:a16="http://schemas.microsoft.com/office/drawing/2014/main" id="{A860BB2A-D996-43B3-B649-2838410A85BA}"/>
+                <a16:creationId xmlns:a16="http://schemas.microsoft.com/office/drawing/2014/main" id="{062C0834-9A97-4FF7-BEBC-D1A11AB868AF}"/>
               </a:ext>
             </a:extLst>
           </p:cNvPr>
@@ -3854,7 +3925,7 @@
           <p:cNvPr id="17" name="">
             <a:extLst xmlns:a="http://schemas.openxmlformats.org/drawingml/2006/main">
               <a:ext uri="{FF2B5EF4-FFF2-40B4-BE49-F238E27FC236}">
-                <a16:creationId xmlns:a16="http://schemas.microsoft.com/office/drawing/2014/main" id="{CC4E949B-6F6B-4269-B210-EF22F5D4694D}"/>
+                <a16:creationId xmlns:a16="http://schemas.microsoft.com/office/drawing/2014/main" id="{CD12F4B1-7B7D-4EA4-A2ED-07AFE926FCE5}"/>
               </a:ext>
             </a:extLst>
           </p:cNvPr>
@@ -4009,7 +4080,7 @@
           <p:cNvPr id="18" name="">
             <a:extLst xmlns:a="http://schemas.openxmlformats.org/drawingml/2006/main">
               <a:ext uri="{FF2B5EF4-FFF2-40B4-BE49-F238E27FC236}">
-                <a16:creationId xmlns:a16="http://schemas.microsoft.com/office/drawing/2014/main" id="{460ED8ED-FAB3-4AEF-B93A-4C9A379C29EC}"/>
+                <a16:creationId xmlns:a16="http://schemas.microsoft.com/office/drawing/2014/main" id="{1DE5D3CD-409A-40AD-A1B2-6B18A003E651}"/>
               </a:ext>
             </a:extLst>
           </p:cNvPr>
@@ -4067,7 +4138,7 @@
           <p:cNvPr id="19" name="">
             <a:extLst xmlns:a="http://schemas.openxmlformats.org/drawingml/2006/main">
               <a:ext uri="{FF2B5EF4-FFF2-40B4-BE49-F238E27FC236}">
-                <a16:creationId xmlns:a16="http://schemas.microsoft.com/office/drawing/2014/main" id="{CCDFDF6E-5126-4C40-A56F-F5EAF3109DBD}"/>
+                <a16:creationId xmlns:a16="http://schemas.microsoft.com/office/drawing/2014/main" id="{D57D933F-E82D-4FAD-87A5-2DACB8E9C52D}"/>
               </a:ext>
             </a:extLst>
           </p:cNvPr>
@@ -4129,7 +4200,7 @@
           <p:cNvPr id="20" name="">
             <a:extLst xmlns:a="http://schemas.openxmlformats.org/drawingml/2006/main">
               <a:ext uri="{FF2B5EF4-FFF2-40B4-BE49-F238E27FC236}">
-                <a16:creationId xmlns:a16="http://schemas.microsoft.com/office/drawing/2014/main" id="{A89D705D-D518-4A90-96A5-001EE77B71E7}"/>
+                <a16:creationId xmlns:a16="http://schemas.microsoft.com/office/drawing/2014/main" id="{FA6718B7-B101-41C0-B4A2-47A42B5C0457}"/>
               </a:ext>
             </a:extLst>
           </p:cNvPr>
@@ -4191,7 +4262,7 @@
           <p:cNvPr id="21" name="">
             <a:extLst xmlns:a="http://schemas.openxmlformats.org/drawingml/2006/main">
               <a:ext uri="{FF2B5EF4-FFF2-40B4-BE49-F238E27FC236}">
-                <a16:creationId xmlns:a16="http://schemas.microsoft.com/office/drawing/2014/main" id="{92DB43B1-54DB-484D-AF20-025EFFF5CAE3}"/>
+                <a16:creationId xmlns:a16="http://schemas.microsoft.com/office/drawing/2014/main" id="{711533EF-B046-4EF8-A36D-5F62924C8E4E}"/>
               </a:ext>
             </a:extLst>
           </p:cNvPr>
@@ -4247,7 +4318,7 @@
     </p:spTree>
     <p:extLst>
       <p:ext uri="{BB962C8B-B14F-4D97-AF65-F5344CB8AC3E}">
-        <p14:creationId xmlns:p14="http://schemas.microsoft.com/office/powerpoint/2010/main" val="1410948838"/>
+        <p14:creationId xmlns:p14="http://schemas.microsoft.com/office/powerpoint/2010/main" val="352484974"/>
       </p:ext>
     </p:extLst>
   </p:cSld>
@@ -4278,7 +4349,7 @@
           <p:cNvPr id="21" name="">
             <a:extLst xmlns:a="http://schemas.openxmlformats.org/drawingml/2006/main">
               <a:ext uri="{FF2B5EF4-FFF2-40B4-BE49-F238E27FC236}">
-                <a16:creationId xmlns:a16="http://schemas.microsoft.com/office/drawing/2014/main" id="{898D0177-C3E3-4EB0-89A1-1641E9F5DF1B}"/>
+                <a16:creationId xmlns:a16="http://schemas.microsoft.com/office/drawing/2014/main" id="{2C992B24-B45D-4E3E-998C-ED6744F82102}"/>
               </a:ext>
             </a:extLst>
           </p:cNvPr>
@@ -4309,7 +4380,7 @@
           <p:cNvPr id="2" name="">
             <a:extLst xmlns:a="http://schemas.openxmlformats.org/drawingml/2006/main">
               <a:ext uri="{FF2B5EF4-FFF2-40B4-BE49-F238E27FC236}">
-                <a16:creationId xmlns:a16="http://schemas.microsoft.com/office/drawing/2014/main" id="{03746EF9-4F03-4EF6-9988-14E903B1DF37}"/>
+                <a16:creationId xmlns:a16="http://schemas.microsoft.com/office/drawing/2014/main" id="{10BFFFF8-C585-490E-BDCF-470CE5905FB1}"/>
               </a:ext>
             </a:extLst>
           </p:cNvPr>
@@ -4367,7 +4438,7 @@
           <p:cNvPr id="3" name="">
             <a:extLst xmlns:a="http://schemas.openxmlformats.org/drawingml/2006/main">
               <a:ext uri="{FF2B5EF4-FFF2-40B4-BE49-F238E27FC236}">
-                <a16:creationId xmlns:a16="http://schemas.microsoft.com/office/drawing/2014/main" id="{DB15A1B3-5E2F-41B8-A15A-E6FE61617BD0}"/>
+                <a16:creationId xmlns:a16="http://schemas.microsoft.com/office/drawing/2014/main" id="{9B75E905-B243-4CCE-8326-A2F4E13B7895}"/>
               </a:ext>
             </a:extLst>
           </p:cNvPr>
@@ -4425,7 +4496,7 @@
           <p:cNvPr id="4" name="">
             <a:extLst xmlns:a="http://schemas.openxmlformats.org/drawingml/2006/main">
               <a:ext uri="{FF2B5EF4-FFF2-40B4-BE49-F238E27FC236}">
-                <a16:creationId xmlns:a16="http://schemas.microsoft.com/office/drawing/2014/main" id="{BF0795ED-11BC-4B40-9B36-5208B807505B}"/>
+                <a16:creationId xmlns:a16="http://schemas.microsoft.com/office/drawing/2014/main" id="{40A71C43-F2C3-48DC-BACA-1304F8E54FD4}"/>
               </a:ext>
             </a:extLst>
           </p:cNvPr>
@@ -4483,7 +4554,7 @@
           <p:cNvPr id="5" name="">
             <a:extLst xmlns:a="http://schemas.openxmlformats.org/drawingml/2006/main">
               <a:ext uri="{FF2B5EF4-FFF2-40B4-BE49-F238E27FC236}">
-                <a16:creationId xmlns:a16="http://schemas.microsoft.com/office/drawing/2014/main" id="{5C4D61CF-651D-49FE-AEEA-68B48B734BA8}"/>
+                <a16:creationId xmlns:a16="http://schemas.microsoft.com/office/drawing/2014/main" id="{119C03ED-45C7-4F64-AAEE-16E49A398D66}"/>
               </a:ext>
             </a:extLst>
           </p:cNvPr>
@@ -4758,7 +4829,7 @@
           <p:cNvPr id="7" name="">
             <a:extLst xmlns:a="http://schemas.openxmlformats.org/drawingml/2006/main">
               <a:ext uri="{FF2B5EF4-FFF2-40B4-BE49-F238E27FC236}">
-                <a16:creationId xmlns:a16="http://schemas.microsoft.com/office/drawing/2014/main" id="{F0402867-5A24-4721-B439-3AF9D7A10B37}"/>
+                <a16:creationId xmlns:a16="http://schemas.microsoft.com/office/drawing/2014/main" id="{737CD51D-86A7-4726-91A8-A8C8E26FB28F}"/>
               </a:ext>
             </a:extLst>
           </p:cNvPr>
@@ -4789,7 +4860,7 @@
           <p:cNvPr id="8" name="">
             <a:extLst xmlns:a="http://schemas.openxmlformats.org/drawingml/2006/main">
               <a:ext uri="{FF2B5EF4-FFF2-40B4-BE49-F238E27FC236}">
-                <a16:creationId xmlns:a16="http://schemas.microsoft.com/office/drawing/2014/main" id="{8FCBBE16-C64C-41B3-8CC4-3ED12B27CA9F}"/>
+                <a16:creationId xmlns:a16="http://schemas.microsoft.com/office/drawing/2014/main" id="{0B9B01B2-4020-4876-B94A-B75A8B792B3B}"/>
               </a:ext>
             </a:extLst>
           </p:cNvPr>
@@ -5368,7 +5439,7 @@
           <p:cNvPr id="10" name="">
             <a:extLst xmlns:a="http://schemas.openxmlformats.org/drawingml/2006/main">
               <a:ext uri="{FF2B5EF4-FFF2-40B4-BE49-F238E27FC236}">
-                <a16:creationId xmlns:a16="http://schemas.microsoft.com/office/drawing/2014/main" id="{AF50E18D-9567-4659-8FCF-F72B84B1D65E}"/>
+                <a16:creationId xmlns:a16="http://schemas.microsoft.com/office/drawing/2014/main" id="{B436F182-3CF5-4418-AE64-D3ED4B29B5DE}"/>
               </a:ext>
             </a:extLst>
           </p:cNvPr>
@@ -5430,7 +5501,7 @@
           <p:cNvPr id="11" name="">
             <a:extLst xmlns:a="http://schemas.openxmlformats.org/drawingml/2006/main">
               <a:ext uri="{FF2B5EF4-FFF2-40B4-BE49-F238E27FC236}">
-                <a16:creationId xmlns:a16="http://schemas.microsoft.com/office/drawing/2014/main" id="{304F1B4E-2614-4BBD-91B6-E6E221F688C6}"/>
+                <a16:creationId xmlns:a16="http://schemas.microsoft.com/office/drawing/2014/main" id="{C34A03FA-A052-4F35-BD6B-D08F88D31724}"/>
               </a:ext>
             </a:extLst>
           </p:cNvPr>
@@ -5495,7 +5566,7 @@
         </p:xfrm>
         <a:graphic xmlns:a="http://schemas.openxmlformats.org/drawingml/2006/main">
           <a:graphicData uri="http://schemas.openxmlformats.org/drawingml/2006/chart">
-            <c:chart xmlns:r="http://schemas.openxmlformats.org/officeDocument/2006/relationships" xmlns:c="http://schemas.openxmlformats.org/drawingml/2006/chart" r:id="R7a90cc35ad0f46be"/>
+            <c:chart xmlns:r="http://schemas.openxmlformats.org/officeDocument/2006/relationships" xmlns:c="http://schemas.openxmlformats.org/drawingml/2006/chart" r:id="R8ea86c02046349e2"/>
           </a:graphicData>
         </a:graphic>
       </p:graphicFrame>
@@ -5504,7 +5575,7 @@
           <p:cNvPr id="13" name="">
             <a:extLst xmlns:a="http://schemas.openxmlformats.org/drawingml/2006/main">
               <a:ext uri="{FF2B5EF4-FFF2-40B4-BE49-F238E27FC236}">
-                <a16:creationId xmlns:a16="http://schemas.microsoft.com/office/drawing/2014/main" id="{6E50017F-6762-45C8-BFA4-89706D5C2188}"/>
+                <a16:creationId xmlns:a16="http://schemas.microsoft.com/office/drawing/2014/main" id="{07DCB189-0F3A-4446-83C9-23FC462C90C1}"/>
               </a:ext>
             </a:extLst>
           </p:cNvPr>
@@ -5562,7 +5633,7 @@
           <p:cNvPr id="14" name="">
             <a:extLst xmlns:a="http://schemas.openxmlformats.org/drawingml/2006/main">
               <a:ext uri="{FF2B5EF4-FFF2-40B4-BE49-F238E27FC236}">
-                <a16:creationId xmlns:a16="http://schemas.microsoft.com/office/drawing/2014/main" id="{F4D1B179-7E99-4138-9009-1553E0EAB6A9}"/>
+                <a16:creationId xmlns:a16="http://schemas.microsoft.com/office/drawing/2014/main" id="{EC566AD2-193B-4761-AD8D-043CE07707DF}"/>
               </a:ext>
             </a:extLst>
           </p:cNvPr>
@@ -5627,7 +5698,7 @@
         </p:xfrm>
         <a:graphic xmlns:a="http://schemas.openxmlformats.org/drawingml/2006/main">
           <a:graphicData uri="http://schemas.openxmlformats.org/drawingml/2006/chart">
-            <c:chart xmlns:r="http://schemas.openxmlformats.org/officeDocument/2006/relationships" xmlns:c="http://schemas.openxmlformats.org/drawingml/2006/chart" r:id="Re82274e37e864c11"/>
+            <c:chart xmlns:r="http://schemas.openxmlformats.org/officeDocument/2006/relationships" xmlns:c="http://schemas.openxmlformats.org/drawingml/2006/chart" r:id="Rb05de982f991453d"/>
           </a:graphicData>
         </a:graphic>
       </p:graphicFrame>
@@ -5636,7 +5707,7 @@
           <p:cNvPr id="16" name="">
             <a:extLst xmlns:a="http://schemas.openxmlformats.org/drawingml/2006/main">
               <a:ext uri="{FF2B5EF4-FFF2-40B4-BE49-F238E27FC236}">
-                <a16:creationId xmlns:a16="http://schemas.microsoft.com/office/drawing/2014/main" id="{34921299-E135-4E8F-B1E6-48EA37BB534C}"/>
+                <a16:creationId xmlns:a16="http://schemas.microsoft.com/office/drawing/2014/main" id="{AB9A9B50-E5FB-4894-82FB-146B472BEA7E}"/>
               </a:ext>
             </a:extLst>
           </p:cNvPr>
@@ -5698,7 +5769,7 @@
           <p:cNvPr id="17" name="">
             <a:extLst xmlns:a="http://schemas.openxmlformats.org/drawingml/2006/main">
               <a:ext uri="{FF2B5EF4-FFF2-40B4-BE49-F238E27FC236}">
-                <a16:creationId xmlns:a16="http://schemas.microsoft.com/office/drawing/2014/main" id="{7540CB38-5626-417E-8D5F-E226F235290E}"/>
+                <a16:creationId xmlns:a16="http://schemas.microsoft.com/office/drawing/2014/main" id="{D780C389-DF2B-4223-B62E-7EE1EFAD1FC8}"/>
               </a:ext>
             </a:extLst>
           </p:cNvPr>
@@ -5729,7 +5800,7 @@
           <p:cNvPr id="18" name="">
             <a:extLst xmlns:a="http://schemas.openxmlformats.org/drawingml/2006/main">
               <a:ext uri="{FF2B5EF4-FFF2-40B4-BE49-F238E27FC236}">
-                <a16:creationId xmlns:a16="http://schemas.microsoft.com/office/drawing/2014/main" id="{2E3D65CC-E374-4074-9DB2-8B2A02F63556}"/>
+                <a16:creationId xmlns:a16="http://schemas.microsoft.com/office/drawing/2014/main" id="{68882C27-19E0-47FE-A770-021C6B1B7890}"/>
               </a:ext>
             </a:extLst>
           </p:cNvPr>
@@ -5787,7 +5858,7 @@
           <p:cNvPr id="19" name="">
             <a:extLst xmlns:a="http://schemas.openxmlformats.org/drawingml/2006/main">
               <a:ext uri="{FF2B5EF4-FFF2-40B4-BE49-F238E27FC236}">
-                <a16:creationId xmlns:a16="http://schemas.microsoft.com/office/drawing/2014/main" id="{08946074-F8F0-4F6A-A346-7B47FEF48D5F}"/>
+                <a16:creationId xmlns:a16="http://schemas.microsoft.com/office/drawing/2014/main" id="{A06E7242-0202-49EB-8AC9-F9DFB099F10A}"/>
               </a:ext>
             </a:extLst>
           </p:cNvPr>
@@ -5845,7 +5916,7 @@
           <p:cNvPr id="20" name="">
             <a:extLst xmlns:a="http://schemas.openxmlformats.org/drawingml/2006/main">
               <a:ext uri="{FF2B5EF4-FFF2-40B4-BE49-F238E27FC236}">
-                <a16:creationId xmlns:a16="http://schemas.microsoft.com/office/drawing/2014/main" id="{423DB0D5-DD70-44FB-8C46-F60FA4B6EB37}"/>
+                <a16:creationId xmlns:a16="http://schemas.microsoft.com/office/drawing/2014/main" id="{0D005E9F-97EA-4B34-A49B-212B84B6FFDF}"/>
               </a:ext>
             </a:extLst>
           </p:cNvPr>
@@ -5901,7 +5972,7 @@
     </p:spTree>
     <p:extLst>
       <p:ext uri="{BB962C8B-B14F-4D97-AF65-F5344CB8AC3E}">
-        <p14:creationId xmlns:p14="http://schemas.microsoft.com/office/powerpoint/2010/main" val="24911965"/>
+        <p14:creationId xmlns:p14="http://schemas.microsoft.com/office/powerpoint/2010/main" val="852660667"/>
       </p:ext>
     </p:extLst>
   </p:cSld>
@@ -5932,7 +6003,7 @@
           <p:cNvPr id="28" name="">
             <a:extLst xmlns:a="http://schemas.openxmlformats.org/drawingml/2006/main">
               <a:ext uri="{FF2B5EF4-FFF2-40B4-BE49-F238E27FC236}">
-                <a16:creationId xmlns:a16="http://schemas.microsoft.com/office/drawing/2014/main" id="{3EADE791-1FCA-4A7C-988A-DC66C7251EC9}"/>
+                <a16:creationId xmlns:a16="http://schemas.microsoft.com/office/drawing/2014/main" id="{2BEC2C06-D455-404C-B742-94BD777453D6}"/>
               </a:ext>
             </a:extLst>
           </p:cNvPr>
@@ -5963,7 +6034,7 @@
           <p:cNvPr id="2" name="">
             <a:extLst xmlns:a="http://schemas.openxmlformats.org/drawingml/2006/main">
               <a:ext uri="{FF2B5EF4-FFF2-40B4-BE49-F238E27FC236}">
-                <a16:creationId xmlns:a16="http://schemas.microsoft.com/office/drawing/2014/main" id="{C62B1A9E-7F6D-4B86-A424-C21C7BBB629A}"/>
+                <a16:creationId xmlns:a16="http://schemas.microsoft.com/office/drawing/2014/main" id="{4EDF17CC-2D62-4387-BA08-AFE779B5A792}"/>
               </a:ext>
             </a:extLst>
           </p:cNvPr>
@@ -6021,7 +6092,7 @@
           <p:cNvPr id="3" name="">
             <a:extLst xmlns:a="http://schemas.openxmlformats.org/drawingml/2006/main">
               <a:ext uri="{FF2B5EF4-FFF2-40B4-BE49-F238E27FC236}">
-                <a16:creationId xmlns:a16="http://schemas.microsoft.com/office/drawing/2014/main" id="{0A5B2C4E-923B-4B81-B483-499EA8D9BDBD}"/>
+                <a16:creationId xmlns:a16="http://schemas.microsoft.com/office/drawing/2014/main" id="{3B4082C0-5C62-4E14-822E-37D44C240B1C}"/>
               </a:ext>
             </a:extLst>
           </p:cNvPr>
@@ -6079,7 +6150,7 @@
           <p:cNvPr id="4" name="">
             <a:extLst xmlns:a="http://schemas.openxmlformats.org/drawingml/2006/main">
               <a:ext uri="{FF2B5EF4-FFF2-40B4-BE49-F238E27FC236}">
-                <a16:creationId xmlns:a16="http://schemas.microsoft.com/office/drawing/2014/main" id="{1203CE1E-4D56-475E-9673-1A7FE053537D}"/>
+                <a16:creationId xmlns:a16="http://schemas.microsoft.com/office/drawing/2014/main" id="{129CBD98-8737-4C7A-9CF6-619CC41E3EE7}"/>
               </a:ext>
             </a:extLst>
           </p:cNvPr>
@@ -6137,7 +6208,7 @@
           <p:cNvPr id="5" name="">
             <a:extLst xmlns:a="http://schemas.openxmlformats.org/drawingml/2006/main">
               <a:ext uri="{FF2B5EF4-FFF2-40B4-BE49-F238E27FC236}">
-                <a16:creationId xmlns:a16="http://schemas.microsoft.com/office/drawing/2014/main" id="{A6EE068A-C9F2-41F6-89E5-9887CCA81EF2}"/>
+                <a16:creationId xmlns:a16="http://schemas.microsoft.com/office/drawing/2014/main" id="{6A9E2481-CCDA-4CEF-9422-D5BB5B35FA9E}"/>
               </a:ext>
             </a:extLst>
           </p:cNvPr>
@@ -6168,7 +6239,7 @@
           <p:cNvPr id="6" name="">
             <a:extLst xmlns:a="http://schemas.openxmlformats.org/drawingml/2006/main">
               <a:ext uri="{FF2B5EF4-FFF2-40B4-BE49-F238E27FC236}">
-                <a16:creationId xmlns:a16="http://schemas.microsoft.com/office/drawing/2014/main" id="{0F68A4D7-1511-47C5-B98A-5CFF9F121F1B}"/>
+                <a16:creationId xmlns:a16="http://schemas.microsoft.com/office/drawing/2014/main" id="{11F5E836-1FA9-4339-A3B3-B0C3A7D8A6E8}"/>
               </a:ext>
             </a:extLst>
           </p:cNvPr>
@@ -6226,7 +6297,7 @@
           <p:cNvPr id="7" name="">
             <a:extLst xmlns:a="http://schemas.openxmlformats.org/drawingml/2006/main">
               <a:ext uri="{FF2B5EF4-FFF2-40B4-BE49-F238E27FC236}">
-                <a16:creationId xmlns:a16="http://schemas.microsoft.com/office/drawing/2014/main" id="{08ED6BDF-493D-4FCB-A28B-9EC8837C158B}"/>
+                <a16:creationId xmlns:a16="http://schemas.microsoft.com/office/drawing/2014/main" id="{3D81B3D2-B6F3-4F20-A6FE-9385420C315D}"/>
               </a:ext>
             </a:extLst>
           </p:cNvPr>
@@ -6288,7 +6359,7 @@
           <p:cNvPr id="8" name="">
             <a:extLst xmlns:a="http://schemas.openxmlformats.org/drawingml/2006/main">
               <a:ext uri="{FF2B5EF4-FFF2-40B4-BE49-F238E27FC236}">
-                <a16:creationId xmlns:a16="http://schemas.microsoft.com/office/drawing/2014/main" id="{0A991127-B45B-483F-98FC-4A96A61FFC40}"/>
+                <a16:creationId xmlns:a16="http://schemas.microsoft.com/office/drawing/2014/main" id="{4C0378CB-E2A9-4E06-972F-7D4E45225B71}"/>
               </a:ext>
             </a:extLst>
           </p:cNvPr>
@@ -6353,7 +6424,7 @@
         </p:xfrm>
         <a:graphic xmlns:a="http://schemas.openxmlformats.org/drawingml/2006/main">
           <a:graphicData uri="http://schemas.openxmlformats.org/drawingml/2006/chart">
-            <c:chart xmlns:r="http://schemas.openxmlformats.org/officeDocument/2006/relationships" xmlns:c="http://schemas.openxmlformats.org/drawingml/2006/chart" r:id="R716022696a6246de"/>
+            <c:chart xmlns:r="http://schemas.openxmlformats.org/officeDocument/2006/relationships" xmlns:c="http://schemas.openxmlformats.org/drawingml/2006/chart" r:id="Rcbaef17b9677406e"/>
           </a:graphicData>
         </a:graphic>
       </p:graphicFrame>
@@ -6362,7 +6433,7 @@
           <p:cNvPr id="10" name="">
             <a:extLst xmlns:a="http://schemas.openxmlformats.org/drawingml/2006/main">
               <a:ext uri="{FF2B5EF4-FFF2-40B4-BE49-F238E27FC236}">
-                <a16:creationId xmlns:a16="http://schemas.microsoft.com/office/drawing/2014/main" id="{9F538C61-6FC7-482C-9ECC-10192492928A}"/>
+                <a16:creationId xmlns:a16="http://schemas.microsoft.com/office/drawing/2014/main" id="{7230D23D-2EE6-451D-82D6-AD1A84F51097}"/>
               </a:ext>
             </a:extLst>
           </p:cNvPr>
@@ -6424,7 +6495,7 @@
           <p:cNvPr id="11" name="">
             <a:extLst xmlns:a="http://schemas.openxmlformats.org/drawingml/2006/main">
               <a:ext uri="{FF2B5EF4-FFF2-40B4-BE49-F238E27FC236}">
-                <a16:creationId xmlns:a16="http://schemas.microsoft.com/office/drawing/2014/main" id="{2271EDD3-C45B-4EEC-B8CD-D084362188B1}"/>
+                <a16:creationId xmlns:a16="http://schemas.microsoft.com/office/drawing/2014/main" id="{6C49B6BA-C1A5-433A-8C0D-83FBAC2220F3}"/>
               </a:ext>
             </a:extLst>
           </p:cNvPr>
@@ -6455,7 +6526,7 @@
           <p:cNvPr id="12" name="">
             <a:extLst xmlns:a="http://schemas.openxmlformats.org/drawingml/2006/main">
               <a:ext uri="{FF2B5EF4-FFF2-40B4-BE49-F238E27FC236}">
-                <a16:creationId xmlns:a16="http://schemas.microsoft.com/office/drawing/2014/main" id="{21175F49-C34F-43B6-ADF3-C9D0DEF5B36B}"/>
+                <a16:creationId xmlns:a16="http://schemas.microsoft.com/office/drawing/2014/main" id="{71B13C54-A78B-40DD-B303-2E03D3C0C14A}"/>
               </a:ext>
             </a:extLst>
           </p:cNvPr>
@@ -6513,7 +6584,7 @@
           <p:cNvPr id="13" name="">
             <a:extLst xmlns:a="http://schemas.openxmlformats.org/drawingml/2006/main">
               <a:ext uri="{FF2B5EF4-FFF2-40B4-BE49-F238E27FC236}">
-                <a16:creationId xmlns:a16="http://schemas.microsoft.com/office/drawing/2014/main" id="{2BB8C7A8-1FDC-4845-AC98-00098DA2C9AF}"/>
+                <a16:creationId xmlns:a16="http://schemas.microsoft.com/office/drawing/2014/main" id="{4D293ADD-8B8B-4436-8061-9E00B2BA4732}"/>
               </a:ext>
             </a:extLst>
           </p:cNvPr>
@@ -6571,7 +6642,7 @@
           <p:cNvPr id="14" name="">
             <a:extLst xmlns:a="http://schemas.openxmlformats.org/drawingml/2006/main">
               <a:ext uri="{FF2B5EF4-FFF2-40B4-BE49-F238E27FC236}">
-                <a16:creationId xmlns:a16="http://schemas.microsoft.com/office/drawing/2014/main" id="{3978C81A-23E4-4917-AB16-737364BFCA3D}"/>
+                <a16:creationId xmlns:a16="http://schemas.microsoft.com/office/drawing/2014/main" id="{D18474EB-B6B4-4200-8447-92460C693870}"/>
               </a:ext>
             </a:extLst>
           </p:cNvPr>
@@ -6696,7 +6767,7 @@
           <p:cNvPr id="15" name="">
             <a:extLst xmlns:a="http://schemas.openxmlformats.org/drawingml/2006/main">
               <a:ext uri="{FF2B5EF4-FFF2-40B4-BE49-F238E27FC236}">
-                <a16:creationId xmlns:a16="http://schemas.microsoft.com/office/drawing/2014/main" id="{43C6B7AC-73B0-4103-9A11-AD2EC8185C5E}"/>
+                <a16:creationId xmlns:a16="http://schemas.microsoft.com/office/drawing/2014/main" id="{64190CFF-FF2A-4042-A944-5C6D9E3AEC61}"/>
               </a:ext>
             </a:extLst>
           </p:cNvPr>
@@ -6758,7 +6829,7 @@
           <p:cNvPr id="16" name="">
             <a:extLst xmlns:a="http://schemas.openxmlformats.org/drawingml/2006/main">
               <a:ext uri="{FF2B5EF4-FFF2-40B4-BE49-F238E27FC236}">
-                <a16:creationId xmlns:a16="http://schemas.microsoft.com/office/drawing/2014/main" id="{EA5E3F6E-1498-4AC3-A39A-06E139489B49}"/>
+                <a16:creationId xmlns:a16="http://schemas.microsoft.com/office/drawing/2014/main" id="{CA146623-A236-49C4-9963-C475FB24F6BB}"/>
               </a:ext>
             </a:extLst>
           </p:cNvPr>
@@ -6816,7 +6887,7 @@
           <p:cNvPr id="17" name="">
             <a:extLst xmlns:a="http://schemas.openxmlformats.org/drawingml/2006/main">
               <a:ext uri="{FF2B5EF4-FFF2-40B4-BE49-F238E27FC236}">
-                <a16:creationId xmlns:a16="http://schemas.microsoft.com/office/drawing/2014/main" id="{3F464F23-1D9B-4382-9352-425347C15E34}"/>
+                <a16:creationId xmlns:a16="http://schemas.microsoft.com/office/drawing/2014/main" id="{4560A8C5-BA3D-4B68-9DC3-54731498E7D9}"/>
               </a:ext>
             </a:extLst>
           </p:cNvPr>
@@ -6874,7 +6945,7 @@
           <p:cNvPr id="18" name="">
             <a:extLst xmlns:a="http://schemas.openxmlformats.org/drawingml/2006/main">
               <a:ext uri="{FF2B5EF4-FFF2-40B4-BE49-F238E27FC236}">
-                <a16:creationId xmlns:a16="http://schemas.microsoft.com/office/drawing/2014/main" id="{30B5F5CF-462A-48A1-A639-05B451F5FDF7}"/>
+                <a16:creationId xmlns:a16="http://schemas.microsoft.com/office/drawing/2014/main" id="{39A2071B-6214-48CB-B0D0-3DC5A8C0B9E8}"/>
               </a:ext>
             </a:extLst>
           </p:cNvPr>
@@ -6999,7 +7070,7 @@
           <p:cNvPr id="19" name="">
             <a:extLst xmlns:a="http://schemas.openxmlformats.org/drawingml/2006/main">
               <a:ext uri="{FF2B5EF4-FFF2-40B4-BE49-F238E27FC236}">
-                <a16:creationId xmlns:a16="http://schemas.microsoft.com/office/drawing/2014/main" id="{DACDED6B-8DC5-45F1-83E1-264326CD2B8A}"/>
+                <a16:creationId xmlns:a16="http://schemas.microsoft.com/office/drawing/2014/main" id="{041311B8-3BBA-4A14-8D11-06A955C2E6D2}"/>
               </a:ext>
             </a:extLst>
           </p:cNvPr>
@@ -7061,7 +7132,7 @@
           <p:cNvPr id="20" name="">
             <a:extLst xmlns:a="http://schemas.openxmlformats.org/drawingml/2006/main">
               <a:ext uri="{FF2B5EF4-FFF2-40B4-BE49-F238E27FC236}">
-                <a16:creationId xmlns:a16="http://schemas.microsoft.com/office/drawing/2014/main" id="{30DAE800-9A6B-49A3-87AB-ABA14BE843F7}"/>
+                <a16:creationId xmlns:a16="http://schemas.microsoft.com/office/drawing/2014/main" id="{95129B28-90D8-496C-8D5C-A69802405CA7}"/>
               </a:ext>
             </a:extLst>
           </p:cNvPr>
@@ -7119,7 +7190,7 @@
           <p:cNvPr id="21" name="">
             <a:extLst xmlns:a="http://schemas.openxmlformats.org/drawingml/2006/main">
               <a:ext uri="{FF2B5EF4-FFF2-40B4-BE49-F238E27FC236}">
-                <a16:creationId xmlns:a16="http://schemas.microsoft.com/office/drawing/2014/main" id="{D68C96DC-62C1-4BE8-BBB8-29677AEF5BF1}"/>
+                <a16:creationId xmlns:a16="http://schemas.microsoft.com/office/drawing/2014/main" id="{756638EA-313B-4F65-BBDC-943CE99EBB46}"/>
               </a:ext>
             </a:extLst>
           </p:cNvPr>
@@ -7177,7 +7248,7 @@
           <p:cNvPr id="22" name="">
             <a:extLst xmlns:a="http://schemas.openxmlformats.org/drawingml/2006/main">
               <a:ext uri="{FF2B5EF4-FFF2-40B4-BE49-F238E27FC236}">
-                <a16:creationId xmlns:a16="http://schemas.microsoft.com/office/drawing/2014/main" id="{E2983D8D-9293-490D-B12A-34CAC20F705C}"/>
+                <a16:creationId xmlns:a16="http://schemas.microsoft.com/office/drawing/2014/main" id="{036E2EAB-D11F-4780-86DE-AAEC2257AA7E}"/>
               </a:ext>
             </a:extLst>
           </p:cNvPr>
@@ -7302,7 +7373,7 @@
           <p:cNvPr id="23" name="">
             <a:extLst xmlns:a="http://schemas.openxmlformats.org/drawingml/2006/main">
               <a:ext uri="{FF2B5EF4-FFF2-40B4-BE49-F238E27FC236}">
-                <a16:creationId xmlns:a16="http://schemas.microsoft.com/office/drawing/2014/main" id="{2887F7E1-1D91-46BF-B490-6E743004FB37}"/>
+                <a16:creationId xmlns:a16="http://schemas.microsoft.com/office/drawing/2014/main" id="{35701518-FBB2-4F4C-9E52-965D068D3C22}"/>
               </a:ext>
             </a:extLst>
           </p:cNvPr>
@@ -7364,7 +7435,7 @@
           <p:cNvPr id="24" name="">
             <a:extLst xmlns:a="http://schemas.openxmlformats.org/drawingml/2006/main">
               <a:ext uri="{FF2B5EF4-FFF2-40B4-BE49-F238E27FC236}">
-                <a16:creationId xmlns:a16="http://schemas.microsoft.com/office/drawing/2014/main" id="{9FA2D58A-A98E-4FBF-9C39-185CECEFE8E5}"/>
+                <a16:creationId xmlns:a16="http://schemas.microsoft.com/office/drawing/2014/main" id="{E3678DD3-F914-4D96-9454-DF265CD67AA3}"/>
               </a:ext>
             </a:extLst>
           </p:cNvPr>
@@ -7395,7 +7466,7 @@
           <p:cNvPr id="25" name="">
             <a:extLst xmlns:a="http://schemas.openxmlformats.org/drawingml/2006/main">
               <a:ext uri="{FF2B5EF4-FFF2-40B4-BE49-F238E27FC236}">
-                <a16:creationId xmlns:a16="http://schemas.microsoft.com/office/drawing/2014/main" id="{A9112A8D-E5F5-4168-A75C-10A3C0991098}"/>
+                <a16:creationId xmlns:a16="http://schemas.microsoft.com/office/drawing/2014/main" id="{451304E9-80CB-4D00-BA77-CA11327E680D}"/>
               </a:ext>
             </a:extLst>
           </p:cNvPr>
@@ -7453,7 +7524,7 @@
           <p:cNvPr id="26" name="">
             <a:extLst xmlns:a="http://schemas.openxmlformats.org/drawingml/2006/main">
               <a:ext uri="{FF2B5EF4-FFF2-40B4-BE49-F238E27FC236}">
-                <a16:creationId xmlns:a16="http://schemas.microsoft.com/office/drawing/2014/main" id="{7F5B5CCC-364B-4DA0-AAA3-ED4AB7153E94}"/>
+                <a16:creationId xmlns:a16="http://schemas.microsoft.com/office/drawing/2014/main" id="{EA459DAF-536E-4A9D-8678-2CF25EDB4A0C}"/>
               </a:ext>
             </a:extLst>
           </p:cNvPr>
@@ -7511,7 +7582,7 @@
           <p:cNvPr id="27" name="">
             <a:extLst xmlns:a="http://schemas.openxmlformats.org/drawingml/2006/main">
               <a:ext uri="{FF2B5EF4-FFF2-40B4-BE49-F238E27FC236}">
-                <a16:creationId xmlns:a16="http://schemas.microsoft.com/office/drawing/2014/main" id="{354E71C7-99A9-414B-8D9F-9169CE2F9253}"/>
+                <a16:creationId xmlns:a16="http://schemas.microsoft.com/office/drawing/2014/main" id="{2A902717-B4C6-43F1-AA3E-78D76DE62C24}"/>
               </a:ext>
             </a:extLst>
           </p:cNvPr>
@@ -7567,7 +7638,7 @@
     </p:spTree>
     <p:extLst>
       <p:ext uri="{BB962C8B-B14F-4D97-AF65-F5344CB8AC3E}">
-        <p14:creationId xmlns:p14="http://schemas.microsoft.com/office/powerpoint/2010/main" val="1325649716"/>
+        <p14:creationId xmlns:p14="http://schemas.microsoft.com/office/powerpoint/2010/main" val="1317530066"/>
       </p:ext>
     </p:extLst>
   </p:cSld>
@@ -7598,7 +7669,7 @@
           <p:cNvPr id="19" name="">
             <a:extLst xmlns:a="http://schemas.openxmlformats.org/drawingml/2006/main">
               <a:ext uri="{FF2B5EF4-FFF2-40B4-BE49-F238E27FC236}">
-                <a16:creationId xmlns:a16="http://schemas.microsoft.com/office/drawing/2014/main" id="{D418F832-8C4E-49EB-91EE-AF7AA7D0FC66}"/>
+                <a16:creationId xmlns:a16="http://schemas.microsoft.com/office/drawing/2014/main" id="{B3D4C214-34C9-484E-AFEB-9101A9155F35}"/>
               </a:ext>
             </a:extLst>
           </p:cNvPr>
@@ -7629,7 +7700,7 @@
           <p:cNvPr id="2" name="">
             <a:extLst xmlns:a="http://schemas.openxmlformats.org/drawingml/2006/main">
               <a:ext uri="{FF2B5EF4-FFF2-40B4-BE49-F238E27FC236}">
-                <a16:creationId xmlns:a16="http://schemas.microsoft.com/office/drawing/2014/main" id="{FFC5D0AD-BAE6-4C80-AF50-258E710168EA}"/>
+                <a16:creationId xmlns:a16="http://schemas.microsoft.com/office/drawing/2014/main" id="{32CBC757-B798-4920-9D43-62F1250D9C47}"/>
               </a:ext>
             </a:extLst>
           </p:cNvPr>
@@ -7687,7 +7758,7 @@
           <p:cNvPr id="3" name="">
             <a:extLst xmlns:a="http://schemas.openxmlformats.org/drawingml/2006/main">
               <a:ext uri="{FF2B5EF4-FFF2-40B4-BE49-F238E27FC236}">
-                <a16:creationId xmlns:a16="http://schemas.microsoft.com/office/drawing/2014/main" id="{488BF421-9871-4B88-83DB-4AD77F72E603}"/>
+                <a16:creationId xmlns:a16="http://schemas.microsoft.com/office/drawing/2014/main" id="{B72A5697-6BDB-4132-8992-3258EEAEA223}"/>
               </a:ext>
             </a:extLst>
           </p:cNvPr>
@@ -7745,7 +7816,7 @@
           <p:cNvPr id="4" name="">
             <a:extLst xmlns:a="http://schemas.openxmlformats.org/drawingml/2006/main">
               <a:ext uri="{FF2B5EF4-FFF2-40B4-BE49-F238E27FC236}">
-                <a16:creationId xmlns:a16="http://schemas.microsoft.com/office/drawing/2014/main" id="{D20119AB-EF87-4B3B-ADD8-24B640561BCD}"/>
+                <a16:creationId xmlns:a16="http://schemas.microsoft.com/office/drawing/2014/main" id="{F1C6A4A2-15D1-4F50-A1A6-7582087CBA60}"/>
               </a:ext>
             </a:extLst>
           </p:cNvPr>
@@ -7803,7 +7874,7 @@
           <p:cNvPr id="5" name="">
             <a:extLst xmlns:a="http://schemas.openxmlformats.org/drawingml/2006/main">
               <a:ext uri="{FF2B5EF4-FFF2-40B4-BE49-F238E27FC236}">
-                <a16:creationId xmlns:a16="http://schemas.microsoft.com/office/drawing/2014/main" id="{D359FF68-50C9-4C88-9FD3-95D442FAD55A}"/>
+                <a16:creationId xmlns:a16="http://schemas.microsoft.com/office/drawing/2014/main" id="{705DC09C-E104-408F-B854-24551A555AF4}"/>
               </a:ext>
             </a:extLst>
           </p:cNvPr>
@@ -7834,7 +7905,7 @@
           <p:cNvPr id="6" name="">
             <a:extLst xmlns:a="http://schemas.openxmlformats.org/drawingml/2006/main">
               <a:ext uri="{FF2B5EF4-FFF2-40B4-BE49-F238E27FC236}">
-                <a16:creationId xmlns:a16="http://schemas.microsoft.com/office/drawing/2014/main" id="{9724C9DA-8D45-40BA-8899-9AD22F4E6A88}"/>
+                <a16:creationId xmlns:a16="http://schemas.microsoft.com/office/drawing/2014/main" id="{FA4D050D-6808-4B49-956A-168C114D415C}"/>
               </a:ext>
             </a:extLst>
           </p:cNvPr>
@@ -7899,7 +7970,7 @@
         </p:xfrm>
         <a:graphic xmlns:a="http://schemas.openxmlformats.org/drawingml/2006/main">
           <a:graphicData uri="http://schemas.openxmlformats.org/drawingml/2006/chart">
-            <c:chart xmlns:r="http://schemas.openxmlformats.org/officeDocument/2006/relationships" xmlns:c="http://schemas.openxmlformats.org/drawingml/2006/chart" r:id="Ra677d170313b4d00"/>
+            <c:chart xmlns:r="http://schemas.openxmlformats.org/officeDocument/2006/relationships" xmlns:c="http://schemas.openxmlformats.org/drawingml/2006/chart" r:id="Rb4364b8ffc6949da"/>
           </a:graphicData>
         </a:graphic>
       </p:graphicFrame>
@@ -7908,7 +7979,7 @@
           <p:cNvPr id="8" name="">
             <a:extLst xmlns:a="http://schemas.openxmlformats.org/drawingml/2006/main">
               <a:ext uri="{FF2B5EF4-FFF2-40B4-BE49-F238E27FC236}">
-                <a16:creationId xmlns:a16="http://schemas.microsoft.com/office/drawing/2014/main" id="{FEB35BCE-EA0F-4657-8098-A3209ECA7A0F}"/>
+                <a16:creationId xmlns:a16="http://schemas.microsoft.com/office/drawing/2014/main" id="{8173FA8F-9740-435A-B6DA-1ECEC7292499}"/>
               </a:ext>
             </a:extLst>
           </p:cNvPr>
@@ -7970,7 +8041,7 @@
           <p:cNvPr id="9" name="">
             <a:extLst xmlns:a="http://schemas.openxmlformats.org/drawingml/2006/main">
               <a:ext uri="{FF2B5EF4-FFF2-40B4-BE49-F238E27FC236}">
-                <a16:creationId xmlns:a16="http://schemas.microsoft.com/office/drawing/2014/main" id="{7DBDB3D8-65EE-4B99-8923-808FE515D47C}"/>
+                <a16:creationId xmlns:a16="http://schemas.microsoft.com/office/drawing/2014/main" id="{4B002680-AD93-44D3-9BEE-0F5805AD57C0}"/>
               </a:ext>
             </a:extLst>
           </p:cNvPr>
@@ -8492,7 +8563,7 @@
           <p:cNvPr id="11" name="">
             <a:extLst xmlns:a="http://schemas.openxmlformats.org/drawingml/2006/main">
               <a:ext uri="{FF2B5EF4-FFF2-40B4-BE49-F238E27FC236}">
-                <a16:creationId xmlns:a16="http://schemas.microsoft.com/office/drawing/2014/main" id="{70141F9B-25FF-4272-80D7-A78A6CE6B3D8}"/>
+                <a16:creationId xmlns:a16="http://schemas.microsoft.com/office/drawing/2014/main" id="{EEF208B3-4B07-4A97-9646-B3A34EC838FD}"/>
               </a:ext>
             </a:extLst>
           </p:cNvPr>
@@ -8554,7 +8625,7 @@
           <p:cNvPr id="12" name="">
             <a:extLst xmlns:a="http://schemas.openxmlformats.org/drawingml/2006/main">
               <a:ext uri="{FF2B5EF4-FFF2-40B4-BE49-F238E27FC236}">
-                <a16:creationId xmlns:a16="http://schemas.microsoft.com/office/drawing/2014/main" id="{17F5E38B-9048-47A5-9558-DF69DAD92E74}"/>
+                <a16:creationId xmlns:a16="http://schemas.microsoft.com/office/drawing/2014/main" id="{12B55DC2-769C-4B94-9EE9-F063A8525FB8}"/>
               </a:ext>
             </a:extLst>
           </p:cNvPr>
@@ -8585,7 +8656,7 @@
           <p:cNvPr id="13" name="">
             <a:extLst xmlns:a="http://schemas.openxmlformats.org/drawingml/2006/main">
               <a:ext uri="{FF2B5EF4-FFF2-40B4-BE49-F238E27FC236}">
-                <a16:creationId xmlns:a16="http://schemas.microsoft.com/office/drawing/2014/main" id="{8662FF9B-24A5-4284-820F-511330003451}"/>
+                <a16:creationId xmlns:a16="http://schemas.microsoft.com/office/drawing/2014/main" id="{019C6DB1-6FAF-4EAE-B80B-DEC9A683A27A}"/>
               </a:ext>
             </a:extLst>
           </p:cNvPr>
@@ -8945,7 +9016,7 @@
           <p:cNvPr id="15" name="">
             <a:extLst xmlns:a="http://schemas.openxmlformats.org/drawingml/2006/main">
               <a:ext uri="{FF2B5EF4-FFF2-40B4-BE49-F238E27FC236}">
-                <a16:creationId xmlns:a16="http://schemas.microsoft.com/office/drawing/2014/main" id="{E99F4089-A559-4A3D-BE81-07B51AFEAC37}"/>
+                <a16:creationId xmlns:a16="http://schemas.microsoft.com/office/drawing/2014/main" id="{E161ECBF-7D1A-4949-BCD4-D96919240D4D}"/>
               </a:ext>
             </a:extLst>
           </p:cNvPr>
@@ -9249,7 +9320,7 @@
           <p:cNvPr id="17" name="">
             <a:extLst xmlns:a="http://schemas.openxmlformats.org/drawingml/2006/main">
               <a:ext uri="{FF2B5EF4-FFF2-40B4-BE49-F238E27FC236}">
-                <a16:creationId xmlns:a16="http://schemas.microsoft.com/office/drawing/2014/main" id="{AAF01B1A-DB38-45B6-8C46-8799B8DEC9B8}"/>
+                <a16:creationId xmlns:a16="http://schemas.microsoft.com/office/drawing/2014/main" id="{13459459-2CAC-451C-AB37-5DD8383D2CC0}"/>
               </a:ext>
             </a:extLst>
           </p:cNvPr>
@@ -9311,7 +9382,7 @@
           <p:cNvPr id="18" name="">
             <a:extLst xmlns:a="http://schemas.openxmlformats.org/drawingml/2006/main">
               <a:ext uri="{FF2B5EF4-FFF2-40B4-BE49-F238E27FC236}">
-                <a16:creationId xmlns:a16="http://schemas.microsoft.com/office/drawing/2014/main" id="{B4FCBF8A-1B64-48D5-80F5-D2091AE58358}"/>
+                <a16:creationId xmlns:a16="http://schemas.microsoft.com/office/drawing/2014/main" id="{77BF4164-A657-4391-B84D-7C043FBE7E3F}"/>
               </a:ext>
             </a:extLst>
           </p:cNvPr>
@@ -9367,7 +9438,7 @@
     </p:spTree>
     <p:extLst>
       <p:ext uri="{BB962C8B-B14F-4D97-AF65-F5344CB8AC3E}">
-        <p14:creationId xmlns:p14="http://schemas.microsoft.com/office/powerpoint/2010/main" val="2009785202"/>
+        <p14:creationId xmlns:p14="http://schemas.microsoft.com/office/powerpoint/2010/main" val="1069441159"/>
       </p:ext>
     </p:extLst>
   </p:cSld>
@@ -9398,7 +9469,7 @@
           <p:cNvPr id="20" name="">
             <a:extLst xmlns:a="http://schemas.openxmlformats.org/drawingml/2006/main">
               <a:ext uri="{FF2B5EF4-FFF2-40B4-BE49-F238E27FC236}">
-                <a16:creationId xmlns:a16="http://schemas.microsoft.com/office/drawing/2014/main" id="{434465A5-A768-47DD-A79E-0A597E436147}"/>
+                <a16:creationId xmlns:a16="http://schemas.microsoft.com/office/drawing/2014/main" id="{2DA68AC4-1C6A-4136-910B-77DBD54739A4}"/>
               </a:ext>
             </a:extLst>
           </p:cNvPr>
@@ -9429,7 +9500,7 @@
           <p:cNvPr id="2" name="">
             <a:extLst xmlns:a="http://schemas.openxmlformats.org/drawingml/2006/main">
               <a:ext uri="{FF2B5EF4-FFF2-40B4-BE49-F238E27FC236}">
-                <a16:creationId xmlns:a16="http://schemas.microsoft.com/office/drawing/2014/main" id="{F025EBC5-6356-437A-92F2-46F298D46C69}"/>
+                <a16:creationId xmlns:a16="http://schemas.microsoft.com/office/drawing/2014/main" id="{7AC182F5-669D-4616-AAEC-2714D3386DFE}"/>
               </a:ext>
             </a:extLst>
           </p:cNvPr>
@@ -9487,7 +9558,7 @@
           <p:cNvPr id="3" name="">
             <a:extLst xmlns:a="http://schemas.openxmlformats.org/drawingml/2006/main">
               <a:ext uri="{FF2B5EF4-FFF2-40B4-BE49-F238E27FC236}">
-                <a16:creationId xmlns:a16="http://schemas.microsoft.com/office/drawing/2014/main" id="{7778A4DC-B196-4AE4-99CA-48658A4D2B08}"/>
+                <a16:creationId xmlns:a16="http://schemas.microsoft.com/office/drawing/2014/main" id="{FE960C77-F85D-4AA9-9EC4-387E4D0259E4}"/>
               </a:ext>
             </a:extLst>
           </p:cNvPr>
@@ -9545,7 +9616,7 @@
           <p:cNvPr id="4" name="">
             <a:extLst xmlns:a="http://schemas.openxmlformats.org/drawingml/2006/main">
               <a:ext uri="{FF2B5EF4-FFF2-40B4-BE49-F238E27FC236}">
-                <a16:creationId xmlns:a16="http://schemas.microsoft.com/office/drawing/2014/main" id="{7DD75931-C767-4409-BF72-15DCAA2A81B9}"/>
+                <a16:creationId xmlns:a16="http://schemas.microsoft.com/office/drawing/2014/main" id="{23049776-850A-4756-83DD-7259E9E9B105}"/>
               </a:ext>
             </a:extLst>
           </p:cNvPr>
@@ -9603,7 +9674,7 @@
           <p:cNvPr id="5" name="">
             <a:extLst xmlns:a="http://schemas.openxmlformats.org/drawingml/2006/main">
               <a:ext uri="{FF2B5EF4-FFF2-40B4-BE49-F238E27FC236}">
-                <a16:creationId xmlns:a16="http://schemas.microsoft.com/office/drawing/2014/main" id="{A8B90E13-20DF-4ADE-AD86-305D39409100}"/>
+                <a16:creationId xmlns:a16="http://schemas.microsoft.com/office/drawing/2014/main" id="{649B4C41-994F-49DA-9B4E-61B8C7713E86}"/>
               </a:ext>
             </a:extLst>
           </p:cNvPr>
@@ -9878,7 +9949,7 @@
           <p:cNvPr id="7" name="">
             <a:extLst xmlns:a="http://schemas.openxmlformats.org/drawingml/2006/main">
               <a:ext uri="{FF2B5EF4-FFF2-40B4-BE49-F238E27FC236}">
-                <a16:creationId xmlns:a16="http://schemas.microsoft.com/office/drawing/2014/main" id="{EFD793B9-EC11-4558-BB92-248F53980688}"/>
+                <a16:creationId xmlns:a16="http://schemas.microsoft.com/office/drawing/2014/main" id="{1CBB179B-531F-4894-B771-4B629902B4EA}"/>
               </a:ext>
             </a:extLst>
           </p:cNvPr>
@@ -9909,7 +9980,7 @@
           <p:cNvPr id="8" name="">
             <a:extLst xmlns:a="http://schemas.openxmlformats.org/drawingml/2006/main">
               <a:ext uri="{FF2B5EF4-FFF2-40B4-BE49-F238E27FC236}">
-                <a16:creationId xmlns:a16="http://schemas.microsoft.com/office/drawing/2014/main" id="{78BB5B85-1EF3-48A7-8770-807CF1D0E530}"/>
+                <a16:creationId xmlns:a16="http://schemas.microsoft.com/office/drawing/2014/main" id="{7E790A05-8A4B-4574-9B29-1E3235F17792}"/>
               </a:ext>
             </a:extLst>
           </p:cNvPr>
@@ -10651,7 +10722,7 @@
           <p:cNvPr id="10" name="">
             <a:extLst xmlns:a="http://schemas.openxmlformats.org/drawingml/2006/main">
               <a:ext uri="{FF2B5EF4-FFF2-40B4-BE49-F238E27FC236}">
-                <a16:creationId xmlns:a16="http://schemas.microsoft.com/office/drawing/2014/main" id="{63391FE7-E85D-41AA-89C6-9A8E933530F6}"/>
+                <a16:creationId xmlns:a16="http://schemas.microsoft.com/office/drawing/2014/main" id="{6FF90696-BFBD-45B7-8D0D-8DFB2B45A574}"/>
               </a:ext>
             </a:extLst>
           </p:cNvPr>
@@ -10955,7 +11026,7 @@
           <p:cNvPr id="12" name="">
             <a:extLst xmlns:a="http://schemas.openxmlformats.org/drawingml/2006/main">
               <a:ext uri="{FF2B5EF4-FFF2-40B4-BE49-F238E27FC236}">
-                <a16:creationId xmlns:a16="http://schemas.microsoft.com/office/drawing/2014/main" id="{488F6F33-4A2D-47C5-9D04-DC7DCF41CF25}"/>
+                <a16:creationId xmlns:a16="http://schemas.microsoft.com/office/drawing/2014/main" id="{8CA4AD52-0599-424D-832E-397953DAA0DD}"/>
               </a:ext>
             </a:extLst>
           </p:cNvPr>
@@ -11013,7 +11084,7 @@
           <p:cNvPr id="13" name="">
             <a:extLst xmlns:a="http://schemas.openxmlformats.org/drawingml/2006/main">
               <a:ext uri="{FF2B5EF4-FFF2-40B4-BE49-F238E27FC236}">
-                <a16:creationId xmlns:a16="http://schemas.microsoft.com/office/drawing/2014/main" id="{87D342A4-5AB4-4CB4-A209-9F4FF5EBD699}"/>
+                <a16:creationId xmlns:a16="http://schemas.microsoft.com/office/drawing/2014/main" id="{42615C7B-D428-4338-A448-C332E2CC856F}"/>
               </a:ext>
             </a:extLst>
           </p:cNvPr>
@@ -11138,7 +11209,7 @@
           <p:cNvPr id="14" name="">
             <a:extLst xmlns:a="http://schemas.openxmlformats.org/drawingml/2006/main">
               <a:ext uri="{FF2B5EF4-FFF2-40B4-BE49-F238E27FC236}">
-                <a16:creationId xmlns:a16="http://schemas.microsoft.com/office/drawing/2014/main" id="{5A7250E2-C6AB-47AC-9AF0-6A33CAE42449}"/>
+                <a16:creationId xmlns:a16="http://schemas.microsoft.com/office/drawing/2014/main" id="{7D502137-E1F4-46AA-99CC-75553F78EFEB}"/>
               </a:ext>
             </a:extLst>
           </p:cNvPr>
@@ -11169,7 +11240,7 @@
           <p:cNvPr id="15" name="">
             <a:extLst xmlns:a="http://schemas.openxmlformats.org/drawingml/2006/main">
               <a:ext uri="{FF2B5EF4-FFF2-40B4-BE49-F238E27FC236}">
-                <a16:creationId xmlns:a16="http://schemas.microsoft.com/office/drawing/2014/main" id="{5BC093EE-2BEE-4430-8417-50FFC986DE31}"/>
+                <a16:creationId xmlns:a16="http://schemas.microsoft.com/office/drawing/2014/main" id="{A8A6C2C6-6EDA-4435-AFCC-2A9BF331B7A7}"/>
               </a:ext>
             </a:extLst>
           </p:cNvPr>
@@ -11227,7 +11298,7 @@
           <p:cNvPr id="16" name="">
             <a:extLst xmlns:a="http://schemas.openxmlformats.org/drawingml/2006/main">
               <a:ext uri="{FF2B5EF4-FFF2-40B4-BE49-F238E27FC236}">
-                <a16:creationId xmlns:a16="http://schemas.microsoft.com/office/drawing/2014/main" id="{146FBC89-3FC5-446D-88D3-4C48526936E0}"/>
+                <a16:creationId xmlns:a16="http://schemas.microsoft.com/office/drawing/2014/main" id="{2E393652-C618-435F-84B0-A3677BA440A1}"/>
               </a:ext>
             </a:extLst>
           </p:cNvPr>
@@ -11289,7 +11360,7 @@
           <p:cNvPr id="17" name="">
             <a:extLst xmlns:a="http://schemas.openxmlformats.org/drawingml/2006/main">
               <a:ext uri="{FF2B5EF4-FFF2-40B4-BE49-F238E27FC236}">
-                <a16:creationId xmlns:a16="http://schemas.microsoft.com/office/drawing/2014/main" id="{C6818857-0A5A-482E-B5C4-E1C0CE787E4D}"/>
+                <a16:creationId xmlns:a16="http://schemas.microsoft.com/office/drawing/2014/main" id="{DD025197-A676-471C-A238-B30D1555F012}"/>
               </a:ext>
             </a:extLst>
           </p:cNvPr>
@@ -11347,7 +11418,7 @@
           <p:cNvPr id="18" name="">
             <a:extLst xmlns:a="http://schemas.openxmlformats.org/drawingml/2006/main">
               <a:ext uri="{FF2B5EF4-FFF2-40B4-BE49-F238E27FC236}">
-                <a16:creationId xmlns:a16="http://schemas.microsoft.com/office/drawing/2014/main" id="{F965EFF2-8506-47A3-A657-B2CC74A86D78}"/>
+                <a16:creationId xmlns:a16="http://schemas.microsoft.com/office/drawing/2014/main" id="{9196152F-0B38-417F-9F02-2D8C6B08AC02}"/>
               </a:ext>
             </a:extLst>
           </p:cNvPr>
@@ -11409,7 +11480,7 @@
           <p:cNvPr id="19" name="">
             <a:extLst xmlns:a="http://schemas.openxmlformats.org/drawingml/2006/main">
               <a:ext uri="{FF2B5EF4-FFF2-40B4-BE49-F238E27FC236}">
-                <a16:creationId xmlns:a16="http://schemas.microsoft.com/office/drawing/2014/main" id="{96232CFD-CE51-4E9D-B431-35717D83FAEE}"/>
+                <a16:creationId xmlns:a16="http://schemas.microsoft.com/office/drawing/2014/main" id="{E534B10B-F879-4A7F-A06B-F14B4CFE7B6C}"/>
               </a:ext>
             </a:extLst>
           </p:cNvPr>
@@ -11465,7 +11536,2081 @@
     </p:spTree>
     <p:extLst>
       <p:ext uri="{BB962C8B-B14F-4D97-AF65-F5344CB8AC3E}">
-        <p14:creationId xmlns:p14="http://schemas.microsoft.com/office/powerpoint/2010/main" val="1285780456"/>
+        <p14:creationId xmlns:p14="http://schemas.microsoft.com/office/powerpoint/2010/main" val="1226686319"/>
+      </p:ext>
+    </p:extLst>
+  </p:cSld>
+</p:sld>
+</file>
+
+<file path=ppt/slides/slide6.xml><?xml version="1.0" encoding="utf-8"?>
+<p:sld xmlns:p="http://schemas.openxmlformats.org/presentationml/2006/main">
+  <p:cSld>
+    <p:bg>
+      <p:bgPr>
+        <a:solidFill xmlns:a="http://schemas.openxmlformats.org/drawingml/2006/main">
+          <a:srgbClr val="F8FBFC"/>
+        </a:solidFill>
+      </p:bgPr>
+    </p:bg>
+    <p:spTree>
+      <p:nvGrpSpPr>
+        <p:cNvPr id="1" name=""/>
+        <p:cNvGrpSpPr/>
+        <p:nvPr/>
+      </p:nvGrpSpPr>
+      <p:grpSpPr>
+        <a:xfrm xmlns:a="http://schemas.openxmlformats.org/drawingml/2006/main"/>
+      </p:grpSpPr>
+      <p:sp>
+        <p:nvSpPr>
+          <p:cNvPr id="20" name="">
+            <a:extLst xmlns:a="http://schemas.openxmlformats.org/drawingml/2006/main">
+              <a:ext uri="{FF2B5EF4-FFF2-40B4-BE49-F238E27FC236}">
+                <a16:creationId xmlns:a16="http://schemas.microsoft.com/office/drawing/2014/main" id="{844F0E27-85F4-43CD-8C30-929AE0074503}"/>
+              </a:ext>
+            </a:extLst>
+          </p:cNvPr>
+          <p:cNvSpPr>
+            <a:spLocks xmlns:a="http://schemas.openxmlformats.org/drawingml/2006/main" noGrp="1"/>
+          </p:cNvSpPr>
+          <p:nvPr/>
+        </p:nvSpPr>
+        <p:spPr>
+          <a:xfrm xmlns:a="http://schemas.openxmlformats.org/drawingml/2006/main">
+            <a:off x="0" y="0"/>
+            <a:ext cx="12192000" cy="152400"/>
+          </a:xfrm>
+          <a:prstGeom xmlns:a="http://schemas.openxmlformats.org/drawingml/2006/main" prst="rect">
+            <a:avLst/>
+          </a:prstGeom>
+          <a:solidFill xmlns:a="http://schemas.openxmlformats.org/drawingml/2006/main">
+            <a:srgbClr val="0F4C5C"/>
+          </a:solidFill>
+          <a:ln xmlns:a="http://schemas.openxmlformats.org/drawingml/2006/main" w="0">
+            <a:noFill/>
+            <a:prstDash val="solid"/>
+          </a:ln>
+        </p:spPr>
+      </p:sp>
+      <p:sp>
+        <p:nvSpPr>
+          <p:cNvPr id="2" name="">
+            <a:extLst xmlns:a="http://schemas.openxmlformats.org/drawingml/2006/main">
+              <a:ext uri="{FF2B5EF4-FFF2-40B4-BE49-F238E27FC236}">
+                <a16:creationId xmlns:a16="http://schemas.microsoft.com/office/drawing/2014/main" id="{B0F4797B-4FD0-468E-863E-D71E13D5F721}"/>
+              </a:ext>
+            </a:extLst>
+          </p:cNvPr>
+          <p:cNvSpPr>
+            <a:spLocks xmlns:a="http://schemas.openxmlformats.org/drawingml/2006/main" noGrp="1"/>
+          </p:cNvSpPr>
+          <p:nvPr/>
+        </p:nvSpPr>
+        <p:spPr>
+          <a:xfrm xmlns:a="http://schemas.openxmlformats.org/drawingml/2006/main">
+            <a:off x="514350" y="361950"/>
+            <a:ext cx="3429000" cy="247650"/>
+          </a:xfrm>
+          <a:prstGeom xmlns:a="http://schemas.openxmlformats.org/drawingml/2006/main" prst="rect">
+            <a:avLst/>
+          </a:prstGeom>
+          <a:noFill xmlns:a="http://schemas.openxmlformats.org/drawingml/2006/main"/>
+          <a:ln xmlns:a="http://schemas.openxmlformats.org/drawingml/2006/main" w="0">
+            <a:noFill/>
+            <a:prstDash val="solid"/>
+          </a:ln>
+        </p:spPr>
+        <p:txBody>
+          <a:bodyPr xmlns:a="http://schemas.openxmlformats.org/drawingml/2006/main" lIns="0" tIns="0" rIns="0" bIns="0">
+            <a:noAutofit/>
+          </a:bodyPr>
+          <a:lstStyle xmlns:a="http://schemas.openxmlformats.org/drawingml/2006/main"/>
+          <a:p xmlns:a="http://schemas.openxmlformats.org/drawingml/2006/main">
+            <a:pPr>
+              <a:defRPr sz="1275" b="1">
+                <a:solidFill>
+                  <a:srgbClr val="0F6F73"/>
+                </a:solidFill>
+                <a:latin typeface="Helvetica Neue"/>
+                <a:ea typeface="Helvetica Neue"/>
+                <a:cs typeface="Helvetica Neue"/>
+              </a:defRPr>
+            </a:pPr>
+            <a:r>
+              <a:rPr sz="1275" b="1">
+                <a:solidFill>
+                  <a:srgbClr val="0F6F73"/>
+                </a:solidFill>
+                <a:latin typeface="Helvetica Neue"/>
+                <a:ea typeface="Helvetica Neue"/>
+                <a:cs typeface="Helvetica Neue"/>
+              </a:rPr>
+              <a:t>Meds Counsulting LLC</a:t>
+            </a:r>
+          </a:p>
+        </p:txBody>
+      </p:sp>
+      <p:sp>
+        <p:nvSpPr>
+          <p:cNvPr id="3" name="">
+            <a:extLst xmlns:a="http://schemas.openxmlformats.org/drawingml/2006/main">
+              <a:ext uri="{FF2B5EF4-FFF2-40B4-BE49-F238E27FC236}">
+                <a16:creationId xmlns:a16="http://schemas.microsoft.com/office/drawing/2014/main" id="{F37653A4-E3CB-4B0A-9253-1A89651C6D06}"/>
+              </a:ext>
+            </a:extLst>
+          </p:cNvPr>
+          <p:cNvSpPr>
+            <a:spLocks xmlns:a="http://schemas.openxmlformats.org/drawingml/2006/main" noGrp="1"/>
+          </p:cNvSpPr>
+          <p:nvPr/>
+        </p:nvSpPr>
+        <p:spPr>
+          <a:xfrm xmlns:a="http://schemas.openxmlformats.org/drawingml/2006/main">
+            <a:off x="514350" y="723900"/>
+            <a:ext cx="8191500" cy="457200"/>
+          </a:xfrm>
+          <a:prstGeom xmlns:a="http://schemas.openxmlformats.org/drawingml/2006/main" prst="rect">
+            <a:avLst/>
+          </a:prstGeom>
+          <a:noFill xmlns:a="http://schemas.openxmlformats.org/drawingml/2006/main"/>
+          <a:ln xmlns:a="http://schemas.openxmlformats.org/drawingml/2006/main" w="0">
+            <a:noFill/>
+            <a:prstDash val="solid"/>
+          </a:ln>
+        </p:spPr>
+        <p:txBody>
+          <a:bodyPr xmlns:a="http://schemas.openxmlformats.org/drawingml/2006/main" lIns="0" tIns="0" rIns="0" bIns="0">
+            <a:noAutofit/>
+          </a:bodyPr>
+          <a:lstStyle xmlns:a="http://schemas.openxmlformats.org/drawingml/2006/main"/>
+          <a:p xmlns:a="http://schemas.openxmlformats.org/drawingml/2006/main">
+            <a:pPr>
+              <a:defRPr sz="2700" b="1">
+                <a:solidFill>
+                  <a:srgbClr val="102A34"/>
+                </a:solidFill>
+                <a:latin typeface="Helvetica Neue"/>
+                <a:ea typeface="Helvetica Neue"/>
+                <a:cs typeface="Helvetica Neue"/>
+              </a:defRPr>
+            </a:pPr>
+            <a:r>
+              <a:rPr sz="2700" b="1">
+                <a:solidFill>
+                  <a:srgbClr val="102A34"/>
+                </a:solidFill>
+                <a:latin typeface="Helvetica Neue"/>
+                <a:ea typeface="Helvetica Neue"/>
+                <a:cs typeface="Helvetica Neue"/>
+              </a:rPr>
+              <a:t>Ethical considerations</a:t>
+            </a:r>
+          </a:p>
+        </p:txBody>
+      </p:sp>
+      <p:sp>
+        <p:nvSpPr>
+          <p:cNvPr id="4" name="">
+            <a:extLst xmlns:a="http://schemas.openxmlformats.org/drawingml/2006/main">
+              <a:ext uri="{FF2B5EF4-FFF2-40B4-BE49-F238E27FC236}">
+                <a16:creationId xmlns:a16="http://schemas.microsoft.com/office/drawing/2014/main" id="{68E369EF-4EF2-46D1-9C58-064671C67C24}"/>
+              </a:ext>
+            </a:extLst>
+          </p:cNvPr>
+          <p:cNvSpPr>
+            <a:spLocks xmlns:a="http://schemas.openxmlformats.org/drawingml/2006/main" noGrp="1"/>
+          </p:cNvSpPr>
+          <p:nvPr/>
+        </p:nvSpPr>
+        <p:spPr>
+          <a:xfrm xmlns:a="http://schemas.openxmlformats.org/drawingml/2006/main">
+            <a:off x="514350" y="1162050"/>
+            <a:ext cx="8096250" cy="209550"/>
+          </a:xfrm>
+          <a:prstGeom xmlns:a="http://schemas.openxmlformats.org/drawingml/2006/main" prst="rect">
+            <a:avLst/>
+          </a:prstGeom>
+          <a:noFill xmlns:a="http://schemas.openxmlformats.org/drawingml/2006/main"/>
+          <a:ln xmlns:a="http://schemas.openxmlformats.org/drawingml/2006/main" w="0">
+            <a:noFill/>
+            <a:prstDash val="solid"/>
+          </a:ln>
+        </p:spPr>
+        <p:txBody>
+          <a:bodyPr xmlns:a="http://schemas.openxmlformats.org/drawingml/2006/main" lIns="0" tIns="0" rIns="0" bIns="0">
+            <a:noAutofit/>
+          </a:bodyPr>
+          <a:lstStyle xmlns:a="http://schemas.openxmlformats.org/drawingml/2006/main"/>
+          <a:p xmlns:a="http://schemas.openxmlformats.org/drawingml/2006/main">
+            <a:pPr>
+              <a:defRPr sz="1088">
+                <a:solidFill>
+                  <a:srgbClr val="50636B"/>
+                </a:solidFill>
+                <a:latin typeface="Helvetica Neue"/>
+                <a:ea typeface="Helvetica Neue"/>
+                <a:cs typeface="Helvetica Neue"/>
+              </a:defRPr>
+            </a:pPr>
+            <a:r>
+              <a:rPr sz="1088">
+                <a:solidFill>
+                  <a:srgbClr val="50636B"/>
+                </a:solidFill>
+                <a:latin typeface="Helvetica Neue"/>
+                <a:ea typeface="Helvetica Neue"/>
+                <a:cs typeface="Helvetica Neue"/>
+              </a:rPr>
+              <a:t>Guardrails for fair, private, transparent, and compliant analytics</a:t>
+            </a:r>
+          </a:p>
+        </p:txBody>
+      </p:sp>
+      <p:sp>
+        <p:nvSpPr>
+          <p:cNvPr id="5" name="">
+            <a:extLst xmlns:a="http://schemas.openxmlformats.org/drawingml/2006/main">
+              <a:ext uri="{FF2B5EF4-FFF2-40B4-BE49-F238E27FC236}">
+                <a16:creationId xmlns:a16="http://schemas.microsoft.com/office/drawing/2014/main" id="{4D29C9FA-932B-4519-BE26-92274E15B77E}"/>
+              </a:ext>
+            </a:extLst>
+          </p:cNvPr>
+          <p:cNvSpPr>
+            <a:spLocks xmlns:a="http://schemas.openxmlformats.org/drawingml/2006/main" noGrp="1"/>
+          </p:cNvSpPr>
+          <p:nvPr/>
+        </p:nvSpPr>
+        <p:spPr>
+          <a:xfrm xmlns:a="http://schemas.openxmlformats.org/drawingml/2006/main">
+            <a:off x="514350" y="1466850"/>
+            <a:ext cx="10287000" cy="28575"/>
+          </a:xfrm>
+          <a:prstGeom xmlns:a="http://schemas.openxmlformats.org/drawingml/2006/main" prst="rect">
+            <a:avLst/>
+          </a:prstGeom>
+          <a:solidFill xmlns:a="http://schemas.openxmlformats.org/drawingml/2006/main">
+            <a:srgbClr val="E9A93A"/>
+          </a:solidFill>
+          <a:ln xmlns:a="http://schemas.openxmlformats.org/drawingml/2006/main" w="0">
+            <a:noFill/>
+            <a:prstDash val="solid"/>
+          </a:ln>
+        </p:spPr>
+      </p:sp>
+      <p:graphicFrame>
+        <p:nvGraphicFramePr>
+          <p:cNvPr id="25" name=""/>
+          <p:cNvGraphicFramePr/>
+          <p:nvPr/>
+        </p:nvGraphicFramePr>
+        <p:xfrm>
+          <a:off xmlns:a="http://schemas.openxmlformats.org/drawingml/2006/main" x="514350" y="1695450"/>
+          <a:ext xmlns:a="http://schemas.openxmlformats.org/drawingml/2006/main" cx="10287000" cy="819150"/>
+        </p:xfrm>
+        <a:graphic xmlns:a="http://schemas.openxmlformats.org/drawingml/2006/main">
+          <a:graphicData uri="http://schemas.openxmlformats.org/drawingml/2006/table">
+            <a:tbl>
+              <a:tblPr/>
+              <a:tblGrid>
+                <a:gridCol w="2571750"/>
+                <a:gridCol w="2571750"/>
+                <a:gridCol w="2571750"/>
+                <a:gridCol w="2571750"/>
+              </a:tblGrid>
+              <a:tr h="409575">
+                <a:tc>
+                  <a:txBody>
+                    <a:bodyPr lIns="66675" tIns="28575" rIns="57150" bIns="28575">
+                      <a:noAutofit/>
+                    </a:bodyPr>
+                    <a:lstStyle/>
+                    <a:p>
+                      <a:pPr algn="ctr"/>
+                      <a:r>
+                        <a:rPr sz="1650" b="1">
+                          <a:solidFill>
+                            <a:srgbClr val="0F4C5C"/>
+                          </a:solidFill>
+                          <a:latin typeface="Helvetica Neue"/>
+                          <a:ea typeface="Helvetica Neue"/>
+                          <a:cs typeface="Helvetica Neue"/>
+                        </a:rPr>
+                        <a:t>Fairness</a:t>
+                      </a:r>
+                    </a:p>
+                  </a:txBody>
+                  <a:tcPr marL="91440" marR="91440" marT="45720" marB="45720" anchor="ctr">
+                    <a:solidFill>
+                      <a:srgbClr val="EEF6F7"/>
+                    </a:solidFill>
+                  </a:tcPr>
+                </a:tc>
+                <a:tc>
+                  <a:txBody>
+                    <a:bodyPr lIns="66675" tIns="28575" rIns="57150" bIns="28575">
+                      <a:noAutofit/>
+                    </a:bodyPr>
+                    <a:lstStyle/>
+                    <a:p>
+                      <a:pPr algn="ctr"/>
+                      <a:r>
+                        <a:rPr sz="1650" b="1">
+                          <a:solidFill>
+                            <a:srgbClr val="0F4C5C"/>
+                          </a:solidFill>
+                          <a:latin typeface="Helvetica Neue"/>
+                          <a:ea typeface="Helvetica Neue"/>
+                          <a:cs typeface="Helvetica Neue"/>
+                        </a:rPr>
+                        <a:t>Privacy</a:t>
+                      </a:r>
+                    </a:p>
+                  </a:txBody>
+                  <a:tcPr marL="91440" marR="91440" marT="45720" marB="45720" anchor="ctr">
+                    <a:solidFill>
+                      <a:srgbClr val="EEF6F7"/>
+                    </a:solidFill>
+                  </a:tcPr>
+                </a:tc>
+                <a:tc>
+                  <a:txBody>
+                    <a:bodyPr lIns="66675" tIns="28575" rIns="57150" bIns="28575">
+                      <a:noAutofit/>
+                    </a:bodyPr>
+                    <a:lstStyle/>
+                    <a:p>
+                      <a:pPr algn="ctr"/>
+                      <a:r>
+                        <a:rPr sz="1650" b="1">
+                          <a:solidFill>
+                            <a:srgbClr val="0F4C5C"/>
+                          </a:solidFill>
+                          <a:latin typeface="Helvetica Neue"/>
+                          <a:ea typeface="Helvetica Neue"/>
+                          <a:cs typeface="Helvetica Neue"/>
+                        </a:rPr>
+                        <a:t>Governance</a:t>
+                      </a:r>
+                    </a:p>
+                  </a:txBody>
+                  <a:tcPr marL="91440" marR="91440" marT="45720" marB="45720" anchor="ctr">
+                    <a:solidFill>
+                      <a:srgbClr val="EEF6F7"/>
+                    </a:solidFill>
+                  </a:tcPr>
+                </a:tc>
+                <a:tc>
+                  <a:txBody>
+                    <a:bodyPr lIns="66675" tIns="28575" rIns="57150" bIns="28575">
+                      <a:noAutofit/>
+                    </a:bodyPr>
+                    <a:lstStyle/>
+                    <a:p>
+                      <a:pPr algn="ctr"/>
+                      <a:r>
+                        <a:rPr sz="1650" b="1">
+                          <a:solidFill>
+                            <a:srgbClr val="0F4C5C"/>
+                          </a:solidFill>
+                          <a:latin typeface="Helvetica Neue"/>
+                          <a:ea typeface="Helvetica Neue"/>
+                          <a:cs typeface="Helvetica Neue"/>
+                        </a:rPr>
+                        <a:t>Compliance</a:t>
+                      </a:r>
+                    </a:p>
+                  </a:txBody>
+                  <a:tcPr marL="91440" marR="91440" marT="45720" marB="45720" anchor="ctr">
+                    <a:solidFill>
+                      <a:srgbClr val="EEF6F7"/>
+                    </a:solidFill>
+                  </a:tcPr>
+                </a:tc>
+              </a:tr>
+              <a:tr h="409575">
+                <a:tc>
+                  <a:txBody>
+                    <a:bodyPr lIns="66675" tIns="28575" rIns="57150" bIns="28575">
+                      <a:noAutofit/>
+                    </a:bodyPr>
+                    <a:lstStyle/>
+                    <a:p>
+                      <a:pPr algn="ctr"/>
+                      <a:r>
+                        <a:rPr sz="705" b="0">
+                          <a:solidFill>
+                            <a:srgbClr val="50636B"/>
+                          </a:solidFill>
+                          <a:latin typeface="Helvetica Neue"/>
+                          <a:ea typeface="Helvetica Neue"/>
+                          <a:cs typeface="Helvetica Neue"/>
+                        </a:rPr>
+                        <a:t>Bias checks before use</a:t>
+                      </a:r>
+                    </a:p>
+                  </a:txBody>
+                  <a:tcPr marL="91440" marR="91440" marT="45720" marB="45720" anchor="ctr">
+                    <a:solidFill>
+                      <a:srgbClr val="F8FBFC"/>
+                    </a:solidFill>
+                  </a:tcPr>
+                </a:tc>
+                <a:tc>
+                  <a:txBody>
+                    <a:bodyPr lIns="66675" tIns="28575" rIns="57150" bIns="28575">
+                      <a:noAutofit/>
+                    </a:bodyPr>
+                    <a:lstStyle/>
+                    <a:p>
+                      <a:pPr algn="ctr"/>
+                      <a:r>
+                        <a:rPr sz="705" b="0">
+                          <a:solidFill>
+                            <a:srgbClr val="50636B"/>
+                          </a:solidFill>
+                          <a:latin typeface="Helvetica Neue"/>
+                          <a:ea typeface="Helvetica Neue"/>
+                          <a:cs typeface="Helvetica Neue"/>
+                        </a:rPr>
+                        <a:t>Minimum necessary data</a:t>
+                      </a:r>
+                    </a:p>
+                  </a:txBody>
+                  <a:tcPr marL="91440" marR="91440" marT="45720" marB="45720" anchor="ctr">
+                    <a:solidFill>
+                      <a:srgbClr val="F8FBFC"/>
+                    </a:solidFill>
+                  </a:tcPr>
+                </a:tc>
+                <a:tc>
+                  <a:txBody>
+                    <a:bodyPr lIns="66675" tIns="28575" rIns="57150" bIns="28575">
+                      <a:noAutofit/>
+                    </a:bodyPr>
+                    <a:lstStyle/>
+                    <a:p>
+                      <a:pPr algn="ctr"/>
+                      <a:r>
+                        <a:rPr sz="705" b="0">
+                          <a:solidFill>
+                            <a:srgbClr val="50636B"/>
+                          </a:solidFill>
+                          <a:latin typeface="Helvetica Neue"/>
+                          <a:ea typeface="Helvetica Neue"/>
+                          <a:cs typeface="Helvetica Neue"/>
+                        </a:rPr>
+                        <a:t>Clear ownership and audit trail</a:t>
+                      </a:r>
+                    </a:p>
+                  </a:txBody>
+                  <a:tcPr marL="91440" marR="91440" marT="45720" marB="45720" anchor="ctr">
+                    <a:solidFill>
+                      <a:srgbClr val="F8FBFC"/>
+                    </a:solidFill>
+                  </a:tcPr>
+                </a:tc>
+                <a:tc>
+                  <a:txBody>
+                    <a:bodyPr lIns="66675" tIns="28575" rIns="57150" bIns="28575">
+                      <a:noAutofit/>
+                    </a:bodyPr>
+                    <a:lstStyle/>
+                    <a:p>
+                      <a:pPr algn="ctr"/>
+                      <a:r>
+                        <a:rPr sz="705" b="0">
+                          <a:solidFill>
+                            <a:srgbClr val="50636B"/>
+                          </a:solidFill>
+                          <a:latin typeface="Helvetica Neue"/>
+                          <a:ea typeface="Helvetica Neue"/>
+                          <a:cs typeface="Helvetica Neue"/>
+                        </a:rPr>
+                        <a:t>HIPAA and responsible AI review</a:t>
+                      </a:r>
+                    </a:p>
+                  </a:txBody>
+                  <a:tcPr marL="91440" marR="91440" marT="45720" marB="45720" anchor="ctr">
+                    <a:solidFill>
+                      <a:srgbClr val="F8FBFC"/>
+                    </a:solidFill>
+                  </a:tcPr>
+                </a:tc>
+              </a:tr>
+            </a:tbl>
+          </a:graphicData>
+        </a:graphic>
+      </p:graphicFrame>
+      <p:sp>
+        <p:nvSpPr>
+          <p:cNvPr id="7" name="">
+            <a:extLst xmlns:a="http://schemas.openxmlformats.org/drawingml/2006/main">
+              <a:ext uri="{FF2B5EF4-FFF2-40B4-BE49-F238E27FC236}">
+                <a16:creationId xmlns:a16="http://schemas.microsoft.com/office/drawing/2014/main" id="{6188FD4F-DF4E-4C67-A29E-BF52CB30A094}"/>
+              </a:ext>
+            </a:extLst>
+          </p:cNvPr>
+          <p:cNvSpPr>
+            <a:spLocks xmlns:a="http://schemas.openxmlformats.org/drawingml/2006/main" noGrp="1"/>
+          </p:cNvSpPr>
+          <p:nvPr/>
+        </p:nvSpPr>
+        <p:spPr>
+          <a:xfrm xmlns:a="http://schemas.openxmlformats.org/drawingml/2006/main">
+            <a:off x="514350" y="2771775"/>
+            <a:ext cx="10287000" cy="14288"/>
+          </a:xfrm>
+          <a:prstGeom xmlns:a="http://schemas.openxmlformats.org/drawingml/2006/main" prst="rect">
+            <a:avLst/>
+          </a:prstGeom>
+          <a:solidFill xmlns:a="http://schemas.openxmlformats.org/drawingml/2006/main">
+            <a:srgbClr val="D1E1E5"/>
+          </a:solidFill>
+          <a:ln xmlns:a="http://schemas.openxmlformats.org/drawingml/2006/main" w="0">
+            <a:noFill/>
+            <a:prstDash val="solid"/>
+          </a:ln>
+        </p:spPr>
+      </p:sp>
+      <p:sp>
+        <p:nvSpPr>
+          <p:cNvPr id="8" name="">
+            <a:extLst xmlns:a="http://schemas.openxmlformats.org/drawingml/2006/main">
+              <a:ext uri="{FF2B5EF4-FFF2-40B4-BE49-F238E27FC236}">
+                <a16:creationId xmlns:a16="http://schemas.microsoft.com/office/drawing/2014/main" id="{E37D7288-4E6C-4888-A188-563D09C309EA}"/>
+              </a:ext>
+            </a:extLst>
+          </p:cNvPr>
+          <p:cNvSpPr>
+            <a:spLocks xmlns:a="http://schemas.openxmlformats.org/drawingml/2006/main" noGrp="1"/>
+          </p:cNvSpPr>
+          <p:nvPr/>
+        </p:nvSpPr>
+        <p:spPr>
+          <a:xfrm xmlns:a="http://schemas.openxmlformats.org/drawingml/2006/main">
+            <a:off x="514350" y="3009900"/>
+            <a:ext cx="3143250" cy="228600"/>
+          </a:xfrm>
+          <a:prstGeom xmlns:a="http://schemas.openxmlformats.org/drawingml/2006/main" prst="rect">
+            <a:avLst/>
+          </a:prstGeom>
+          <a:noFill xmlns:a="http://schemas.openxmlformats.org/drawingml/2006/main"/>
+          <a:ln xmlns:a="http://schemas.openxmlformats.org/drawingml/2006/main" w="0">
+            <a:noFill/>
+            <a:prstDash val="solid"/>
+          </a:ln>
+        </p:spPr>
+        <p:txBody>
+          <a:bodyPr xmlns:a="http://schemas.openxmlformats.org/drawingml/2006/main" lIns="0" tIns="0" rIns="0" bIns="0">
+            <a:noAutofit/>
+          </a:bodyPr>
+          <a:lstStyle xmlns:a="http://schemas.openxmlformats.org/drawingml/2006/main"/>
+          <a:p xmlns:a="http://schemas.openxmlformats.org/drawingml/2006/main">
+            <a:pPr>
+              <a:defRPr sz="1500" b="1">
+                <a:solidFill>
+                  <a:srgbClr val="102A34"/>
+                </a:solidFill>
+                <a:latin typeface="Helvetica Neue"/>
+                <a:ea typeface="Helvetica Neue"/>
+                <a:cs typeface="Helvetica Neue"/>
+              </a:defRPr>
+            </a:pPr>
+            <a:r>
+              <a:rPr sz="1500" b="1">
+                <a:solidFill>
+                  <a:srgbClr val="102A34"/>
+                </a:solidFill>
+                <a:latin typeface="Helvetica Neue"/>
+                <a:ea typeface="Helvetica Neue"/>
+                <a:cs typeface="Helvetica Neue"/>
+              </a:rPr>
+              <a:t>Ethical risk areas</a:t>
+            </a:r>
+          </a:p>
+        </p:txBody>
+      </p:sp>
+      <p:graphicFrame>
+        <p:nvGraphicFramePr>
+          <p:cNvPr id="28" name=""/>
+          <p:cNvGraphicFramePr/>
+          <p:nvPr/>
+        </p:nvGraphicFramePr>
+        <p:xfrm>
+          <a:off xmlns:a="http://schemas.openxmlformats.org/drawingml/2006/main" x="514350" y="3362325"/>
+          <a:ext xmlns:a="http://schemas.openxmlformats.org/drawingml/2006/main" cx="6343650" cy="2000250"/>
+        </p:xfrm>
+        <a:graphic xmlns:a="http://schemas.openxmlformats.org/drawingml/2006/main">
+          <a:graphicData uri="http://schemas.openxmlformats.org/drawingml/2006/table">
+            <a:tbl>
+              <a:tblPr/>
+              <a:tblGrid>
+                <a:gridCol w="1428750"/>
+                <a:gridCol w="2781300"/>
+                <a:gridCol w="2133600"/>
+              </a:tblGrid>
+              <a:tr h="285750">
+                <a:tc>
+                  <a:txBody>
+                    <a:bodyPr lIns="66675" tIns="28575" rIns="57150" bIns="28575">
+                      <a:noAutofit/>
+                    </a:bodyPr>
+                    <a:lstStyle/>
+                    <a:p>
+                      <a:pPr algn="l"/>
+                      <a:r>
+                        <a:rPr sz="630" b="1">
+                          <a:solidFill>
+                            <a:srgbClr val="FFFFFF"/>
+                          </a:solidFill>
+                          <a:latin typeface="Helvetica Neue"/>
+                          <a:ea typeface="Helvetica Neue"/>
+                          <a:cs typeface="Helvetica Neue"/>
+                        </a:rPr>
+                        <a:t>Issue</a:t>
+                      </a:r>
+                    </a:p>
+                  </a:txBody>
+                  <a:tcPr marL="91440" marR="91440" marT="45720" marB="45720" anchor="ctr">
+                    <a:solidFill>
+                      <a:srgbClr val="0F4C5C"/>
+                    </a:solidFill>
+                  </a:tcPr>
+                </a:tc>
+                <a:tc>
+                  <a:txBody>
+                    <a:bodyPr lIns="66675" tIns="28575" rIns="57150" bIns="28575">
+                      <a:noAutofit/>
+                    </a:bodyPr>
+                    <a:lstStyle/>
+                    <a:p>
+                      <a:pPr algn="l"/>
+                      <a:r>
+                        <a:rPr sz="630" b="1">
+                          <a:solidFill>
+                            <a:srgbClr val="FFFFFF"/>
+                          </a:solidFill>
+                          <a:latin typeface="Helvetica Neue"/>
+                          <a:ea typeface="Helvetica Neue"/>
+                          <a:cs typeface="Helvetica Neue"/>
+                        </a:rPr>
+                        <a:t>Concern for NHN</a:t>
+                      </a:r>
+                    </a:p>
+                  </a:txBody>
+                  <a:tcPr marL="91440" marR="91440" marT="45720" marB="45720" anchor="ctr">
+                    <a:solidFill>
+                      <a:srgbClr val="0F4C5C"/>
+                    </a:solidFill>
+                  </a:tcPr>
+                </a:tc>
+                <a:tc>
+                  <a:txBody>
+                    <a:bodyPr lIns="66675" tIns="28575" rIns="57150" bIns="28575">
+                      <a:noAutofit/>
+                    </a:bodyPr>
+                    <a:lstStyle/>
+                    <a:p>
+                      <a:pPr algn="l"/>
+                      <a:r>
+                        <a:rPr sz="630" b="1">
+                          <a:solidFill>
+                            <a:srgbClr val="FFFFFF"/>
+                          </a:solidFill>
+                          <a:latin typeface="Helvetica Neue"/>
+                          <a:ea typeface="Helvetica Neue"/>
+                          <a:cs typeface="Helvetica Neue"/>
+                        </a:rPr>
+                        <a:t>Required control</a:t>
+                      </a:r>
+                    </a:p>
+                  </a:txBody>
+                  <a:tcPr marL="91440" marR="91440" marT="45720" marB="45720" anchor="ctr">
+                    <a:solidFill>
+                      <a:srgbClr val="0F4C5C"/>
+                    </a:solidFill>
+                  </a:tcPr>
+                </a:tc>
+              </a:tr>
+              <a:tr h="285750">
+                <a:tc>
+                  <a:txBody>
+                    <a:bodyPr lIns="66675" tIns="28575" rIns="57150" bIns="28575">
+                      <a:noAutofit/>
+                    </a:bodyPr>
+                    <a:lstStyle/>
+                    <a:p>
+                      <a:pPr algn="l"/>
+                      <a:r>
+                        <a:rPr sz="540" b="1">
+                          <a:solidFill>
+                            <a:srgbClr val="253B44"/>
+                          </a:solidFill>
+                          <a:latin typeface="Helvetica Neue"/>
+                          <a:ea typeface="Helvetica Neue"/>
+                          <a:cs typeface="Helvetica Neue"/>
+                        </a:rPr>
+                        <a:t>Algorithmic bias</a:t>
+                      </a:r>
+                    </a:p>
+                  </a:txBody>
+                  <a:tcPr marL="91440" marR="91440" marT="45720" marB="45720" anchor="ctr">
+                    <a:solidFill>
+                      <a:srgbClr val="EEF6F7"/>
+                    </a:solidFill>
+                  </a:tcPr>
+                </a:tc>
+                <a:tc>
+                  <a:txBody>
+                    <a:bodyPr lIns="66675" tIns="28575" rIns="57150" bIns="28575">
+                      <a:noAutofit/>
+                    </a:bodyPr>
+                    <a:lstStyle/>
+                    <a:p>
+                      <a:pPr algn="l"/>
+                      <a:r>
+                        <a:rPr sz="540" b="0">
+                          <a:solidFill>
+                            <a:srgbClr val="253B44"/>
+                          </a:solidFill>
+                          <a:latin typeface="Helvetica Neue"/>
+                          <a:ea typeface="Helvetica Neue"/>
+                          <a:cs typeface="Helvetica Neue"/>
+                        </a:rPr>
+                        <a:t>Risk scores may under-serve groups if past care access was unequal</a:t>
+                      </a:r>
+                    </a:p>
+                  </a:txBody>
+                  <a:tcPr marL="91440" marR="91440" marT="45720" marB="45720" anchor="ctr">
+                    <a:solidFill>
+                      <a:srgbClr val="EEF6F7"/>
+                    </a:solidFill>
+                  </a:tcPr>
+                </a:tc>
+                <a:tc>
+                  <a:txBody>
+                    <a:bodyPr lIns="66675" tIns="28575" rIns="57150" bIns="28575">
+                      <a:noAutofit/>
+                    </a:bodyPr>
+                    <a:lstStyle/>
+                    <a:p>
+                      <a:pPr algn="l"/>
+                      <a:r>
+                        <a:rPr sz="540" b="0">
+                          <a:solidFill>
+                            <a:srgbClr val="253B44"/>
+                          </a:solidFill>
+                          <a:latin typeface="Helvetica Neue"/>
+                          <a:ea typeface="Helvetica Neue"/>
+                          <a:cs typeface="Helvetica Neue"/>
+                        </a:rPr>
+                        <a:t>Monitor performance by age, diagnosis, discharge type, and insurance where appropriate</a:t>
+                      </a:r>
+                    </a:p>
+                  </a:txBody>
+                  <a:tcPr marL="91440" marR="91440" marT="45720" marB="45720" anchor="ctr">
+                    <a:solidFill>
+                      <a:srgbClr val="EEF6F7"/>
+                    </a:solidFill>
+                  </a:tcPr>
+                </a:tc>
+              </a:tr>
+              <a:tr h="285750">
+                <a:tc>
+                  <a:txBody>
+                    <a:bodyPr lIns="66675" tIns="28575" rIns="57150" bIns="28575">
+                      <a:noAutofit/>
+                    </a:bodyPr>
+                    <a:lstStyle/>
+                    <a:p>
+                      <a:pPr algn="l"/>
+                      <a:r>
+                        <a:rPr sz="540" b="1">
+                          <a:solidFill>
+                            <a:srgbClr val="253B44"/>
+                          </a:solidFill>
+                          <a:latin typeface="Helvetica Neue"/>
+                          <a:ea typeface="Helvetica Neue"/>
+                          <a:cs typeface="Helvetica Neue"/>
+                        </a:rPr>
+                        <a:t>Customer privacy</a:t>
+                      </a:r>
+                    </a:p>
+                  </a:txBody>
+                  <a:tcPr marL="91440" marR="91440" marT="45720" marB="45720" anchor="ctr">
+                    <a:solidFill>
+                      <a:srgbClr val="F8FBFC"/>
+                    </a:solidFill>
+                  </a:tcPr>
+                </a:tc>
+                <a:tc>
+                  <a:txBody>
+                    <a:bodyPr lIns="66675" tIns="28575" rIns="57150" bIns="28575">
+                      <a:noAutofit/>
+                    </a:bodyPr>
+                    <a:lstStyle/>
+                    <a:p>
+                      <a:pPr algn="l"/>
+                      <a:r>
+                        <a:rPr sz="540" b="0">
+                          <a:solidFill>
+                            <a:srgbClr val="253B44"/>
+                          </a:solidFill>
+                          <a:latin typeface="Helvetica Neue"/>
+                          <a:ea typeface="Helvetica Neue"/>
+                          <a:cs typeface="Helvetica Neue"/>
+                        </a:rPr>
+                        <a:t>Patient-level health and financial fields are sensitive</a:t>
+                      </a:r>
+                    </a:p>
+                  </a:txBody>
+                  <a:tcPr marL="91440" marR="91440" marT="45720" marB="45720" anchor="ctr">
+                    <a:solidFill>
+                      <a:srgbClr val="F8FBFC"/>
+                    </a:solidFill>
+                  </a:tcPr>
+                </a:tc>
+                <a:tc>
+                  <a:txBody>
+                    <a:bodyPr lIns="66675" tIns="28575" rIns="57150" bIns="28575">
+                      <a:noAutofit/>
+                    </a:bodyPr>
+                    <a:lstStyle/>
+                    <a:p>
+                      <a:pPr algn="l"/>
+                      <a:r>
+                        <a:rPr sz="540" b="0">
+                          <a:solidFill>
+                            <a:srgbClr val="253B44"/>
+                          </a:solidFill>
+                          <a:latin typeface="Helvetica Neue"/>
+                          <a:ea typeface="Helvetica Neue"/>
+                          <a:cs typeface="Helvetica Neue"/>
+                        </a:rPr>
+                        <a:t>Use minimum necessary data and role-based access</a:t>
+                      </a:r>
+                    </a:p>
+                  </a:txBody>
+                  <a:tcPr marL="91440" marR="91440" marT="45720" marB="45720" anchor="ctr">
+                    <a:solidFill>
+                      <a:srgbClr val="F8FBFC"/>
+                    </a:solidFill>
+                  </a:tcPr>
+                </a:tc>
+              </a:tr>
+              <a:tr h="285750">
+                <a:tc>
+                  <a:txBody>
+                    <a:bodyPr lIns="66675" tIns="28575" rIns="57150" bIns="28575">
+                      <a:noAutofit/>
+                    </a:bodyPr>
+                    <a:lstStyle/>
+                    <a:p>
+                      <a:pPr algn="l"/>
+                      <a:r>
+                        <a:rPr sz="540" b="1">
+                          <a:solidFill>
+                            <a:srgbClr val="253B44"/>
+                          </a:solidFill>
+                          <a:latin typeface="Helvetica Neue"/>
+                          <a:ea typeface="Helvetica Neue"/>
+                          <a:cs typeface="Helvetica Neue"/>
+                        </a:rPr>
+                        <a:t>Data governance</a:t>
+                      </a:r>
+                    </a:p>
+                  </a:txBody>
+                  <a:tcPr marL="91440" marR="91440" marT="45720" marB="45720" anchor="ctr">
+                    <a:solidFill>
+                      <a:srgbClr val="EEF6F7"/>
+                    </a:solidFill>
+                  </a:tcPr>
+                </a:tc>
+                <a:tc>
+                  <a:txBody>
+                    <a:bodyPr lIns="66675" tIns="28575" rIns="57150" bIns="28575">
+                      <a:noAutofit/>
+                    </a:bodyPr>
+                    <a:lstStyle/>
+                    <a:p>
+                      <a:pPr algn="l"/>
+                      <a:r>
+                        <a:rPr sz="540" b="0">
+                          <a:solidFill>
+                            <a:srgbClr val="253B44"/>
+                          </a:solidFill>
+                          <a:latin typeface="Helvetica Neue"/>
+                          <a:ea typeface="Helvetica Neue"/>
+                          <a:cs typeface="Helvetica Neue"/>
+                        </a:rPr>
+                        <a:t>Missing follow-up and financial anomalies can distort decisions</a:t>
+                      </a:r>
+                    </a:p>
+                  </a:txBody>
+                  <a:tcPr marL="91440" marR="91440" marT="45720" marB="45720" anchor="ctr">
+                    <a:solidFill>
+                      <a:srgbClr val="EEF6F7"/>
+                    </a:solidFill>
+                  </a:tcPr>
+                </a:tc>
+                <a:tc>
+                  <a:txBody>
+                    <a:bodyPr lIns="66675" tIns="28575" rIns="57150" bIns="28575">
+                      <a:noAutofit/>
+                    </a:bodyPr>
+                    <a:lstStyle/>
+                    <a:p>
+                      <a:pPr algn="l"/>
+                      <a:r>
+                        <a:rPr sz="540" b="0">
+                          <a:solidFill>
+                            <a:srgbClr val="253B44"/>
+                          </a:solidFill>
+                          <a:latin typeface="Helvetica Neue"/>
+                          <a:ea typeface="Helvetica Neue"/>
+                          <a:cs typeface="Helvetica Neue"/>
+                        </a:rPr>
+                        <a:t>Define owners, validation rules, and change logs</a:t>
+                      </a:r>
+                    </a:p>
+                  </a:txBody>
+                  <a:tcPr marL="91440" marR="91440" marT="45720" marB="45720" anchor="ctr">
+                    <a:solidFill>
+                      <a:srgbClr val="EEF6F7"/>
+                    </a:solidFill>
+                  </a:tcPr>
+                </a:tc>
+              </a:tr>
+              <a:tr h="285750">
+                <a:tc>
+                  <a:txBody>
+                    <a:bodyPr lIns="66675" tIns="28575" rIns="57150" bIns="28575">
+                      <a:noAutofit/>
+                    </a:bodyPr>
+                    <a:lstStyle/>
+                    <a:p>
+                      <a:pPr algn="l"/>
+                      <a:r>
+                        <a:rPr sz="540" b="1">
+                          <a:solidFill>
+                            <a:srgbClr val="253B44"/>
+                          </a:solidFill>
+                          <a:latin typeface="Helvetica Neue"/>
+                          <a:ea typeface="Helvetica Neue"/>
+                          <a:cs typeface="Helvetica Neue"/>
+                        </a:rPr>
+                        <a:t>Transparency</a:t>
+                      </a:r>
+                    </a:p>
+                  </a:txBody>
+                  <a:tcPr marL="91440" marR="91440" marT="45720" marB="45720" anchor="ctr">
+                    <a:solidFill>
+                      <a:srgbClr val="F8FBFC"/>
+                    </a:solidFill>
+                  </a:tcPr>
+                </a:tc>
+                <a:tc>
+                  <a:txBody>
+                    <a:bodyPr lIns="66675" tIns="28575" rIns="57150" bIns="28575">
+                      <a:noAutofit/>
+                    </a:bodyPr>
+                    <a:lstStyle/>
+                    <a:p>
+                      <a:pPr algn="l"/>
+                      <a:r>
+                        <a:rPr sz="540" b="0">
+                          <a:solidFill>
+                            <a:srgbClr val="253B44"/>
+                          </a:solidFill>
+                          <a:latin typeface="Helvetica Neue"/>
+                          <a:ea typeface="Helvetica Neue"/>
+                          <a:cs typeface="Helvetica Neue"/>
+                        </a:rPr>
+                        <a:t>Clinicians need to understand why a patient is high risk</a:t>
+                      </a:r>
+                    </a:p>
+                  </a:txBody>
+                  <a:tcPr marL="91440" marR="91440" marT="45720" marB="45720" anchor="ctr">
+                    <a:solidFill>
+                      <a:srgbClr val="F8FBFC"/>
+                    </a:solidFill>
+                  </a:tcPr>
+                </a:tc>
+                <a:tc>
+                  <a:txBody>
+                    <a:bodyPr lIns="66675" tIns="28575" rIns="57150" bIns="28575">
+                      <a:noAutofit/>
+                    </a:bodyPr>
+                    <a:lstStyle/>
+                    <a:p>
+                      <a:pPr algn="l"/>
+                      <a:r>
+                        <a:rPr sz="540" b="0">
+                          <a:solidFill>
+                            <a:srgbClr val="253B44"/>
+                          </a:solidFill>
+                          <a:latin typeface="Helvetica Neue"/>
+                          <a:ea typeface="Helvetica Neue"/>
+                          <a:cs typeface="Helvetica Neue"/>
+                        </a:rPr>
+                        <a:t>Use explainable model outputs and plain-language score guidance</a:t>
+                      </a:r>
+                    </a:p>
+                  </a:txBody>
+                  <a:tcPr marL="91440" marR="91440" marT="45720" marB="45720" anchor="ctr">
+                    <a:solidFill>
+                      <a:srgbClr val="F8FBFC"/>
+                    </a:solidFill>
+                  </a:tcPr>
+                </a:tc>
+              </a:tr>
+              <a:tr h="285750">
+                <a:tc>
+                  <a:txBody>
+                    <a:bodyPr lIns="66675" tIns="28575" rIns="57150" bIns="28575">
+                      <a:noAutofit/>
+                    </a:bodyPr>
+                    <a:lstStyle/>
+                    <a:p>
+                      <a:pPr algn="l"/>
+                      <a:r>
+                        <a:rPr sz="540" b="1">
+                          <a:solidFill>
+                            <a:srgbClr val="253B44"/>
+                          </a:solidFill>
+                          <a:latin typeface="Helvetica Neue"/>
+                          <a:ea typeface="Helvetica Neue"/>
+                          <a:cs typeface="Helvetica Neue"/>
+                        </a:rPr>
+                        <a:t>Regulatory compliance</a:t>
+                      </a:r>
+                    </a:p>
+                  </a:txBody>
+                  <a:tcPr marL="91440" marR="91440" marT="45720" marB="45720" anchor="ctr">
+                    <a:solidFill>
+                      <a:srgbClr val="EEF6F7"/>
+                    </a:solidFill>
+                  </a:tcPr>
+                </a:tc>
+                <a:tc>
+                  <a:txBody>
+                    <a:bodyPr lIns="66675" tIns="28575" rIns="57150" bIns="28575">
+                      <a:noAutofit/>
+                    </a:bodyPr>
+                    <a:lstStyle/>
+                    <a:p>
+                      <a:pPr algn="l"/>
+                      <a:r>
+                        <a:rPr sz="540" b="0">
+                          <a:solidFill>
+                            <a:srgbClr val="253B44"/>
+                          </a:solidFill>
+                          <a:latin typeface="Helvetica Neue"/>
+                          <a:ea typeface="Helvetica Neue"/>
+                          <a:cs typeface="Helvetica Neue"/>
+                        </a:rPr>
+                        <a:t>Analytics must align with HIPAA and internal policy</a:t>
+                      </a:r>
+                    </a:p>
+                  </a:txBody>
+                  <a:tcPr marL="91440" marR="91440" marT="45720" marB="45720" anchor="ctr">
+                    <a:solidFill>
+                      <a:srgbClr val="EEF6F7"/>
+                    </a:solidFill>
+                  </a:tcPr>
+                </a:tc>
+                <a:tc>
+                  <a:txBody>
+                    <a:bodyPr lIns="66675" tIns="28575" rIns="57150" bIns="28575">
+                      <a:noAutofit/>
+                    </a:bodyPr>
+                    <a:lstStyle/>
+                    <a:p>
+                      <a:pPr algn="l"/>
+                      <a:r>
+                        <a:rPr sz="540" b="0">
+                          <a:solidFill>
+                            <a:srgbClr val="253B44"/>
+                          </a:solidFill>
+                          <a:latin typeface="Helvetica Neue"/>
+                          <a:ea typeface="Helvetica Neue"/>
+                          <a:cs typeface="Helvetica Neue"/>
+                        </a:rPr>
+                        <a:t>Review data use, access, retention, and reporting with compliance leaders</a:t>
+                      </a:r>
+                    </a:p>
+                  </a:txBody>
+                  <a:tcPr marL="91440" marR="91440" marT="45720" marB="45720" anchor="ctr">
+                    <a:solidFill>
+                      <a:srgbClr val="EEF6F7"/>
+                    </a:solidFill>
+                  </a:tcPr>
+                </a:tc>
+              </a:tr>
+              <a:tr h="285750">
+                <a:tc>
+                  <a:txBody>
+                    <a:bodyPr lIns="66675" tIns="28575" rIns="57150" bIns="28575">
+                      <a:noAutofit/>
+                    </a:bodyPr>
+                    <a:lstStyle/>
+                    <a:p>
+                      <a:pPr algn="l"/>
+                      <a:r>
+                        <a:rPr sz="540" b="1">
+                          <a:solidFill>
+                            <a:srgbClr val="253B44"/>
+                          </a:solidFill>
+                          <a:latin typeface="Helvetica Neue"/>
+                          <a:ea typeface="Helvetica Neue"/>
+                          <a:cs typeface="Helvetica Neue"/>
+                        </a:rPr>
+                        <a:t>Responsible AI</a:t>
+                      </a:r>
+                    </a:p>
+                  </a:txBody>
+                  <a:tcPr marL="91440" marR="91440" marT="45720" marB="45720" anchor="ctr">
+                    <a:solidFill>
+                      <a:srgbClr val="F8FBFC"/>
+                    </a:solidFill>
+                  </a:tcPr>
+                </a:tc>
+                <a:tc>
+                  <a:txBody>
+                    <a:bodyPr lIns="66675" tIns="28575" rIns="57150" bIns="28575">
+                      <a:noAutofit/>
+                    </a:bodyPr>
+                    <a:lstStyle/>
+                    <a:p>
+                      <a:pPr algn="l"/>
+                      <a:r>
+                        <a:rPr sz="540" b="0">
+                          <a:solidFill>
+                            <a:srgbClr val="253B44"/>
+                          </a:solidFill>
+                          <a:latin typeface="Helvetica Neue"/>
+                          <a:ea typeface="Helvetica Neue"/>
+                          <a:cs typeface="Helvetica Neue"/>
+                        </a:rPr>
+                        <a:t>Predictions should support judgment, not replace it</a:t>
+                      </a:r>
+                    </a:p>
+                  </a:txBody>
+                  <a:tcPr marL="91440" marR="91440" marT="45720" marB="45720" anchor="ctr">
+                    <a:solidFill>
+                      <a:srgbClr val="F8FBFC"/>
+                    </a:solidFill>
+                  </a:tcPr>
+                </a:tc>
+                <a:tc>
+                  <a:txBody>
+                    <a:bodyPr lIns="66675" tIns="28575" rIns="57150" bIns="28575">
+                      <a:noAutofit/>
+                    </a:bodyPr>
+                    <a:lstStyle/>
+                    <a:p>
+                      <a:pPr algn="l"/>
+                      <a:r>
+                        <a:rPr sz="540" b="0">
+                          <a:solidFill>
+                            <a:srgbClr val="253B44"/>
+                          </a:solidFill>
+                          <a:latin typeface="Helvetica Neue"/>
+                          <a:ea typeface="Helvetica Neue"/>
+                          <a:cs typeface="Helvetica Neue"/>
+                        </a:rPr>
+                        <a:t>Keep human review before care decisions and budget commitments</a:t>
+                      </a:r>
+                    </a:p>
+                  </a:txBody>
+                  <a:tcPr marL="91440" marR="91440" marT="45720" marB="45720" anchor="ctr">
+                    <a:solidFill>
+                      <a:srgbClr val="F8FBFC"/>
+                    </a:solidFill>
+                  </a:tcPr>
+                </a:tc>
+              </a:tr>
+            </a:tbl>
+          </a:graphicData>
+        </a:graphic>
+      </p:graphicFrame>
+      <p:sp>
+        <p:nvSpPr>
+          <p:cNvPr id="10" name="">
+            <a:extLst xmlns:a="http://schemas.openxmlformats.org/drawingml/2006/main">
+              <a:ext uri="{FF2B5EF4-FFF2-40B4-BE49-F238E27FC236}">
+                <a16:creationId xmlns:a16="http://schemas.microsoft.com/office/drawing/2014/main" id="{C11A673D-D365-42BD-B8D8-5190700DC70F}"/>
+              </a:ext>
+            </a:extLst>
+          </p:cNvPr>
+          <p:cNvSpPr>
+            <a:spLocks xmlns:a="http://schemas.openxmlformats.org/drawingml/2006/main" noGrp="1"/>
+          </p:cNvSpPr>
+          <p:nvPr/>
+        </p:nvSpPr>
+        <p:spPr>
+          <a:xfrm xmlns:a="http://schemas.openxmlformats.org/drawingml/2006/main">
+            <a:off x="7277100" y="3009900"/>
+            <a:ext cx="2857500" cy="228600"/>
+          </a:xfrm>
+          <a:prstGeom xmlns:a="http://schemas.openxmlformats.org/drawingml/2006/main" prst="rect">
+            <a:avLst/>
+          </a:prstGeom>
+          <a:noFill xmlns:a="http://schemas.openxmlformats.org/drawingml/2006/main"/>
+          <a:ln xmlns:a="http://schemas.openxmlformats.org/drawingml/2006/main" w="0">
+            <a:noFill/>
+            <a:prstDash val="solid"/>
+          </a:ln>
+        </p:spPr>
+        <p:txBody>
+          <a:bodyPr xmlns:a="http://schemas.openxmlformats.org/drawingml/2006/main" lIns="0" tIns="0" rIns="0" bIns="0">
+            <a:noAutofit/>
+          </a:bodyPr>
+          <a:lstStyle xmlns:a="http://schemas.openxmlformats.org/drawingml/2006/main"/>
+          <a:p xmlns:a="http://schemas.openxmlformats.org/drawingml/2006/main">
+            <a:pPr>
+              <a:defRPr sz="1500" b="1">
+                <a:solidFill>
+                  <a:srgbClr val="102A34"/>
+                </a:solidFill>
+                <a:latin typeface="Helvetica Neue"/>
+                <a:ea typeface="Helvetica Neue"/>
+                <a:cs typeface="Helvetica Neue"/>
+              </a:defRPr>
+            </a:pPr>
+            <a:r>
+              <a:rPr sz="1500" b="1">
+                <a:solidFill>
+                  <a:srgbClr val="102A34"/>
+                </a:solidFill>
+                <a:latin typeface="Helvetica Neue"/>
+                <a:ea typeface="Helvetica Neue"/>
+                <a:cs typeface="Helvetica Neue"/>
+              </a:rPr>
+              <a:t>Operating principles</a:t>
+            </a:r>
+          </a:p>
+        </p:txBody>
+      </p:sp>
+      <p:graphicFrame>
+        <p:nvGraphicFramePr>
+          <p:cNvPr id="30" name=""/>
+          <p:cNvGraphicFramePr/>
+          <p:nvPr/>
+        </p:nvGraphicFramePr>
+        <p:xfrm>
+          <a:off xmlns:a="http://schemas.openxmlformats.org/drawingml/2006/main" x="7277100" y="3362325"/>
+          <a:ext xmlns:a="http://schemas.openxmlformats.org/drawingml/2006/main" cx="3524250" cy="1381125"/>
+        </p:xfrm>
+        <a:graphic xmlns:a="http://schemas.openxmlformats.org/drawingml/2006/main">
+          <a:graphicData uri="http://schemas.openxmlformats.org/drawingml/2006/table">
+            <a:tbl>
+              <a:tblPr/>
+              <a:tblGrid>
+                <a:gridCol w="1219200"/>
+                <a:gridCol w="2305050"/>
+              </a:tblGrid>
+              <a:tr h="276225">
+                <a:tc>
+                  <a:txBody>
+                    <a:bodyPr lIns="66675" tIns="28575" rIns="57150" bIns="28575">
+                      <a:noAutofit/>
+                    </a:bodyPr>
+                    <a:lstStyle/>
+                    <a:p>
+                      <a:pPr algn="l"/>
+                      <a:r>
+                        <a:rPr sz="660" b="1">
+                          <a:solidFill>
+                            <a:srgbClr val="FFFFFF"/>
+                          </a:solidFill>
+                          <a:latin typeface="Helvetica Neue"/>
+                          <a:ea typeface="Helvetica Neue"/>
+                          <a:cs typeface="Helvetica Neue"/>
+                        </a:rPr>
+                        <a:t>Principle</a:t>
+                      </a:r>
+                    </a:p>
+                  </a:txBody>
+                  <a:tcPr marL="91440" marR="91440" marT="45720" marB="45720" anchor="ctr">
+                    <a:solidFill>
+                      <a:srgbClr val="0F4C5C"/>
+                    </a:solidFill>
+                  </a:tcPr>
+                </a:tc>
+                <a:tc>
+                  <a:txBody>
+                    <a:bodyPr lIns="66675" tIns="28575" rIns="57150" bIns="28575">
+                      <a:noAutofit/>
+                    </a:bodyPr>
+                    <a:lstStyle/>
+                    <a:p>
+                      <a:pPr algn="l"/>
+                      <a:r>
+                        <a:rPr sz="660" b="1">
+                          <a:solidFill>
+                            <a:srgbClr val="FFFFFF"/>
+                          </a:solidFill>
+                          <a:latin typeface="Helvetica Neue"/>
+                          <a:ea typeface="Helvetica Neue"/>
+                          <a:cs typeface="Helvetica Neue"/>
+                        </a:rPr>
+                        <a:t>How to apply it</a:t>
+                      </a:r>
+                    </a:p>
+                  </a:txBody>
+                  <a:tcPr marL="91440" marR="91440" marT="45720" marB="45720" anchor="ctr">
+                    <a:solidFill>
+                      <a:srgbClr val="0F4C5C"/>
+                    </a:solidFill>
+                  </a:tcPr>
+                </a:tc>
+              </a:tr>
+              <a:tr h="276225">
+                <a:tc>
+                  <a:txBody>
+                    <a:bodyPr lIns="66675" tIns="28575" rIns="57150" bIns="28575">
+                      <a:noAutofit/>
+                    </a:bodyPr>
+                    <a:lstStyle/>
+                    <a:p>
+                      <a:pPr algn="l"/>
+                      <a:r>
+                        <a:rPr sz="615" b="1">
+                          <a:solidFill>
+                            <a:srgbClr val="253B44"/>
+                          </a:solidFill>
+                          <a:latin typeface="Helvetica Neue"/>
+                          <a:ea typeface="Helvetica Neue"/>
+                          <a:cs typeface="Helvetica Neue"/>
+                        </a:rPr>
+                        <a:t>Fair</a:t>
+                      </a:r>
+                    </a:p>
+                  </a:txBody>
+                  <a:tcPr marL="91440" marR="91440" marT="45720" marB="45720" anchor="ctr">
+                    <a:solidFill>
+                      <a:srgbClr val="EEF6F7"/>
+                    </a:solidFill>
+                  </a:tcPr>
+                </a:tc>
+                <a:tc>
+                  <a:txBody>
+                    <a:bodyPr lIns="66675" tIns="28575" rIns="57150" bIns="28575">
+                      <a:noAutofit/>
+                    </a:bodyPr>
+                    <a:lstStyle/>
+                    <a:p>
+                      <a:pPr algn="l"/>
+                      <a:r>
+                        <a:rPr sz="615" b="0">
+                          <a:solidFill>
+                            <a:srgbClr val="253B44"/>
+                          </a:solidFill>
+                          <a:latin typeface="Helvetica Neue"/>
+                          <a:ea typeface="Helvetica Neue"/>
+                          <a:cs typeface="Helvetica Neue"/>
+                        </a:rPr>
+                        <a:t>Test whether model errors differ across patient groups</a:t>
+                      </a:r>
+                    </a:p>
+                  </a:txBody>
+                  <a:tcPr marL="91440" marR="91440" marT="45720" marB="45720" anchor="ctr">
+                    <a:solidFill>
+                      <a:srgbClr val="EEF6F7"/>
+                    </a:solidFill>
+                  </a:tcPr>
+                </a:tc>
+              </a:tr>
+              <a:tr h="276225">
+                <a:tc>
+                  <a:txBody>
+                    <a:bodyPr lIns="66675" tIns="28575" rIns="57150" bIns="28575">
+                      <a:noAutofit/>
+                    </a:bodyPr>
+                    <a:lstStyle/>
+                    <a:p>
+                      <a:pPr algn="l"/>
+                      <a:r>
+                        <a:rPr sz="615" b="1">
+                          <a:solidFill>
+                            <a:srgbClr val="253B44"/>
+                          </a:solidFill>
+                          <a:latin typeface="Helvetica Neue"/>
+                          <a:ea typeface="Helvetica Neue"/>
+                          <a:cs typeface="Helvetica Neue"/>
+                        </a:rPr>
+                        <a:t>Private</a:t>
+                      </a:r>
+                    </a:p>
+                  </a:txBody>
+                  <a:tcPr marL="91440" marR="91440" marT="45720" marB="45720" anchor="ctr">
+                    <a:solidFill>
+                      <a:srgbClr val="F8FBFC"/>
+                    </a:solidFill>
+                  </a:tcPr>
+                </a:tc>
+                <a:tc>
+                  <a:txBody>
+                    <a:bodyPr lIns="66675" tIns="28575" rIns="57150" bIns="28575">
+                      <a:noAutofit/>
+                    </a:bodyPr>
+                    <a:lstStyle/>
+                    <a:p>
+                      <a:pPr algn="l"/>
+                      <a:r>
+                        <a:rPr sz="615" b="0">
+                          <a:solidFill>
+                            <a:srgbClr val="253B44"/>
+                          </a:solidFill>
+                          <a:latin typeface="Helvetica Neue"/>
+                          <a:ea typeface="Helvetica Neue"/>
+                          <a:cs typeface="Helvetica Neue"/>
+                        </a:rPr>
+                        <a:t>Limit data access to teams with a clear care or reporting need</a:t>
+                      </a:r>
+                    </a:p>
+                  </a:txBody>
+                  <a:tcPr marL="91440" marR="91440" marT="45720" marB="45720" anchor="ctr">
+                    <a:solidFill>
+                      <a:srgbClr val="F8FBFC"/>
+                    </a:solidFill>
+                  </a:tcPr>
+                </a:tc>
+              </a:tr>
+              <a:tr h="276225">
+                <a:tc>
+                  <a:txBody>
+                    <a:bodyPr lIns="66675" tIns="28575" rIns="57150" bIns="28575">
+                      <a:noAutofit/>
+                    </a:bodyPr>
+                    <a:lstStyle/>
+                    <a:p>
+                      <a:pPr algn="l"/>
+                      <a:r>
+                        <a:rPr sz="615" b="1">
+                          <a:solidFill>
+                            <a:srgbClr val="253B44"/>
+                          </a:solidFill>
+                          <a:latin typeface="Helvetica Neue"/>
+                          <a:ea typeface="Helvetica Neue"/>
+                          <a:cs typeface="Helvetica Neue"/>
+                        </a:rPr>
+                        <a:t>Explainable</a:t>
+                      </a:r>
+                    </a:p>
+                  </a:txBody>
+                  <a:tcPr marL="91440" marR="91440" marT="45720" marB="45720" anchor="ctr">
+                    <a:solidFill>
+                      <a:srgbClr val="EEF6F7"/>
+                    </a:solidFill>
+                  </a:tcPr>
+                </a:tc>
+                <a:tc>
+                  <a:txBody>
+                    <a:bodyPr lIns="66675" tIns="28575" rIns="57150" bIns="28575">
+                      <a:noAutofit/>
+                    </a:bodyPr>
+                    <a:lstStyle/>
+                    <a:p>
+                      <a:pPr algn="l"/>
+                      <a:r>
+                        <a:rPr sz="615" b="0">
+                          <a:solidFill>
+                            <a:srgbClr val="253B44"/>
+                          </a:solidFill>
+                          <a:latin typeface="Helvetica Neue"/>
+                          <a:ea typeface="Helvetica Neue"/>
+                          <a:cs typeface="Helvetica Neue"/>
+                        </a:rPr>
+                        <a:t>Show the key factors behind each high-risk flag</a:t>
+                      </a:r>
+                    </a:p>
+                  </a:txBody>
+                  <a:tcPr marL="91440" marR="91440" marT="45720" marB="45720" anchor="ctr">
+                    <a:solidFill>
+                      <a:srgbClr val="EEF6F7"/>
+                    </a:solidFill>
+                  </a:tcPr>
+                </a:tc>
+              </a:tr>
+              <a:tr h="276225">
+                <a:tc>
+                  <a:txBody>
+                    <a:bodyPr lIns="66675" tIns="28575" rIns="57150" bIns="28575">
+                      <a:noAutofit/>
+                    </a:bodyPr>
+                    <a:lstStyle/>
+                    <a:p>
+                      <a:pPr algn="l"/>
+                      <a:r>
+                        <a:rPr sz="615" b="1">
+                          <a:solidFill>
+                            <a:srgbClr val="253B44"/>
+                          </a:solidFill>
+                          <a:latin typeface="Helvetica Neue"/>
+                          <a:ea typeface="Helvetica Neue"/>
+                          <a:cs typeface="Helvetica Neue"/>
+                        </a:rPr>
+                        <a:t>Accountable</a:t>
+                      </a:r>
+                    </a:p>
+                  </a:txBody>
+                  <a:tcPr marL="91440" marR="91440" marT="45720" marB="45720" anchor="ctr">
+                    <a:solidFill>
+                      <a:srgbClr val="F8FBFC"/>
+                    </a:solidFill>
+                  </a:tcPr>
+                </a:tc>
+                <a:tc>
+                  <a:txBody>
+                    <a:bodyPr lIns="66675" tIns="28575" rIns="57150" bIns="28575">
+                      <a:noAutofit/>
+                    </a:bodyPr>
+                    <a:lstStyle/>
+                    <a:p>
+                      <a:pPr algn="l"/>
+                      <a:r>
+                        <a:rPr sz="615" b="0">
+                          <a:solidFill>
+                            <a:srgbClr val="253B44"/>
+                          </a:solidFill>
+                          <a:latin typeface="Helvetica Neue"/>
+                          <a:ea typeface="Helvetica Neue"/>
+                          <a:cs typeface="Helvetica Neue"/>
+                        </a:rPr>
+                        <a:t>Assign owners for model refresh, dashboard definitions, and issue escalation</a:t>
+                      </a:r>
+                    </a:p>
+                  </a:txBody>
+                  <a:tcPr marL="91440" marR="91440" marT="45720" marB="45720" anchor="ctr">
+                    <a:solidFill>
+                      <a:srgbClr val="F8FBFC"/>
+                    </a:solidFill>
+                  </a:tcPr>
+                </a:tc>
+              </a:tr>
+            </a:tbl>
+          </a:graphicData>
+        </a:graphic>
+      </p:graphicFrame>
+      <p:sp>
+        <p:nvSpPr>
+          <p:cNvPr id="12" name="">
+            <a:extLst xmlns:a="http://schemas.openxmlformats.org/drawingml/2006/main">
+              <a:ext uri="{FF2B5EF4-FFF2-40B4-BE49-F238E27FC236}">
+                <a16:creationId xmlns:a16="http://schemas.microsoft.com/office/drawing/2014/main" id="{A84A2948-1019-4550-A7EE-76BC385DC662}"/>
+              </a:ext>
+            </a:extLst>
+          </p:cNvPr>
+          <p:cNvSpPr>
+            <a:spLocks xmlns:a="http://schemas.openxmlformats.org/drawingml/2006/main" noGrp="1"/>
+          </p:cNvSpPr>
+          <p:nvPr/>
+        </p:nvSpPr>
+        <p:spPr>
+          <a:xfrm xmlns:a="http://schemas.openxmlformats.org/drawingml/2006/main">
+            <a:off x="7277100" y="4991100"/>
+            <a:ext cx="2476500" cy="228600"/>
+          </a:xfrm>
+          <a:prstGeom xmlns:a="http://schemas.openxmlformats.org/drawingml/2006/main" prst="rect">
+            <a:avLst/>
+          </a:prstGeom>
+          <a:noFill xmlns:a="http://schemas.openxmlformats.org/drawingml/2006/main"/>
+          <a:ln xmlns:a="http://schemas.openxmlformats.org/drawingml/2006/main" w="0">
+            <a:noFill/>
+            <a:prstDash val="solid"/>
+          </a:ln>
+        </p:spPr>
+        <p:txBody>
+          <a:bodyPr xmlns:a="http://schemas.openxmlformats.org/drawingml/2006/main" lIns="0" tIns="0" rIns="0" bIns="0">
+            <a:noAutofit/>
+          </a:bodyPr>
+          <a:lstStyle xmlns:a="http://schemas.openxmlformats.org/drawingml/2006/main"/>
+          <a:p xmlns:a="http://schemas.openxmlformats.org/drawingml/2006/main">
+            <a:pPr>
+              <a:defRPr sz="1500" b="1">
+                <a:solidFill>
+                  <a:srgbClr val="102A34"/>
+                </a:solidFill>
+                <a:latin typeface="Helvetica Neue"/>
+                <a:ea typeface="Helvetica Neue"/>
+                <a:cs typeface="Helvetica Neue"/>
+              </a:defRPr>
+            </a:pPr>
+            <a:r>
+              <a:rPr sz="1500" b="1">
+                <a:solidFill>
+                  <a:srgbClr val="102A34"/>
+                </a:solidFill>
+                <a:latin typeface="Helvetica Neue"/>
+                <a:ea typeface="Helvetica Neue"/>
+                <a:cs typeface="Helvetica Neue"/>
+              </a:rPr>
+              <a:t>Governance workflow</a:t>
+            </a:r>
+          </a:p>
+        </p:txBody>
+      </p:sp>
+      <p:sp>
+        <p:nvSpPr>
+          <p:cNvPr id="13" name="">
+            <a:extLst xmlns:a="http://schemas.openxmlformats.org/drawingml/2006/main">
+              <a:ext uri="{FF2B5EF4-FFF2-40B4-BE49-F238E27FC236}">
+                <a16:creationId xmlns:a16="http://schemas.microsoft.com/office/drawing/2014/main" id="{5CE00989-C321-4F5E-BDEF-4EDE6CB88D7E}"/>
+              </a:ext>
+            </a:extLst>
+          </p:cNvPr>
+          <p:cNvSpPr>
+            <a:spLocks xmlns:a="http://schemas.openxmlformats.org/drawingml/2006/main" noGrp="1"/>
+          </p:cNvSpPr>
+          <p:nvPr/>
+        </p:nvSpPr>
+        <p:spPr>
+          <a:xfrm xmlns:a="http://schemas.openxmlformats.org/drawingml/2006/main">
+            <a:off x="7353300" y="5314950"/>
+            <a:ext cx="3333750" cy="819150"/>
+          </a:xfrm>
+          <a:prstGeom xmlns:a="http://schemas.openxmlformats.org/drawingml/2006/main" prst="rect">
+            <a:avLst/>
+          </a:prstGeom>
+          <a:noFill xmlns:a="http://schemas.openxmlformats.org/drawingml/2006/main"/>
+          <a:ln xmlns:a="http://schemas.openxmlformats.org/drawingml/2006/main" w="0">
+            <a:noFill/>
+            <a:prstDash val="solid"/>
+          </a:ln>
+        </p:spPr>
+        <p:txBody>
+          <a:bodyPr xmlns:a="http://schemas.openxmlformats.org/drawingml/2006/main" lIns="0" tIns="0" rIns="0" bIns="0">
+            <a:noAutofit/>
+          </a:bodyPr>
+          <a:lstStyle xmlns:a="http://schemas.openxmlformats.org/drawingml/2006/main"/>
+          <a:p xmlns:a="http://schemas.openxmlformats.org/drawingml/2006/main">
+            <a:pPr marL="139700" indent="-63500">
+              <a:lnSpc>
+                <a:spcPct val="103000"/>
+              </a:lnSpc>
+              <a:spcAft>
+                <a:spcPts val="300"/>
+              </a:spcAft>
+              <a:buNone/>
+              <a:defRPr sz="765">
+                <a:solidFill>
+                  <a:srgbClr val="253B44"/>
+                </a:solidFill>
+                <a:latin typeface="Helvetica Neue"/>
+                <a:ea typeface="Helvetica Neue"/>
+                <a:cs typeface="Helvetica Neue"/>
+              </a:defRPr>
+            </a:pPr>
+            <a:r>
+              <a:rPr sz="765">
+                <a:solidFill>
+                  <a:srgbClr val="253B44"/>
+                </a:solidFill>
+                <a:latin typeface="Helvetica Neue"/>
+                <a:ea typeface="Helvetica Neue"/>
+                <a:cs typeface="Helvetica Neue"/>
+              </a:rPr>
+              <a:t>Validate data quality before model refresh or ROI reporting</a:t>
+            </a:r>
+          </a:p>
+          <a:p xmlns:a="http://schemas.openxmlformats.org/drawingml/2006/main">
+            <a:pPr marL="139700" indent="-63500">
+              <a:lnSpc>
+                <a:spcPct val="103000"/>
+              </a:lnSpc>
+              <a:spcAft>
+                <a:spcPts val="300"/>
+              </a:spcAft>
+              <a:buNone/>
+              <a:defRPr sz="765">
+                <a:solidFill>
+                  <a:srgbClr val="253B44"/>
+                </a:solidFill>
+                <a:latin typeface="Helvetica Neue"/>
+                <a:ea typeface="Helvetica Neue"/>
+                <a:cs typeface="Helvetica Neue"/>
+              </a:defRPr>
+            </a:pPr>
+            <a:r>
+              <a:rPr sz="765">
+                <a:solidFill>
+                  <a:srgbClr val="253B44"/>
+                </a:solidFill>
+                <a:latin typeface="Helvetica Neue"/>
+                <a:ea typeface="Helvetica Neue"/>
+                <a:cs typeface="Helvetica Neue"/>
+              </a:rPr>
+              <a:t>Document model purpose, limitations, and approved user groups</a:t>
+            </a:r>
+          </a:p>
+          <a:p xmlns:a="http://schemas.openxmlformats.org/drawingml/2006/main">
+            <a:pPr marL="139700" indent="-63500">
+              <a:lnSpc>
+                <a:spcPct val="103000"/>
+              </a:lnSpc>
+              <a:spcAft>
+                <a:spcPts val="300"/>
+              </a:spcAft>
+              <a:buNone/>
+              <a:defRPr sz="765">
+                <a:solidFill>
+                  <a:srgbClr val="253B44"/>
+                </a:solidFill>
+                <a:latin typeface="Helvetica Neue"/>
+                <a:ea typeface="Helvetica Neue"/>
+                <a:cs typeface="Helvetica Neue"/>
+              </a:defRPr>
+            </a:pPr>
+            <a:r>
+              <a:rPr sz="765">
+                <a:solidFill>
+                  <a:srgbClr val="253B44"/>
+                </a:solidFill>
+                <a:latin typeface="Helvetica Neue"/>
+                <a:ea typeface="Helvetica Neue"/>
+                <a:cs typeface="Helvetica Neue"/>
+              </a:rPr>
+              <a:t>Escalate fairness, privacy, or compliance concerns before scaling</a:t>
+            </a:r>
+          </a:p>
+        </p:txBody>
+      </p:sp>
+      <p:sp>
+        <p:nvSpPr>
+          <p:cNvPr id="14" name="">
+            <a:extLst xmlns:a="http://schemas.openxmlformats.org/drawingml/2006/main">
+              <a:ext uri="{FF2B5EF4-FFF2-40B4-BE49-F238E27FC236}">
+                <a16:creationId xmlns:a16="http://schemas.microsoft.com/office/drawing/2014/main" id="{E091F774-3BA4-4FFD-A0CC-D2EAB5C15BAB}"/>
+              </a:ext>
+            </a:extLst>
+          </p:cNvPr>
+          <p:cNvSpPr>
+            <a:spLocks xmlns:a="http://schemas.openxmlformats.org/drawingml/2006/main" noGrp="1"/>
+          </p:cNvSpPr>
+          <p:nvPr/>
+        </p:nvSpPr>
+        <p:spPr>
+          <a:xfrm xmlns:a="http://schemas.openxmlformats.org/drawingml/2006/main">
+            <a:off x="514350" y="5591175"/>
+            <a:ext cx="6343650" cy="14288"/>
+          </a:xfrm>
+          <a:prstGeom xmlns:a="http://schemas.openxmlformats.org/drawingml/2006/main" prst="rect">
+            <a:avLst/>
+          </a:prstGeom>
+          <a:solidFill xmlns:a="http://schemas.openxmlformats.org/drawingml/2006/main">
+            <a:srgbClr val="D1E1E5"/>
+          </a:solidFill>
+          <a:ln xmlns:a="http://schemas.openxmlformats.org/drawingml/2006/main" w="0">
+            <a:noFill/>
+            <a:prstDash val="solid"/>
+          </a:ln>
+        </p:spPr>
+      </p:sp>
+      <p:sp>
+        <p:nvSpPr>
+          <p:cNvPr id="15" name="">
+            <a:extLst xmlns:a="http://schemas.openxmlformats.org/drawingml/2006/main">
+              <a:ext uri="{FF2B5EF4-FFF2-40B4-BE49-F238E27FC236}">
+                <a16:creationId xmlns:a16="http://schemas.microsoft.com/office/drawing/2014/main" id="{92CC6F0F-7E8B-439E-8A1D-AE3C8718A054}"/>
+              </a:ext>
+            </a:extLst>
+          </p:cNvPr>
+          <p:cNvSpPr>
+            <a:spLocks xmlns:a="http://schemas.openxmlformats.org/drawingml/2006/main" noGrp="1"/>
+          </p:cNvSpPr>
+          <p:nvPr/>
+        </p:nvSpPr>
+        <p:spPr>
+          <a:xfrm xmlns:a="http://schemas.openxmlformats.org/drawingml/2006/main">
+            <a:off x="514350" y="5810250"/>
+            <a:ext cx="1714500" cy="209550"/>
+          </a:xfrm>
+          <a:prstGeom xmlns:a="http://schemas.openxmlformats.org/drawingml/2006/main" prst="rect">
+            <a:avLst/>
+          </a:prstGeom>
+          <a:noFill xmlns:a="http://schemas.openxmlformats.org/drawingml/2006/main"/>
+          <a:ln xmlns:a="http://schemas.openxmlformats.org/drawingml/2006/main" w="0">
+            <a:noFill/>
+            <a:prstDash val="solid"/>
+          </a:ln>
+        </p:spPr>
+        <p:txBody>
+          <a:bodyPr xmlns:a="http://schemas.openxmlformats.org/drawingml/2006/main" lIns="0" tIns="0" rIns="0" bIns="0">
+            <a:noAutofit/>
+          </a:bodyPr>
+          <a:lstStyle xmlns:a="http://schemas.openxmlformats.org/drawingml/2006/main"/>
+          <a:p xmlns:a="http://schemas.openxmlformats.org/drawingml/2006/main">
+            <a:pPr>
+              <a:defRPr sz="1200" b="1">
+                <a:solidFill>
+                  <a:srgbClr val="102A34"/>
+                </a:solidFill>
+                <a:latin typeface="Helvetica Neue"/>
+                <a:ea typeface="Helvetica Neue"/>
+                <a:cs typeface="Helvetica Neue"/>
+              </a:defRPr>
+            </a:pPr>
+            <a:r>
+              <a:rPr sz="1200" b="1">
+                <a:solidFill>
+                  <a:srgbClr val="102A34"/>
+                </a:solidFill>
+                <a:latin typeface="Helvetica Neue"/>
+                <a:ea typeface="Helvetica Neue"/>
+                <a:cs typeface="Helvetica Neue"/>
+              </a:rPr>
+              <a:t>Decision standard</a:t>
+            </a:r>
+          </a:p>
+        </p:txBody>
+      </p:sp>
+      <p:sp>
+        <p:nvSpPr>
+          <p:cNvPr id="16" name="">
+            <a:extLst xmlns:a="http://schemas.openxmlformats.org/drawingml/2006/main">
+              <a:ext uri="{FF2B5EF4-FFF2-40B4-BE49-F238E27FC236}">
+                <a16:creationId xmlns:a16="http://schemas.microsoft.com/office/drawing/2014/main" id="{E29797B1-1C64-408E-9B9F-31A039EC0A79}"/>
+              </a:ext>
+            </a:extLst>
+          </p:cNvPr>
+          <p:cNvSpPr>
+            <a:spLocks xmlns:a="http://schemas.openxmlformats.org/drawingml/2006/main" noGrp="1"/>
+          </p:cNvSpPr>
+          <p:nvPr/>
+        </p:nvSpPr>
+        <p:spPr>
+          <a:xfrm xmlns:a="http://schemas.openxmlformats.org/drawingml/2006/main">
+            <a:off x="2228850" y="5829300"/>
+            <a:ext cx="4629150" cy="419100"/>
+          </a:xfrm>
+          <a:prstGeom xmlns:a="http://schemas.openxmlformats.org/drawingml/2006/main" prst="rect">
+            <a:avLst/>
+          </a:prstGeom>
+          <a:noFill xmlns:a="http://schemas.openxmlformats.org/drawingml/2006/main"/>
+          <a:ln xmlns:a="http://schemas.openxmlformats.org/drawingml/2006/main" w="0">
+            <a:noFill/>
+            <a:prstDash val="solid"/>
+          </a:ln>
+        </p:spPr>
+        <p:txBody>
+          <a:bodyPr xmlns:a="http://schemas.openxmlformats.org/drawingml/2006/main" lIns="0" tIns="0" rIns="0" bIns="0">
+            <a:noAutofit/>
+          </a:bodyPr>
+          <a:lstStyle xmlns:a="http://schemas.openxmlformats.org/drawingml/2006/main"/>
+          <a:p xmlns:a="http://schemas.openxmlformats.org/drawingml/2006/main">
+            <a:pPr>
+              <a:lnSpc>
+                <a:spcPct val="105000"/>
+              </a:lnSpc>
+              <a:buNone/>
+              <a:defRPr sz="810">
+                <a:solidFill>
+                  <a:srgbClr val="253B44"/>
+                </a:solidFill>
+                <a:latin typeface="Helvetica Neue"/>
+                <a:ea typeface="Helvetica Neue"/>
+                <a:cs typeface="Helvetica Neue"/>
+              </a:defRPr>
+            </a:pPr>
+            <a:r>
+              <a:rPr sz="810">
+                <a:solidFill>
+                  <a:srgbClr val="253B44"/>
+                </a:solidFill>
+                <a:latin typeface="Helvetica Neue"/>
+                <a:ea typeface="Helvetica Neue"/>
+                <a:cs typeface="Helvetica Neue"/>
+              </a:rPr>
+              <a:t>Use the model as a decision-support tool only when fairness checks, privacy controls, data governance, transparency, and compliance review are in place.</a:t>
+            </a:r>
+          </a:p>
+        </p:txBody>
+      </p:sp>
+      <p:sp>
+        <p:nvSpPr>
+          <p:cNvPr id="17" name="">
+            <a:extLst xmlns:a="http://schemas.openxmlformats.org/drawingml/2006/main">
+              <a:ext uri="{FF2B5EF4-FFF2-40B4-BE49-F238E27FC236}">
+                <a16:creationId xmlns:a16="http://schemas.microsoft.com/office/drawing/2014/main" id="{1790F17D-0E5A-450B-848D-10926AF28833}"/>
+              </a:ext>
+            </a:extLst>
+          </p:cNvPr>
+          <p:cNvSpPr>
+            <a:spLocks xmlns:a="http://schemas.openxmlformats.org/drawingml/2006/main" noGrp="1"/>
+          </p:cNvSpPr>
+          <p:nvPr/>
+        </p:nvSpPr>
+        <p:spPr>
+          <a:xfrm xmlns:a="http://schemas.openxmlformats.org/drawingml/2006/main">
+            <a:off x="7277100" y="6219825"/>
+            <a:ext cx="1428750" cy="190500"/>
+          </a:xfrm>
+          <a:prstGeom xmlns:a="http://schemas.openxmlformats.org/drawingml/2006/main" prst="rect">
+            <a:avLst/>
+          </a:prstGeom>
+          <a:noFill xmlns:a="http://schemas.openxmlformats.org/drawingml/2006/main"/>
+          <a:ln xmlns:a="http://schemas.openxmlformats.org/drawingml/2006/main" w="0">
+            <a:noFill/>
+            <a:prstDash val="solid"/>
+          </a:ln>
+        </p:spPr>
+        <p:txBody>
+          <a:bodyPr xmlns:a="http://schemas.openxmlformats.org/drawingml/2006/main" lIns="0" tIns="0" rIns="0" bIns="0">
+            <a:noAutofit/>
+          </a:bodyPr>
+          <a:lstStyle xmlns:a="http://schemas.openxmlformats.org/drawingml/2006/main"/>
+          <a:p xmlns:a="http://schemas.openxmlformats.org/drawingml/2006/main">
+            <a:pPr>
+              <a:defRPr sz="1088" b="1">
+                <a:solidFill>
+                  <a:srgbClr val="102A34"/>
+                </a:solidFill>
+                <a:latin typeface="Helvetica Neue"/>
+                <a:ea typeface="Helvetica Neue"/>
+                <a:cs typeface="Helvetica Neue"/>
+              </a:defRPr>
+            </a:pPr>
+            <a:r>
+              <a:rPr sz="1088" b="1">
+                <a:solidFill>
+                  <a:srgbClr val="102A34"/>
+                </a:solidFill>
+                <a:latin typeface="Helvetica Neue"/>
+                <a:ea typeface="Helvetica Neue"/>
+                <a:cs typeface="Helvetica Neue"/>
+              </a:rPr>
+              <a:t>Practical implication</a:t>
+            </a:r>
+          </a:p>
+        </p:txBody>
+      </p:sp>
+      <p:sp>
+        <p:nvSpPr>
+          <p:cNvPr id="18" name="">
+            <a:extLst xmlns:a="http://schemas.openxmlformats.org/drawingml/2006/main">
+              <a:ext uri="{FF2B5EF4-FFF2-40B4-BE49-F238E27FC236}">
+                <a16:creationId xmlns:a16="http://schemas.microsoft.com/office/drawing/2014/main" id="{55B52CE2-2E76-4884-A828-8071E48751E8}"/>
+              </a:ext>
+            </a:extLst>
+          </p:cNvPr>
+          <p:cNvSpPr>
+            <a:spLocks xmlns:a="http://schemas.openxmlformats.org/drawingml/2006/main" noGrp="1"/>
+          </p:cNvSpPr>
+          <p:nvPr/>
+        </p:nvSpPr>
+        <p:spPr>
+          <a:xfrm xmlns:a="http://schemas.openxmlformats.org/drawingml/2006/main">
+            <a:off x="8705850" y="6238875"/>
+            <a:ext cx="2095500" cy="266700"/>
+          </a:xfrm>
+          <a:prstGeom xmlns:a="http://schemas.openxmlformats.org/drawingml/2006/main" prst="rect">
+            <a:avLst/>
+          </a:prstGeom>
+          <a:noFill xmlns:a="http://schemas.openxmlformats.org/drawingml/2006/main"/>
+          <a:ln xmlns:a="http://schemas.openxmlformats.org/drawingml/2006/main" w="0">
+            <a:noFill/>
+            <a:prstDash val="solid"/>
+          </a:ln>
+        </p:spPr>
+        <p:txBody>
+          <a:bodyPr xmlns:a="http://schemas.openxmlformats.org/drawingml/2006/main" lIns="0" tIns="0" rIns="0" bIns="0">
+            <a:noAutofit/>
+          </a:bodyPr>
+          <a:lstStyle xmlns:a="http://schemas.openxmlformats.org/drawingml/2006/main"/>
+          <a:p xmlns:a="http://schemas.openxmlformats.org/drawingml/2006/main">
+            <a:pPr>
+              <a:lnSpc>
+                <a:spcPct val="104000"/>
+              </a:lnSpc>
+              <a:buNone/>
+              <a:defRPr sz="780">
+                <a:solidFill>
+                  <a:srgbClr val="253B44"/>
+                </a:solidFill>
+                <a:latin typeface="Helvetica Neue"/>
+                <a:ea typeface="Helvetica Neue"/>
+                <a:cs typeface="Helvetica Neue"/>
+              </a:defRPr>
+            </a:pPr>
+            <a:r>
+              <a:rPr sz="780">
+                <a:solidFill>
+                  <a:srgbClr val="253B44"/>
+                </a:solidFill>
+                <a:latin typeface="Helvetica Neue"/>
+                <a:ea typeface="Helvetica Neue"/>
+                <a:cs typeface="Helvetica Neue"/>
+              </a:rPr>
+              <a:t>Care teams keep final judgment over patient outreach and discharge decisions.</a:t>
+            </a:r>
+          </a:p>
+        </p:txBody>
+      </p:sp>
+      <p:sp>
+        <p:nvSpPr>
+          <p:cNvPr id="19" name="">
+            <a:extLst xmlns:a="http://schemas.openxmlformats.org/drawingml/2006/main">
+              <a:ext uri="{FF2B5EF4-FFF2-40B4-BE49-F238E27FC236}">
+                <a16:creationId xmlns:a16="http://schemas.microsoft.com/office/drawing/2014/main" id="{3C098D69-96D2-4C8B-BD00-0DE30A3C3113}"/>
+              </a:ext>
+            </a:extLst>
+          </p:cNvPr>
+          <p:cNvSpPr>
+            <a:spLocks xmlns:a="http://schemas.openxmlformats.org/drawingml/2006/main" noGrp="1"/>
+          </p:cNvSpPr>
+          <p:nvPr/>
+        </p:nvSpPr>
+        <p:spPr>
+          <a:xfrm xmlns:a="http://schemas.openxmlformats.org/drawingml/2006/main">
+            <a:off x="514350" y="6572250"/>
+            <a:ext cx="8191500" cy="171450"/>
+          </a:xfrm>
+          <a:prstGeom xmlns:a="http://schemas.openxmlformats.org/drawingml/2006/main" prst="rect">
+            <a:avLst/>
+          </a:prstGeom>
+          <a:noFill xmlns:a="http://schemas.openxmlformats.org/drawingml/2006/main"/>
+          <a:ln xmlns:a="http://schemas.openxmlformats.org/drawingml/2006/main" w="0">
+            <a:noFill/>
+            <a:prstDash val="solid"/>
+          </a:ln>
+        </p:spPr>
+        <p:txBody>
+          <a:bodyPr xmlns:a="http://schemas.openxmlformats.org/drawingml/2006/main" lIns="0" tIns="0" rIns="0" bIns="0">
+            <a:noAutofit/>
+          </a:bodyPr>
+          <a:lstStyle xmlns:a="http://schemas.openxmlformats.org/drawingml/2006/main"/>
+          <a:p xmlns:a="http://schemas.openxmlformats.org/drawingml/2006/main">
+            <a:pPr>
+              <a:defRPr sz="750">
+                <a:solidFill>
+                  <a:srgbClr val="667A82"/>
+                </a:solidFill>
+                <a:latin typeface="Helvetica Neue"/>
+                <a:ea typeface="Helvetica Neue"/>
+                <a:cs typeface="Helvetica Neue"/>
+              </a:defRPr>
+            </a:pPr>
+            <a:r>
+              <a:rPr sz="750">
+                <a:solidFill>
+                  <a:srgbClr val="667A82"/>
+                </a:solidFill>
+                <a:latin typeface="Helvetica Neue"/>
+                <a:ea typeface="Helvetica Neue"/>
+                <a:cs typeface="Helvetica Neue"/>
+              </a:rPr>
+              <a:t>Source: project requirements, NHN data quality findings, risk model workflow, and healthcare compliance context</a:t>
+            </a:r>
+          </a:p>
+        </p:txBody>
+      </p:sp>
+    </p:spTree>
+    <p:extLst>
+      <p:ext uri="{BB962C8B-B14F-4D97-AF65-F5344CB8AC3E}">
+        <p14:creationId xmlns:p14="http://schemas.microsoft.com/office/powerpoint/2010/main" val="1844573749"/>
       </p:ext>
     </p:extLst>
   </p:cSld>

</xml_diff>